<commit_message>
Integrate recovered P2 evidence and final analyses
</commit_message>
<xml_diff>
--- a/presentation/P2_Final_Defense_Tong_Siyuan.pptx
+++ b/presentation/P2_Final_Defense_Tong_Siyuan.pptx
@@ -2,25 +2,25 @@
 <file path=ppt/presentation.xml><?xml version="1.0" encoding="utf-8"?>
 <p:presentation xmlns:p="http://schemas.openxmlformats.org/presentationml/2006/main">
   <p:sldMasterIdLst>
-    <p:sldMasterId xmlns:r="http://schemas.openxmlformats.org/officeDocument/2006/relationships" id="2147483648" r:id="Rc8005ce325204cfd"/>
+    <p:sldMasterId xmlns:r="http://schemas.openxmlformats.org/officeDocument/2006/relationships" id="2147483648" r:id="R363b5eff2f8a4af6"/>
   </p:sldMasterIdLst>
   <p:notesMasterIdLst>
-    <p:notesMasterId xmlns:r="http://schemas.openxmlformats.org/officeDocument/2006/relationships" r:id="R0e41e3f8c1344321"/>
+    <p:notesMasterId xmlns:r="http://schemas.openxmlformats.org/officeDocument/2006/relationships" r:id="R27620808feba4e59"/>
   </p:notesMasterIdLst>
   <p:sldIdLst>
-    <p:sldId xmlns:r="http://schemas.openxmlformats.org/officeDocument/2006/relationships" id="256" r:id="R77dfc9a5489240c8"/>
-    <p:sldId xmlns:r="http://schemas.openxmlformats.org/officeDocument/2006/relationships" id="257" r:id="Rc12df25c0bff49b7"/>
-    <p:sldId xmlns:r="http://schemas.openxmlformats.org/officeDocument/2006/relationships" id="258" r:id="Rdbb07b5e66084e0a"/>
-    <p:sldId xmlns:r="http://schemas.openxmlformats.org/officeDocument/2006/relationships" id="259" r:id="Rf45c0c4d31e942fc"/>
-    <p:sldId xmlns:r="http://schemas.openxmlformats.org/officeDocument/2006/relationships" id="260" r:id="R08a8fd08463d4d94"/>
-    <p:sldId xmlns:r="http://schemas.openxmlformats.org/officeDocument/2006/relationships" id="261" r:id="R832d0b11d1794788"/>
-    <p:sldId xmlns:r="http://schemas.openxmlformats.org/officeDocument/2006/relationships" id="262" r:id="R1b1eaa38688147f2"/>
-    <p:sldId xmlns:r="http://schemas.openxmlformats.org/officeDocument/2006/relationships" id="263" r:id="R2aacc23b3d5f44b5"/>
-    <p:sldId xmlns:r="http://schemas.openxmlformats.org/officeDocument/2006/relationships" id="264" r:id="R12b2fd41aae8438f"/>
-    <p:sldId xmlns:r="http://schemas.openxmlformats.org/officeDocument/2006/relationships" id="265" r:id="R3ccfc0da6c9f442f"/>
-    <p:sldId xmlns:r="http://schemas.openxmlformats.org/officeDocument/2006/relationships" id="266" r:id="Rd57898c315234164"/>
-    <p:sldId xmlns:r="http://schemas.openxmlformats.org/officeDocument/2006/relationships" id="267" r:id="Ra627be6e76274a99"/>
-    <p:sldId xmlns:r="http://schemas.openxmlformats.org/officeDocument/2006/relationships" id="268" r:id="R5105fe4aff9644af"/>
+    <p:sldId xmlns:r="http://schemas.openxmlformats.org/officeDocument/2006/relationships" id="256" r:id="R8b5d243aa0e84b82"/>
+    <p:sldId xmlns:r="http://schemas.openxmlformats.org/officeDocument/2006/relationships" id="257" r:id="Re61029a4cb074d73"/>
+    <p:sldId xmlns:r="http://schemas.openxmlformats.org/officeDocument/2006/relationships" id="258" r:id="R00dd28a7ef364758"/>
+    <p:sldId xmlns:r="http://schemas.openxmlformats.org/officeDocument/2006/relationships" id="259" r:id="R47336d97605b4f8f"/>
+    <p:sldId xmlns:r="http://schemas.openxmlformats.org/officeDocument/2006/relationships" id="260" r:id="Rb19f9f23effb4f4e"/>
+    <p:sldId xmlns:r="http://schemas.openxmlformats.org/officeDocument/2006/relationships" id="261" r:id="Rd969818c08824d70"/>
+    <p:sldId xmlns:r="http://schemas.openxmlformats.org/officeDocument/2006/relationships" id="262" r:id="R31dcf1f7a7dd4329"/>
+    <p:sldId xmlns:r="http://schemas.openxmlformats.org/officeDocument/2006/relationships" id="263" r:id="R120d447c48b1434c"/>
+    <p:sldId xmlns:r="http://schemas.openxmlformats.org/officeDocument/2006/relationships" id="264" r:id="R2160bbbdb5be4b9f"/>
+    <p:sldId xmlns:r="http://schemas.openxmlformats.org/officeDocument/2006/relationships" id="265" r:id="R3bf813f745c341cf"/>
+    <p:sldId xmlns:r="http://schemas.openxmlformats.org/officeDocument/2006/relationships" id="266" r:id="R012dfd241c8e4671"/>
+    <p:sldId xmlns:r="http://schemas.openxmlformats.org/officeDocument/2006/relationships" id="267" r:id="Rd013bbe6935d408a"/>
+    <p:sldId xmlns:r="http://schemas.openxmlformats.org/officeDocument/2006/relationships" id="268" r:id="R8e08a35011104bd2"/>
   </p:sldIdLst>
   <p:sldSz cx="12192000" cy="6858000"/>
   <p:notesSz cx="6858000" cy="9144000"/>
@@ -559,12 +559,12 @@
           </a:p>
           <a:p xmlns:a="http://schemas.openxmlformats.org/drawingml/2006/main">
             <a:r>
-              <a:t>This slide prevents an overly simple deployment argument. The smallest parameter count is not the fastest implementation.</a:t>
-            </a:r>
-          </a:p>
-          <a:p xmlns:a="http://schemas.openxmlformats.org/drawingml/2006/main">
-            <a:r>
-              <a:t>The benchmark uses random batch-one input, five warm-ups, and thirty timed runs. Because the supplied bundle lacks confirmed runtime metadata and dispersion, treat FPS as environment-specific engineering evidence.</a:t>
+              <a:t>The smallest parameter count is not the fastest implementation.</a:t>
+            </a:r>
+          </a:p>
+          <a:p xmlns:a="http://schemas.openxmlformats.org/drawingml/2006/main">
+            <a:r>
+              <a:t>The benchmark uses random batch-one input, five warm-ups, and thirty timed runs. A current capture records PyTorch 2.7.1, MONAI 1.5.2, CUDA 11.8, cuDNN 9.1, and an RTX 4060 Laptop GPU, but its identity with the historical benchmark environment is unconfirmed.</a:t>
             </a:r>
           </a:p>
           <a:p xmlns:a="http://schemas.openxmlformats.org/drawingml/2006/main">
@@ -585,6 +585,11 @@
           <a:p xmlns:a="http://schemas.openxmlformats.org/drawingml/2006/main">
             <a:r>
               <a:t>- Repository: evidence/rigorous_patient_split/summary_metrics.csv</a:t>
+            </a:r>
+          </a:p>
+          <a:p xmlns:a="http://schemas.openxmlformats.org/drawingml/2006/main">
+            <a:r>
+              <a:t>- Repository: evidence/rigorous_patient_split/environment.json</a:t>
             </a:r>
           </a:p>
           <a:p xmlns:a="http://schemas.openxmlformats.org/drawingml/2006/main">
@@ -669,17 +674,17 @@
           </a:p>
           <a:p xmlns:a="http://schemas.openxmlformats.org/drawingml/2006/main">
             <a:r>
-              <a:t>Separate validity from completeness. The central table and split pass data-free consistency checks; this supports a descriptive comparison.</a:t>
-            </a:r>
-          </a:p>
-          <a:p xmlns:a="http://schemas.openxmlformats.org/drawingml/2006/main">
-            <a:r>
-              <a:t>However, the bundle omitted per-case rows, logs, checkpoint identity, and confirmed environment. Therefore no confidence intervals or exact learning curve are claimed.</a:t>
-            </a:r>
-          </a:p>
-          <a:p xmlns:a="http://schemas.openxmlformats.org/drawingml/2006/main">
-            <a:r>
-              <a:t>Explain the closure collector: it hashes checkpoints without publishing weights and computes patient-level bootstrap intervals only if all original rows are recovered.</a:t>
+              <a:t>Separate numerical consistency from complete historical attestation.</a:t>
+            </a:r>
+          </a:p>
+          <a:p xmlns:a="http://schemas.openxmlformats.org/drawingml/2006/main">
+            <a:r>
+              <a:t>The recovered six case tables, six epoch logs, and six checkpoint records agree with the summary. The patient bootstrap and empty-class check are now reproducible.</a:t>
+            </a:r>
+          </a:p>
+          <a:p xmlns:a="http://schemas.openxmlformats.org/drawingml/2006/main">
+            <a:r>
+              <a:t>Strict closure still fails on exactly four historical links: checkpoint-set identity, environment identity, exact command, and complete dataset snapshot.</a:t>
             </a:r>
           </a:p>
           <a:p xmlns:a="http://schemas.openxmlformats.org/drawingml/2006/main">
@@ -700,6 +705,11 @@
           <a:p xmlns:a="http://schemas.openxmlformats.org/drawingml/2006/main">
             <a:r>
               <a:t>- Repository: evidence/rigorous_patient_split/evidence_audit_report.json</a:t>
+            </a:r>
+          </a:p>
+          <a:p xmlns:a="http://schemas.openxmlformats.org/drawingml/2006/main">
+            <a:r>
+              <a:t>- Repository: evidence/rigorous_patient_split/RECOVERED_CLOSURE_RECEIPT.json</a:t>
             </a:r>
           </a:p>
           <a:p xmlns:a="http://schemas.openxmlformats.org/drawingml/2006/main">
@@ -789,12 +799,17 @@
           </a:p>
           <a:p xmlns:a="http://schemas.openxmlformats.org/drawingml/2006/main">
             <a:r>
-              <a:t>Summarize the contribution in the narrow form supported by the evidence: a compact spatial 3D segmentation architecture and a transparent accuracy–efficiency evaluation.</a:t>
-            </a:r>
-          </a:p>
-          <a:p xmlns:a="http://schemas.openxmlformats.org/drawingml/2006/main">
-            <a:r>
-              <a:t>Then distinguish immediate evidence work from true 4D research. Do not imply that adding ED and ES as separate cases creates a temporal model.</a:t>
+              <a:t>Summarize the contribution in the narrow form supported by the evidence: a compact spatial 3D segmentation architecture and a transparent accuracy-efficiency evaluation.</a:t>
+            </a:r>
+          </a:p>
+          <a:p xmlns:a="http://schemas.openxmlformats.org/drawingml/2006/main">
+            <a:r>
+              <a:t>The immediate next step is no longer to recover case rows; it is to confirm historical provenance and strengthen validity with matched ablations, multiple seeds, and independent evaluation.</a:t>
+            </a:r>
+          </a:p>
+          <a:p xmlns:a="http://schemas.openxmlformats.org/drawingml/2006/main">
+            <a:r>
+              <a:t>True 4D temporal modelling remains a separate future research direction.</a:t>
             </a:r>
           </a:p>
           <a:p xmlns:a="http://schemas.openxmlformats.org/drawingml/2006/main">
@@ -815,6 +830,11 @@
           <a:p xmlns:a="http://schemas.openxmlformats.org/drawingml/2006/main">
             <a:r>
               <a:t>- Repository: SCIENTIFIC_BOUNDARIES.md</a:t>
+            </a:r>
+          </a:p>
+          <a:p xmlns:a="http://schemas.openxmlformats.org/drawingml/2006/main">
+            <a:r>
+              <a:t>- Repository: evidence/rigorous_patient_split/evidence_audit_report.json</a:t>
             </a:r>
           </a:p>
           <a:p xmlns:a="http://schemas.openxmlformats.org/drawingml/2006/main">
@@ -1549,17 +1569,17 @@
           </a:p>
           <a:p xmlns:a="http://schemas.openxmlformats.org/drawingml/2006/main">
             <a:r>
-              <a:t>Use the graph to articulate the actual contribution: Nano-Mamba sits left because of compactness, while retaining competitive validation Dice.</a:t>
-            </a:r>
-          </a:p>
-          <a:p xmlns:a="http://schemas.openxmlformats.org/drawingml/2006/main">
-            <a:r>
-              <a:t>Compared with SegResNet16, it gives up 1.918 percentage points while using 69.021% fewer reported parameters.</a:t>
-            </a:r>
-          </a:p>
-          <a:p xmlns:a="http://schemas.openxmlformats.org/drawingml/2006/main">
-            <a:r>
-              <a:t>Avoid turning the chart into a universal deployment claim; it only covers the six executed configurations.</a:t>
+              <a:t>Use the graph to articulate the actual contribution: Nano-Mamba sits left because of compactness while retaining competitive validation Dice.</a:t>
+            </a:r>
+          </a:p>
+          <a:p xmlns:a="http://schemas.openxmlformats.org/drawingml/2006/main">
+            <a:r>
+              <a:t>The recovered paired patient interval is +2.83 to +5.01 percentage points versus UNet3D and −3.01 to −0.88 versus SegResNet16.</a:t>
+            </a:r>
+          </a:p>
+          <a:p xmlns:a="http://schemas.openxmlformats.org/drawingml/2006/main">
+            <a:r>
+              <a:t>These are post-hoc intervals on the validation patients used for checkpoint selection, not an independent test.</a:t>
             </a:r>
           </a:p>
           <a:p xmlns:a="http://schemas.openxmlformats.org/drawingml/2006/main">
@@ -1585,6 +1605,11 @@
           <a:p xmlns:a="http://schemas.openxmlformats.org/drawingml/2006/main">
             <a:r>
               <a:t>- Repository: evidence/rigorous_patient_split/summary_metrics.csv</a:t>
+            </a:r>
+          </a:p>
+          <a:p xmlns:a="http://schemas.openxmlformats.org/drawingml/2006/main">
+            <a:r>
+              <a:t>- Repository: evidence/rigorous_patient_split/evidence_audit_report.json</a:t>
             </a:r>
           </a:p>
           <a:p xmlns:a="http://schemas.openxmlformats.org/drawingml/2006/main">
@@ -1664,12 +1689,12 @@
           </a:p>
           <a:p xmlns:a="http://schemas.openxmlformats.org/drawingml/2006/main">
             <a:r>
-              <a:t>Treat this as an important negative result, not an embarrassment. The current gated module is not consistently better by Dice.</a:t>
-            </a:r>
-          </a:p>
-          <a:p xmlns:a="http://schemas.openxmlformats.org/drawingml/2006/main">
-            <a:r>
-              <a:t>The correct defence is that the project explores an accuracy–efficiency design point. A matched-capacity ablation and multiple seeds are needed for a causal architecture claim.</a:t>
+              <a:t>Treat this as an important negative result. The paired Nano-minus-No-Mamba interval is −1.48 to −0.23 percentage points on these validation patients.</a:t>
+            </a:r>
+          </a:p>
+          <a:p xmlns:a="http://schemas.openxmlformats.org/drawingml/2006/main">
+            <a:r>
+              <a:t>No-Mamba is larger and structurally different, so the observed ordering does not isolate a causal effect of the gate. Matched capacity and multiple seeds remain necessary.</a:t>
             </a:r>
           </a:p>
           <a:p xmlns:a="http://schemas.openxmlformats.org/drawingml/2006/main">
@@ -1685,6 +1710,16 @@
           <a:p xmlns:a="http://schemas.openxmlformats.org/drawingml/2006/main">
             <a:r>
               <a:t>- Repository: evidence/rigorous_patient_split/summary_metrics.csv</a:t>
+            </a:r>
+          </a:p>
+          <a:p xmlns:a="http://schemas.openxmlformats.org/drawingml/2006/main">
+            <a:r>
+              <a:t>- Repository: evidence/rigorous_patient_split/per_case_NanoMambaUNet.csv</a:t>
+            </a:r>
+          </a:p>
+          <a:p xmlns:a="http://schemas.openxmlformats.org/drawingml/2006/main">
+            <a:r>
+              <a:t>- Repository: evidence/rigorous_patient_split/per_case_Ablation_NoMamba_UNet.csv</a:t>
             </a:r>
           </a:p>
           <a:p xmlns:a="http://schemas.openxmlformats.org/drawingml/2006/main">
@@ -1877,7 +1912,7 @@
   </p:cSld>
   <p:clrMap bg1="lt1" tx1="dk1" bg2="lt2" tx2="dk2" accent1="accent1" accent2="accent2" accent3="accent3" accent4="accent4" accent5="accent5" accent6="accent6" hlink="hlink" folHlink="folHlink"/>
   <p:sldLayoutIdLst>
-    <p:sldLayoutId xmlns:r="http://schemas.openxmlformats.org/officeDocument/2006/relationships" id="2147483649" r:id="R97f03223490c46f3"/>
+    <p:sldLayoutId xmlns:r="http://schemas.openxmlformats.org/officeDocument/2006/relationships" id="2147483649" r:id="Re0cef0c161984328"/>
   </p:sldLayoutIdLst>
   <p:txStyles>
     <p:titleStyle>
@@ -2520,6 +2555,7 @@
           <a:lstStyle xmlns:a="http://schemas.openxmlformats.org/drawingml/2006/main"/>
           <a:p xmlns:a="http://schemas.openxmlformats.org/drawingml/2006/main">
             <a:pPr algn="l">
+              <a:buNone/>
               <a:defRPr sz="1275" b="1" i="0">
                 <a:solidFill>
                   <a:srgbClr val="5F6670"/>
@@ -2578,6 +2614,7 @@
           <a:lstStyle xmlns:a="http://schemas.openxmlformats.org/drawingml/2006/main"/>
           <a:p xmlns:a="http://schemas.openxmlformats.org/drawingml/2006/main">
             <a:pPr algn="l">
+              <a:buNone/>
               <a:defRPr sz="5250" b="1" i="0">
                 <a:solidFill>
                   <a:srgbClr val="000000"/>
@@ -2601,6 +2638,7 @@
           </a:p>
           <a:p xmlns:a="http://schemas.openxmlformats.org/drawingml/2006/main">
             <a:pPr algn="l">
+              <a:buNone/>
               <a:defRPr sz="5250" b="1" i="0">
                 <a:solidFill>
                   <a:srgbClr val="000000"/>
@@ -2624,6 +2662,7 @@
           </a:p>
           <a:p xmlns:a="http://schemas.openxmlformats.org/drawingml/2006/main">
             <a:pPr algn="l">
+              <a:buNone/>
               <a:defRPr sz="5250" b="1" i="0">
                 <a:solidFill>
                   <a:srgbClr val="000000"/>
@@ -2682,6 +2721,7 @@
           <a:lstStyle xmlns:a="http://schemas.openxmlformats.org/drawingml/2006/main"/>
           <a:p xmlns:a="http://schemas.openxmlformats.org/drawingml/2006/main">
             <a:pPr algn="l">
+              <a:buNone/>
               <a:defRPr sz="2400" b="1" i="0">
                 <a:solidFill>
                   <a:srgbClr val="3D8DFF"/>
@@ -2740,6 +2780,7 @@
           <a:lstStyle xmlns:a="http://schemas.openxmlformats.org/drawingml/2006/main"/>
           <a:p xmlns:a="http://schemas.openxmlformats.org/drawingml/2006/main">
             <a:pPr algn="l">
+              <a:buNone/>
               <a:defRPr sz="1725" b="0" i="0">
                 <a:solidFill>
                   <a:srgbClr val="5F6670"/>
@@ -2763,6 +2804,7 @@
           </a:p>
           <a:p xmlns:a="http://schemas.openxmlformats.org/drawingml/2006/main">
             <a:pPr algn="l">
+              <a:buNone/>
               <a:defRPr sz="1725" b="0" i="0">
                 <a:solidFill>
                   <a:srgbClr val="5F6670"/>
@@ -2786,6 +2828,7 @@
           </a:p>
           <a:p xmlns:a="http://schemas.openxmlformats.org/drawingml/2006/main">
             <a:pPr algn="l">
+              <a:buNone/>
               <a:defRPr sz="1725" b="0" i="0">
                 <a:solidFill>
                   <a:srgbClr val="5F6670"/>
@@ -2844,6 +2887,7 @@
           <a:lstStyle xmlns:a="http://schemas.openxmlformats.org/drawingml/2006/main"/>
           <a:p xmlns:a="http://schemas.openxmlformats.org/drawingml/2006/main">
             <a:pPr algn="l">
+              <a:buNone/>
               <a:defRPr sz="2100" b="1" i="0">
                 <a:solidFill>
                   <a:srgbClr val="000000"/>
@@ -2867,6 +2911,7 @@
           </a:p>
           <a:p xmlns:a="http://schemas.openxmlformats.org/drawingml/2006/main">
             <a:pPr algn="l">
+              <a:buNone/>
               <a:defRPr sz="2100" b="1" i="0">
                 <a:solidFill>
                   <a:srgbClr val="000000"/>
@@ -2890,6 +2935,7 @@
           </a:p>
           <a:p xmlns:a="http://schemas.openxmlformats.org/drawingml/2006/main">
             <a:pPr algn="l">
+              <a:buNone/>
               <a:defRPr sz="2100" b="1" i="0">
                 <a:solidFill>
                   <a:srgbClr val="000000"/>
@@ -2977,6 +3023,7 @@
           <a:lstStyle xmlns:a="http://schemas.openxmlformats.org/drawingml/2006/main"/>
           <a:p xmlns:a="http://schemas.openxmlformats.org/drawingml/2006/main">
             <a:pPr algn="l">
+              <a:buNone/>
               <a:defRPr sz="1125" b="1" i="0">
                 <a:solidFill>
                   <a:srgbClr val="5F6670"/>
@@ -3035,6 +3082,7 @@
           <a:lstStyle xmlns:a="http://schemas.openxmlformats.org/drawingml/2006/main"/>
           <a:p xmlns:a="http://schemas.openxmlformats.org/drawingml/2006/main">
             <a:pPr algn="l">
+              <a:buNone/>
               <a:defRPr sz="3600" b="1" i="0">
                 <a:solidFill>
                   <a:srgbClr val="000000"/>
@@ -3124,6 +3172,7 @@
           <a:lstStyle xmlns:a="http://schemas.openxmlformats.org/drawingml/2006/main"/>
           <a:p xmlns:a="http://schemas.openxmlformats.org/drawingml/2006/main">
             <a:pPr algn="r">
+              <a:buNone/>
               <a:defRPr sz="1050" b="0" i="0">
                 <a:solidFill>
                   <a:srgbClr val="5F6670"/>
@@ -3182,14 +3231,14 @@
       </p:sp>
       <p:pic>
         <p:nvPicPr>
-          <p:cNvPr id="19" name=""/>
+          <p:cNvPr id="21" name=""/>
           <p:cNvPicPr>
             <a:picLocks xmlns:a="http://schemas.openxmlformats.org/drawingml/2006/main" noChangeAspect="1"/>
           </p:cNvPicPr>
           <p:nvPr/>
         </p:nvPicPr>
         <p:blipFill>
-          <a:blip xmlns:r="http://schemas.openxmlformats.org/officeDocument/2006/relationships" xmlns:a="http://schemas.openxmlformats.org/drawingml/2006/main" r:embed="R52b61adafc3243cf"/>
+          <a:blip xmlns:r="http://schemas.openxmlformats.org/officeDocument/2006/relationships" xmlns:a="http://schemas.openxmlformats.org/drawingml/2006/main" r:embed="R8994f76e4fd6458a"/>
           <a:stretch xmlns:a="http://schemas.openxmlformats.org/drawingml/2006/main"/>
         </p:blipFill>
         <p:spPr>
@@ -3237,6 +3286,7 @@
           <a:lstStyle xmlns:a="http://schemas.openxmlformats.org/drawingml/2006/main"/>
           <a:p xmlns:a="http://schemas.openxmlformats.org/drawingml/2006/main">
             <a:pPr algn="l">
+              <a:buNone/>
               <a:defRPr sz="2925" b="1" i="0">
                 <a:solidFill>
                   <a:srgbClr val="000000"/>
@@ -3295,6 +3345,7 @@
           <a:lstStyle xmlns:a="http://schemas.openxmlformats.org/drawingml/2006/main"/>
           <a:p xmlns:a="http://schemas.openxmlformats.org/drawingml/2006/main">
             <a:pPr algn="l">
+              <a:buNone/>
               <a:defRPr sz="1650" b="0" i="0">
                 <a:solidFill>
                   <a:srgbClr val="5F6670"/>
@@ -3353,6 +3404,7 @@
           <a:lstStyle xmlns:a="http://schemas.openxmlformats.org/drawingml/2006/main"/>
           <a:p xmlns:a="http://schemas.openxmlformats.org/drawingml/2006/main">
             <a:pPr algn="l">
+              <a:buNone/>
               <a:defRPr sz="2925" b="1" i="0">
                 <a:solidFill>
                   <a:srgbClr val="3D8DFF"/>
@@ -3411,6 +3463,7 @@
           <a:lstStyle xmlns:a="http://schemas.openxmlformats.org/drawingml/2006/main"/>
           <a:p xmlns:a="http://schemas.openxmlformats.org/drawingml/2006/main">
             <a:pPr algn="l">
+              <a:buNone/>
               <a:defRPr sz="1650" b="0" i="0">
                 <a:solidFill>
                   <a:srgbClr val="5F6670"/>
@@ -3500,6 +3553,7 @@
           <a:lstStyle xmlns:a="http://schemas.openxmlformats.org/drawingml/2006/main"/>
           <a:p xmlns:a="http://schemas.openxmlformats.org/drawingml/2006/main">
             <a:pPr algn="l">
+              <a:buNone/>
               <a:defRPr sz="1650" b="1" i="0">
                 <a:solidFill>
                   <a:srgbClr val="000000"/>
@@ -3523,6 +3577,7 @@
           </a:p>
           <a:p xmlns:a="http://schemas.openxmlformats.org/drawingml/2006/main">
             <a:pPr algn="l">
+              <a:buNone/>
               <a:defRPr sz="1650" b="1" i="0">
                 <a:solidFill>
                   <a:srgbClr val="000000"/>
@@ -3581,6 +3636,7 @@
           <a:lstStyle xmlns:a="http://schemas.openxmlformats.org/drawingml/2006/main"/>
           <a:p xmlns:a="http://schemas.openxmlformats.org/drawingml/2006/main">
             <a:pPr algn="l">
+              <a:buNone/>
               <a:defRPr sz="975" b="0" i="0">
                 <a:solidFill>
                   <a:srgbClr val="5F6670"/>
@@ -3599,7 +3655,7 @@
                 <a:ea typeface="Arial"/>
                 <a:cs typeface="Arial"/>
               </a:rPr>
-              <a:t>Original runtime environment was not included in the supplied evidence bundle</a:t>
+              <a:t>Current RTX 4060 / PyTorch capture exists; historical benchmark environment remains unconfirmed</a:t>
             </a:r>
           </a:p>
         </p:txBody>
@@ -3668,6 +3724,7 @@
           <a:lstStyle xmlns:a="http://schemas.openxmlformats.org/drawingml/2006/main"/>
           <a:p xmlns:a="http://schemas.openxmlformats.org/drawingml/2006/main">
             <a:pPr algn="l">
+              <a:buNone/>
               <a:defRPr sz="1125" b="1" i="0">
                 <a:solidFill>
                   <a:srgbClr val="5F6670"/>
@@ -3726,6 +3783,7 @@
           <a:lstStyle xmlns:a="http://schemas.openxmlformats.org/drawingml/2006/main"/>
           <a:p xmlns:a="http://schemas.openxmlformats.org/drawingml/2006/main">
             <a:pPr algn="l">
+              <a:buNone/>
               <a:defRPr sz="3600" b="1" i="0">
                 <a:solidFill>
                   <a:srgbClr val="000000"/>
@@ -3815,6 +3873,7 @@
           <a:lstStyle xmlns:a="http://schemas.openxmlformats.org/drawingml/2006/main"/>
           <a:p xmlns:a="http://schemas.openxmlformats.org/drawingml/2006/main">
             <a:pPr algn="r">
+              <a:buNone/>
               <a:defRPr sz="1050" b="0" i="0">
                 <a:solidFill>
                   <a:srgbClr val="5F6670"/>
@@ -3873,6 +3932,7 @@
           <a:lstStyle xmlns:a="http://schemas.openxmlformats.org/drawingml/2006/main"/>
           <a:p xmlns:a="http://schemas.openxmlformats.org/drawingml/2006/main">
             <a:pPr algn="l">
+              <a:buNone/>
               <a:defRPr sz="2400" b="1" i="0">
                 <a:solidFill>
                   <a:srgbClr val="3D8DFF"/>
@@ -3931,6 +3991,7 @@
           <a:lstStyle xmlns:a="http://schemas.openxmlformats.org/drawingml/2006/main"/>
           <a:p xmlns:a="http://schemas.openxmlformats.org/drawingml/2006/main">
             <a:pPr algn="l">
+              <a:buNone/>
               <a:defRPr sz="1725" b="0" i="0">
                 <a:solidFill>
                   <a:srgbClr val="000000"/>
@@ -3949,7 +4010,18 @@
                 <a:ea typeface="Arial"/>
                 <a:cs typeface="Arial"/>
               </a:rPr>
-              <a:t>•  Main CSV and JSON agree arithmetically</a:t>
+              <a:t>•  </a:t>
+            </a:r>
+            <a:r>
+              <a:rPr sz="1725" b="0" i="0">
+                <a:solidFill>
+                  <a:srgbClr val="000000"/>
+                </a:solidFill>
+                <a:latin typeface="Arial"/>
+                <a:ea typeface="Arial"/>
+                <a:cs typeface="Arial"/>
+              </a:rPr>
+              <a:t>6 × 40 case rows reproduce every summary value</a:t>
             </a:r>
           </a:p>
           <a:p xmlns:a="http://schemas.openxmlformats.org/drawingml/2006/main">
@@ -3959,6 +4031,7 @@
           </a:p>
           <a:p xmlns:a="http://schemas.openxmlformats.org/drawingml/2006/main">
             <a:pPr algn="l">
+              <a:buNone/>
               <a:defRPr sz="1725" b="0" i="0">
                 <a:solidFill>
                   <a:srgbClr val="000000"/>
@@ -3977,7 +4050,18 @@
                 <a:ea typeface="Arial"/>
                 <a:cs typeface="Arial"/>
               </a:rPr>
-              <a:t>•  Seed-42 split is disjoint and complete</a:t>
+              <a:t>•  </a:t>
+            </a:r>
+            <a:r>
+              <a:rPr sz="1725" b="0" i="0">
+                <a:solidFill>
+                  <a:srgbClr val="000000"/>
+                </a:solidFill>
+                <a:latin typeface="Arial"/>
+                <a:ea typeface="Arial"/>
+                <a:cs typeface="Arial"/>
+              </a:rPr>
+              <a:t>6 × 150 logs reproduce all best epochs</a:t>
             </a:r>
           </a:p>
           <a:p xmlns:a="http://schemas.openxmlformats.org/drawingml/2006/main">
@@ -3987,6 +4071,7 @@
           </a:p>
           <a:p xmlns:a="http://schemas.openxmlformats.org/drawingml/2006/main">
             <a:pPr algn="l">
+              <a:buNone/>
               <a:defRPr sz="1725" b="0" i="0">
                 <a:solidFill>
                   <a:srgbClr val="000000"/>
@@ -4005,7 +4090,18 @@
                 <a:ea typeface="Arial"/>
                 <a:cs typeface="Arial"/>
               </a:rPr>
-              <a:t>•  All quantitative figures read the audited CSV</a:t>
+              <a:t>•  </a:t>
+            </a:r>
+            <a:r>
+              <a:rPr sz="1725" b="0" i="0">
+                <a:solidFill>
+                  <a:srgbClr val="000000"/>
+                </a:solidFill>
+                <a:latin typeface="Arial"/>
+                <a:ea typeface="Arial"/>
+                <a:cs typeface="Arial"/>
+              </a:rPr>
+              <a:t>6 checkpoint hashes and metadata agree</a:t>
             </a:r>
           </a:p>
           <a:p xmlns:a="http://schemas.openxmlformats.org/drawingml/2006/main">
@@ -4015,6 +4111,7 @@
           </a:p>
           <a:p xmlns:a="http://schemas.openxmlformats.org/drawingml/2006/main">
             <a:pPr algn="l">
+              <a:buNone/>
               <a:defRPr sz="1725" b="0" i="0">
                 <a:solidFill>
                   <a:srgbClr val="000000"/>
@@ -4033,7 +4130,18 @@
                 <a:ea typeface="Arial"/>
                 <a:cs typeface="Arial"/>
               </a:rPr>
-              <a:t>•  Unsupported curve and qualitative claims removed</a:t>
+              <a:t>•  </a:t>
+            </a:r>
+            <a:r>
+              <a:rPr sz="1725" b="0" i="0">
+                <a:solidFill>
+                  <a:srgbClr val="000000"/>
+                </a:solidFill>
+                <a:latin typeface="Arial"/>
+                <a:ea typeface="Arial"/>
+                <a:cs typeface="Arial"/>
+              </a:rPr>
+              <a:t>Empty-empty branch: 0 of 720 class scores</a:t>
             </a:r>
           </a:p>
         </p:txBody>
@@ -4104,6 +4212,7 @@
           <a:lstStyle xmlns:a="http://schemas.openxmlformats.org/drawingml/2006/main"/>
           <a:p xmlns:a="http://schemas.openxmlformats.org/drawingml/2006/main">
             <a:pPr algn="l">
+              <a:buNone/>
               <a:defRPr sz="2400" b="1" i="0">
                 <a:solidFill>
                   <a:srgbClr val="000000"/>
@@ -4122,7 +4231,7 @@
                 <a:ea typeface="Arial"/>
                 <a:cs typeface="Arial"/>
               </a:rPr>
-              <a:t>OPEN ON ORIGINAL MACHINE</a:t>
+              <a:t>FOUR HISTORY LINKS OPEN</a:t>
             </a:r>
           </a:p>
         </p:txBody>
@@ -4162,6 +4271,7 @@
           <a:lstStyle xmlns:a="http://schemas.openxmlformats.org/drawingml/2006/main"/>
           <a:p xmlns:a="http://schemas.openxmlformats.org/drawingml/2006/main">
             <a:pPr algn="l">
+              <a:buNone/>
               <a:defRPr sz="1725" b="0" i="0">
                 <a:solidFill>
                   <a:srgbClr val="000000"/>
@@ -4180,7 +4290,18 @@
                 <a:ea typeface="Arial"/>
                 <a:cs typeface="Arial"/>
               </a:rPr>
-              <a:t>•  Per-case rows for confidence intervals</a:t>
+              <a:t>•  </a:t>
+            </a:r>
+            <a:r>
+              <a:rPr sz="1725" b="0" i="0">
+                <a:solidFill>
+                  <a:srgbClr val="000000"/>
+                </a:solidFill>
+                <a:latin typeface="Arial"/>
+                <a:ea typeface="Arial"/>
+                <a:cs typeface="Arial"/>
+              </a:rPr>
+              <a:t>Checkpoint directory not confirmed unchanged</a:t>
             </a:r>
           </a:p>
           <a:p xmlns:a="http://schemas.openxmlformats.org/drawingml/2006/main">
@@ -4190,6 +4311,7 @@
           </a:p>
           <a:p xmlns:a="http://schemas.openxmlformats.org/drawingml/2006/main">
             <a:pPr algn="l">
+              <a:buNone/>
               <a:defRPr sz="1725" b="0" i="0">
                 <a:solidFill>
                   <a:srgbClr val="000000"/>
@@ -4208,7 +4330,18 @@
                 <a:ea typeface="Arial"/>
                 <a:cs typeface="Arial"/>
               </a:rPr>
-              <a:t>•  Epoch logs for learning-curve verification</a:t>
+              <a:t>•  </a:t>
+            </a:r>
+            <a:r>
+              <a:rPr sz="1725" b="0" i="0">
+                <a:solidFill>
+                  <a:srgbClr val="000000"/>
+                </a:solidFill>
+                <a:latin typeface="Arial"/>
+                <a:ea typeface="Arial"/>
+                <a:cs typeface="Arial"/>
+              </a:rPr>
+              <a:t>Historical Conda/GPU environment unconfirmed</a:t>
             </a:r>
           </a:p>
           <a:p xmlns:a="http://schemas.openxmlformats.org/drawingml/2006/main">
@@ -4218,6 +4351,7 @@
           </a:p>
           <a:p xmlns:a="http://schemas.openxmlformats.org/drawingml/2006/main">
             <a:pPr algn="l">
+              <a:buNone/>
               <a:defRPr sz="1725" b="0" i="0">
                 <a:solidFill>
                   <a:srgbClr val="000000"/>
@@ -4236,7 +4370,18 @@
                 <a:ea typeface="Arial"/>
                 <a:cs typeface="Arial"/>
               </a:rPr>
-              <a:t>•  Checkpoint hashes and confirmed environment</a:t>
+              <a:t>•  </a:t>
+            </a:r>
+            <a:r>
+              <a:rPr sz="1725" b="0" i="0">
+                <a:solidFill>
+                  <a:srgbClr val="000000"/>
+                </a:solidFill>
+                <a:latin typeface="Arial"/>
+                <a:ea typeface="Arial"/>
+                <a:cs typeface="Arial"/>
+              </a:rPr>
+              <a:t>Exact command and working directory unconfirmed</a:t>
             </a:r>
           </a:p>
           <a:p xmlns:a="http://schemas.openxmlformats.org/drawingml/2006/main">
@@ -4246,6 +4391,7 @@
           </a:p>
           <a:p xmlns:a="http://schemas.openxmlformats.org/drawingml/2006/main">
             <a:pPr algn="l">
+              <a:buNone/>
               <a:defRPr sz="1725" b="0" i="0">
                 <a:solidFill>
                   <a:srgbClr val="000000"/>
@@ -4264,7 +4410,18 @@
                 <a:ea typeface="Arial"/>
                 <a:cs typeface="Arial"/>
               </a:rPr>
-              <a:t>•  Independent test, multi-seed, and external validation</a:t>
+              <a:t>•  </a:t>
+            </a:r>
+            <a:r>
+              <a:rPr sz="1725" b="0" i="0">
+                <a:solidFill>
+                  <a:srgbClr val="000000"/>
+                </a:solidFill>
+                <a:latin typeface="Arial"/>
+                <a:ea typeface="Arial"/>
+                <a:cs typeface="Arial"/>
+              </a:rPr>
+              <a:t>Full 200-case historical content manifest absent</a:t>
             </a:r>
           </a:p>
         </p:txBody>
@@ -4335,6 +4492,7 @@
           <a:lstStyle xmlns:a="http://schemas.openxmlformats.org/drawingml/2006/main"/>
           <a:p xmlns:a="http://schemas.openxmlformats.org/drawingml/2006/main">
             <a:pPr algn="l">
+              <a:buNone/>
               <a:defRPr sz="1650" b="1" i="0">
                 <a:solidFill>
                   <a:srgbClr val="000000"/>
@@ -4353,7 +4511,7 @@
                 <a:ea typeface="Arial"/>
                 <a:cs typeface="Arial"/>
               </a:rPr>
-              <a:t>Core evidence audit: PASS · Strict closure: INCOMPLETE (truthfully blocked on missing original artefacts)</a:t>
+              <a:t>Aggregate + recovered evidence: PASS · Strict closure: INCOMPLETE on four historical confirmations</a:t>
             </a:r>
           </a:p>
         </p:txBody>
@@ -4422,6 +4580,7 @@
           <a:lstStyle xmlns:a="http://schemas.openxmlformats.org/drawingml/2006/main"/>
           <a:p xmlns:a="http://schemas.openxmlformats.org/drawingml/2006/main">
             <a:pPr algn="l">
+              <a:buNone/>
               <a:defRPr sz="1125" b="1" i="0">
                 <a:solidFill>
                   <a:srgbClr val="5F6670"/>
@@ -4480,6 +4639,7 @@
           <a:lstStyle xmlns:a="http://schemas.openxmlformats.org/drawingml/2006/main"/>
           <a:p xmlns:a="http://schemas.openxmlformats.org/drawingml/2006/main">
             <a:pPr algn="l">
+              <a:buNone/>
               <a:defRPr sz="3600" b="1" i="0">
                 <a:solidFill>
                   <a:srgbClr val="000000"/>
@@ -4569,6 +4729,7 @@
           <a:lstStyle xmlns:a="http://schemas.openxmlformats.org/drawingml/2006/main"/>
           <a:p xmlns:a="http://schemas.openxmlformats.org/drawingml/2006/main">
             <a:pPr algn="r">
+              <a:buNone/>
               <a:defRPr sz="1050" b="0" i="0">
                 <a:solidFill>
                   <a:srgbClr val="5F6670"/>
@@ -4751,6 +4912,7 @@
           <a:lstStyle xmlns:a="http://schemas.openxmlformats.org/drawingml/2006/main"/>
           <a:p xmlns:a="http://schemas.openxmlformats.org/drawingml/2006/main">
             <a:pPr algn="l">
+              <a:buNone/>
               <a:defRPr sz="2400" b="1" i="0">
                 <a:solidFill>
                   <a:srgbClr val="000000"/>
@@ -4809,6 +4971,7 @@
           <a:lstStyle xmlns:a="http://schemas.openxmlformats.org/drawingml/2006/main"/>
           <a:p xmlns:a="http://schemas.openxmlformats.org/drawingml/2006/main">
             <a:pPr algn="l">
+              <a:buNone/>
               <a:defRPr sz="2400" b="1" i="0">
                 <a:solidFill>
                   <a:srgbClr val="000000"/>
@@ -4867,6 +5030,7 @@
           <a:lstStyle xmlns:a="http://schemas.openxmlformats.org/drawingml/2006/main"/>
           <a:p xmlns:a="http://schemas.openxmlformats.org/drawingml/2006/main">
             <a:pPr algn="l">
+              <a:buNone/>
               <a:defRPr sz="1650" b="0" i="0">
                 <a:solidFill>
                   <a:srgbClr val="5F6670"/>
@@ -4925,6 +5089,7 @@
           <a:lstStyle xmlns:a="http://schemas.openxmlformats.org/drawingml/2006/main"/>
           <a:p xmlns:a="http://schemas.openxmlformats.org/drawingml/2006/main">
             <a:pPr algn="l">
+              <a:buNone/>
               <a:defRPr sz="2400" b="1" i="0">
                 <a:solidFill>
                   <a:srgbClr val="3D8DFF"/>
@@ -4965,6 +5130,183 @@
         <p:spPr>
           <a:xfrm xmlns:a="http://schemas.openxmlformats.org/drawingml/2006/main">
             <a:off x="4857750" y="3581400"/>
+            <a:ext cx="2857500" cy="514350"/>
+          </a:xfrm>
+          <a:prstGeom xmlns:a="http://schemas.openxmlformats.org/drawingml/2006/main" prst="rect">
+            <a:avLst/>
+          </a:prstGeom>
+          <a:noFill xmlns:a="http://schemas.openxmlformats.org/drawingml/2006/main"/>
+          <a:ln xmlns:a="http://schemas.openxmlformats.org/drawingml/2006/main" w="0">
+            <a:noFill/>
+            <a:prstDash val="solid"/>
+          </a:ln>
+        </p:spPr>
+        <p:txBody>
+          <a:bodyPr xmlns:a="http://schemas.openxmlformats.org/drawingml/2006/main" anchor="t">
+            <a:normAutofit fontScale="97655"/>
+          </a:bodyPr>
+          <a:lstStyle xmlns:a="http://schemas.openxmlformats.org/drawingml/2006/main"/>
+          <a:p xmlns:a="http://schemas.openxmlformats.org/drawingml/2006/main">
+            <a:pPr algn="l">
+              <a:buNone/>
+              <a:defRPr sz="2400" b="1" i="0">
+                <a:solidFill>
+                  <a:srgbClr val="000000"/>
+                </a:solidFill>
+                <a:latin typeface="Arial"/>
+                <a:ea typeface="Arial"/>
+                <a:cs typeface="Arial"/>
+              </a:defRPr>
+            </a:pPr>
+            <a:r>
+              <a:rPr sz="2400" b="1" i="0">
+                <a:solidFill>
+                  <a:srgbClr val="000000"/>
+                </a:solidFill>
+                <a:latin typeface="Arial"/>
+                <a:ea typeface="Arial"/>
+                <a:cs typeface="Arial"/>
+              </a:rPr>
+              <a:t>Strengthen validity</a:t>
+            </a:r>
+          </a:p>
+        </p:txBody>
+      </p:sp>
+      <p:sp>
+        <p:nvSpPr>
+          <p:cNvPr id="14" name="">
+            <a:extLst xmlns:a="http://schemas.openxmlformats.org/drawingml/2006/main">
+              <a:ext uri="{FF2B5EF4-FFF2-40B4-BE49-F238E27FC236}">
+                <a16:creationId xmlns:a16="http://schemas.microsoft.com/office/drawing/2014/main" id="{B54A9A30-A1C2-4C33-9308-E0D38180AE7F}"/>
+              </a:ext>
+            </a:extLst>
+          </p:cNvPr>
+          <p:cNvSpPr>
+            <a:spLocks xmlns:a="http://schemas.openxmlformats.org/drawingml/2006/main" noGrp="1"/>
+          </p:cNvSpPr>
+          <p:nvPr/>
+        </p:nvSpPr>
+        <p:spPr>
+          <a:xfrm xmlns:a="http://schemas.openxmlformats.org/drawingml/2006/main">
+            <a:off x="4857750" y="4171950"/>
+            <a:ext cx="2857500" cy="1123950"/>
+          </a:xfrm>
+          <a:prstGeom xmlns:a="http://schemas.openxmlformats.org/drawingml/2006/main" prst="rect">
+            <a:avLst/>
+          </a:prstGeom>
+          <a:noFill xmlns:a="http://schemas.openxmlformats.org/drawingml/2006/main"/>
+          <a:ln xmlns:a="http://schemas.openxmlformats.org/drawingml/2006/main" w="0">
+            <a:noFill/>
+            <a:prstDash val="solid"/>
+          </a:ln>
+        </p:spPr>
+        <p:txBody>
+          <a:bodyPr xmlns:a="http://schemas.openxmlformats.org/drawingml/2006/main" anchor="t">
+            <a:normAutofit fontScale="83739"/>
+          </a:bodyPr>
+          <a:lstStyle xmlns:a="http://schemas.openxmlformats.org/drawingml/2006/main"/>
+          <a:p xmlns:a="http://schemas.openxmlformats.org/drawingml/2006/main">
+            <a:pPr algn="l">
+              <a:buNone/>
+              <a:defRPr sz="1650" b="0" i="0">
+                <a:solidFill>
+                  <a:srgbClr val="5F6670"/>
+                </a:solidFill>
+                <a:latin typeface="Arial"/>
+                <a:ea typeface="Arial"/>
+                <a:cs typeface="Arial"/>
+              </a:defRPr>
+            </a:pPr>
+            <a:r>
+              <a:rPr sz="1650" b="0" i="0">
+                <a:solidFill>
+                  <a:srgbClr val="5F6670"/>
+                </a:solidFill>
+                <a:latin typeface="Arial"/>
+                <a:ea typeface="Arial"/>
+                <a:cs typeface="Arial"/>
+              </a:rPr>
+              <a:t>Confirm historical provenance; run matched ablations and multiple seeds; add an independent or external test cohort.</a:t>
+            </a:r>
+          </a:p>
+        </p:txBody>
+      </p:sp>
+      <p:sp>
+        <p:nvSpPr>
+          <p:cNvPr id="15" name="">
+            <a:extLst xmlns:a="http://schemas.openxmlformats.org/drawingml/2006/main">
+              <a:ext uri="{FF2B5EF4-FFF2-40B4-BE49-F238E27FC236}">
+                <a16:creationId xmlns:a16="http://schemas.microsoft.com/office/drawing/2014/main" id="{7B83C346-5693-44A1-A2D6-38CCDD7FF9B2}"/>
+              </a:ext>
+            </a:extLst>
+          </p:cNvPr>
+          <p:cNvSpPr>
+            <a:spLocks xmlns:a="http://schemas.openxmlformats.org/drawingml/2006/main" noGrp="1"/>
+          </p:cNvSpPr>
+          <p:nvPr/>
+        </p:nvSpPr>
+        <p:spPr>
+          <a:xfrm xmlns:a="http://schemas.openxmlformats.org/drawingml/2006/main">
+            <a:off x="8667750" y="2286000"/>
+            <a:ext cx="2476500" cy="361950"/>
+          </a:xfrm>
+          <a:prstGeom xmlns:a="http://schemas.openxmlformats.org/drawingml/2006/main" prst="rect">
+            <a:avLst/>
+          </a:prstGeom>
+          <a:noFill xmlns:a="http://schemas.openxmlformats.org/drawingml/2006/main"/>
+          <a:ln xmlns:a="http://schemas.openxmlformats.org/drawingml/2006/main" w="0">
+            <a:noFill/>
+            <a:prstDash val="solid"/>
+          </a:ln>
+        </p:spPr>
+        <p:txBody>
+          <a:bodyPr xmlns:a="http://schemas.openxmlformats.org/drawingml/2006/main" anchor="t">
+            <a:normAutofit fontScale="73958"/>
+          </a:bodyPr>
+          <a:lstStyle xmlns:a="http://schemas.openxmlformats.org/drawingml/2006/main"/>
+          <a:p xmlns:a="http://schemas.openxmlformats.org/drawingml/2006/main">
+            <a:pPr algn="l">
+              <a:buNone/>
+              <a:defRPr sz="2400" b="1" i="0">
+                <a:solidFill>
+                  <a:srgbClr val="000000"/>
+                </a:solidFill>
+                <a:latin typeface="Arial"/>
+                <a:ea typeface="Arial"/>
+                <a:cs typeface="Arial"/>
+              </a:defRPr>
+            </a:pPr>
+            <a:r>
+              <a:rPr sz="2400" b="1" i="0">
+                <a:solidFill>
+                  <a:srgbClr val="000000"/>
+                </a:solidFill>
+                <a:latin typeface="Arial"/>
+                <a:ea typeface="Arial"/>
+                <a:cs typeface="Arial"/>
+              </a:rPr>
+              <a:t>FUTURE SCOPE</a:t>
+            </a:r>
+          </a:p>
+        </p:txBody>
+      </p:sp>
+      <p:sp>
+        <p:nvSpPr>
+          <p:cNvPr id="16" name="">
+            <a:extLst xmlns:a="http://schemas.openxmlformats.org/drawingml/2006/main">
+              <a:ext uri="{FF2B5EF4-FFF2-40B4-BE49-F238E27FC236}">
+                <a16:creationId xmlns:a16="http://schemas.microsoft.com/office/drawing/2014/main" id="{95345CA3-3E48-44FF-AFDE-ED6ACC45FF1B}"/>
+              </a:ext>
+            </a:extLst>
+          </p:cNvPr>
+          <p:cNvSpPr>
+            <a:spLocks xmlns:a="http://schemas.openxmlformats.org/drawingml/2006/main" noGrp="1"/>
+          </p:cNvSpPr>
+          <p:nvPr/>
+        </p:nvSpPr>
+        <p:spPr>
+          <a:xfrm xmlns:a="http://schemas.openxmlformats.org/drawingml/2006/main">
+            <a:off x="8667750" y="3581400"/>
             <a:ext cx="2857500" cy="514350"/>
           </a:xfrm>
           <a:prstGeom xmlns:a="http://schemas.openxmlformats.org/drawingml/2006/main" prst="rect">
@@ -4983,6 +5325,7 @@
           <a:lstStyle xmlns:a="http://schemas.openxmlformats.org/drawingml/2006/main"/>
           <a:p xmlns:a="http://schemas.openxmlformats.org/drawingml/2006/main">
             <a:pPr algn="l">
+              <a:buNone/>
               <a:defRPr sz="2400" b="1" i="0">
                 <a:solidFill>
                   <a:srgbClr val="000000"/>
@@ -5001,28 +5344,28 @@
                 <a:ea typeface="Arial"/>
                 <a:cs typeface="Arial"/>
               </a:rPr>
-              <a:t>Close uncertainty</a:t>
-            </a:r>
-          </a:p>
-        </p:txBody>
-      </p:sp>
-      <p:sp>
-        <p:nvSpPr>
-          <p:cNvPr id="14" name="">
-            <a:extLst xmlns:a="http://schemas.openxmlformats.org/drawingml/2006/main">
-              <a:ext uri="{FF2B5EF4-FFF2-40B4-BE49-F238E27FC236}">
-                <a16:creationId xmlns:a16="http://schemas.microsoft.com/office/drawing/2014/main" id="{B54A9A30-A1C2-4C33-9308-E0D38180AE7F}"/>
-              </a:ext>
-            </a:extLst>
-          </p:cNvPr>
-          <p:cNvSpPr>
-            <a:spLocks xmlns:a="http://schemas.openxmlformats.org/drawingml/2006/main" noGrp="1"/>
-          </p:cNvSpPr>
-          <p:nvPr/>
-        </p:nvSpPr>
-        <p:spPr>
-          <a:xfrm xmlns:a="http://schemas.openxmlformats.org/drawingml/2006/main">
-            <a:off x="4857750" y="4171950"/>
+              <a:t>True 4D motion</a:t>
+            </a:r>
+          </a:p>
+        </p:txBody>
+      </p:sp>
+      <p:sp>
+        <p:nvSpPr>
+          <p:cNvPr id="17" name="">
+            <a:extLst xmlns:a="http://schemas.openxmlformats.org/drawingml/2006/main">
+              <a:ext uri="{FF2B5EF4-FFF2-40B4-BE49-F238E27FC236}">
+                <a16:creationId xmlns:a16="http://schemas.microsoft.com/office/drawing/2014/main" id="{B39AD8F1-5ADD-4E0A-8906-F3EED65BB38F}"/>
+              </a:ext>
+            </a:extLst>
+          </p:cNvPr>
+          <p:cNvSpPr>
+            <a:spLocks xmlns:a="http://schemas.openxmlformats.org/drawingml/2006/main" noGrp="1"/>
+          </p:cNvSpPr>
+          <p:nvPr/>
+        </p:nvSpPr>
+        <p:spPr>
+          <a:xfrm xmlns:a="http://schemas.openxmlformats.org/drawingml/2006/main">
+            <a:off x="8667750" y="4171950"/>
             <a:ext cx="2857500" cy="1123950"/>
           </a:xfrm>
           <a:prstGeom xmlns:a="http://schemas.openxmlformats.org/drawingml/2006/main" prst="rect">
@@ -5041,180 +5384,7 @@
           <a:lstStyle xmlns:a="http://schemas.openxmlformats.org/drawingml/2006/main"/>
           <a:p xmlns:a="http://schemas.openxmlformats.org/drawingml/2006/main">
             <a:pPr algn="l">
-              <a:defRPr sz="1650" b="0" i="0">
-                <a:solidFill>
-                  <a:srgbClr val="5F6670"/>
-                </a:solidFill>
-                <a:latin typeface="Arial"/>
-                <a:ea typeface="Arial"/>
-                <a:cs typeface="Arial"/>
-              </a:defRPr>
-            </a:pPr>
-            <a:r>
-              <a:rPr sz="1650" b="0" i="0">
-                <a:solidFill>
-                  <a:srgbClr val="5F6670"/>
-                </a:solidFill>
-                <a:latin typeface="Arial"/>
-                <a:ea typeface="Arial"/>
-                <a:cs typeface="Arial"/>
-              </a:rPr>
-              <a:t>Recover per-case rows, add paired CIs, matched ablations, multiple seeds, and external validation.</a:t>
-            </a:r>
-          </a:p>
-        </p:txBody>
-      </p:sp>
-      <p:sp>
-        <p:nvSpPr>
-          <p:cNvPr id="15" name="">
-            <a:extLst xmlns:a="http://schemas.openxmlformats.org/drawingml/2006/main">
-              <a:ext uri="{FF2B5EF4-FFF2-40B4-BE49-F238E27FC236}">
-                <a16:creationId xmlns:a16="http://schemas.microsoft.com/office/drawing/2014/main" id="{7B83C346-5693-44A1-A2D6-38CCDD7FF9B2}"/>
-              </a:ext>
-            </a:extLst>
-          </p:cNvPr>
-          <p:cNvSpPr>
-            <a:spLocks xmlns:a="http://schemas.openxmlformats.org/drawingml/2006/main" noGrp="1"/>
-          </p:cNvSpPr>
-          <p:nvPr/>
-        </p:nvSpPr>
-        <p:spPr>
-          <a:xfrm xmlns:a="http://schemas.openxmlformats.org/drawingml/2006/main">
-            <a:off x="8667750" y="2286000"/>
-            <a:ext cx="2476500" cy="361950"/>
-          </a:xfrm>
-          <a:prstGeom xmlns:a="http://schemas.openxmlformats.org/drawingml/2006/main" prst="rect">
-            <a:avLst/>
-          </a:prstGeom>
-          <a:noFill xmlns:a="http://schemas.openxmlformats.org/drawingml/2006/main"/>
-          <a:ln xmlns:a="http://schemas.openxmlformats.org/drawingml/2006/main" w="0">
-            <a:noFill/>
-            <a:prstDash val="solid"/>
-          </a:ln>
-        </p:spPr>
-        <p:txBody>
-          <a:bodyPr xmlns:a="http://schemas.openxmlformats.org/drawingml/2006/main" anchor="t">
-            <a:normAutofit fontScale="73958"/>
-          </a:bodyPr>
-          <a:lstStyle xmlns:a="http://schemas.openxmlformats.org/drawingml/2006/main"/>
-          <a:p xmlns:a="http://schemas.openxmlformats.org/drawingml/2006/main">
-            <a:pPr algn="l">
-              <a:defRPr sz="2400" b="1" i="0">
-                <a:solidFill>
-                  <a:srgbClr val="000000"/>
-                </a:solidFill>
-                <a:latin typeface="Arial"/>
-                <a:ea typeface="Arial"/>
-                <a:cs typeface="Arial"/>
-              </a:defRPr>
-            </a:pPr>
-            <a:r>
-              <a:rPr sz="2400" b="1" i="0">
-                <a:solidFill>
-                  <a:srgbClr val="000000"/>
-                </a:solidFill>
-                <a:latin typeface="Arial"/>
-                <a:ea typeface="Arial"/>
-                <a:cs typeface="Arial"/>
-              </a:rPr>
-              <a:t>FUTURE SCOPE</a:t>
-            </a:r>
-          </a:p>
-        </p:txBody>
-      </p:sp>
-      <p:sp>
-        <p:nvSpPr>
-          <p:cNvPr id="16" name="">
-            <a:extLst xmlns:a="http://schemas.openxmlformats.org/drawingml/2006/main">
-              <a:ext uri="{FF2B5EF4-FFF2-40B4-BE49-F238E27FC236}">
-                <a16:creationId xmlns:a16="http://schemas.microsoft.com/office/drawing/2014/main" id="{95345CA3-3E48-44FF-AFDE-ED6ACC45FF1B}"/>
-              </a:ext>
-            </a:extLst>
-          </p:cNvPr>
-          <p:cNvSpPr>
-            <a:spLocks xmlns:a="http://schemas.openxmlformats.org/drawingml/2006/main" noGrp="1"/>
-          </p:cNvSpPr>
-          <p:nvPr/>
-        </p:nvSpPr>
-        <p:spPr>
-          <a:xfrm xmlns:a="http://schemas.openxmlformats.org/drawingml/2006/main">
-            <a:off x="8667750" y="3581400"/>
-            <a:ext cx="2857500" cy="514350"/>
-          </a:xfrm>
-          <a:prstGeom xmlns:a="http://schemas.openxmlformats.org/drawingml/2006/main" prst="rect">
-            <a:avLst/>
-          </a:prstGeom>
-          <a:noFill xmlns:a="http://schemas.openxmlformats.org/drawingml/2006/main"/>
-          <a:ln xmlns:a="http://schemas.openxmlformats.org/drawingml/2006/main" w="0">
-            <a:noFill/>
-            <a:prstDash val="solid"/>
-          </a:ln>
-        </p:spPr>
-        <p:txBody>
-          <a:bodyPr xmlns:a="http://schemas.openxmlformats.org/drawingml/2006/main" anchor="t">
-            <a:normAutofit fontScale="100000"/>
-          </a:bodyPr>
-          <a:lstStyle xmlns:a="http://schemas.openxmlformats.org/drawingml/2006/main"/>
-          <a:p xmlns:a="http://schemas.openxmlformats.org/drawingml/2006/main">
-            <a:pPr algn="l">
-              <a:defRPr sz="2400" b="1" i="0">
-                <a:solidFill>
-                  <a:srgbClr val="000000"/>
-                </a:solidFill>
-                <a:latin typeface="Arial"/>
-                <a:ea typeface="Arial"/>
-                <a:cs typeface="Arial"/>
-              </a:defRPr>
-            </a:pPr>
-            <a:r>
-              <a:rPr sz="2400" b="1" i="0">
-                <a:solidFill>
-                  <a:srgbClr val="000000"/>
-                </a:solidFill>
-                <a:latin typeface="Arial"/>
-                <a:ea typeface="Arial"/>
-                <a:cs typeface="Arial"/>
-              </a:rPr>
-              <a:t>True 4D motion</a:t>
-            </a:r>
-          </a:p>
-        </p:txBody>
-      </p:sp>
-      <p:sp>
-        <p:nvSpPr>
-          <p:cNvPr id="17" name="">
-            <a:extLst xmlns:a="http://schemas.openxmlformats.org/drawingml/2006/main">
-              <a:ext uri="{FF2B5EF4-FFF2-40B4-BE49-F238E27FC236}">
-                <a16:creationId xmlns:a16="http://schemas.microsoft.com/office/drawing/2014/main" id="{B39AD8F1-5ADD-4E0A-8906-F3EED65BB38F}"/>
-              </a:ext>
-            </a:extLst>
-          </p:cNvPr>
-          <p:cNvSpPr>
-            <a:spLocks xmlns:a="http://schemas.openxmlformats.org/drawingml/2006/main" noGrp="1"/>
-          </p:cNvSpPr>
-          <p:nvPr/>
-        </p:nvSpPr>
-        <p:spPr>
-          <a:xfrm xmlns:a="http://schemas.openxmlformats.org/drawingml/2006/main">
-            <a:off x="8667750" y="4171950"/>
-            <a:ext cx="2857500" cy="1123950"/>
-          </a:xfrm>
-          <a:prstGeom xmlns:a="http://schemas.openxmlformats.org/drawingml/2006/main" prst="rect">
-            <a:avLst/>
-          </a:prstGeom>
-          <a:noFill xmlns:a="http://schemas.openxmlformats.org/drawingml/2006/main"/>
-          <a:ln xmlns:a="http://schemas.openxmlformats.org/drawingml/2006/main" w="0">
-            <a:noFill/>
-            <a:prstDash val="solid"/>
-          </a:ln>
-        </p:spPr>
-        <p:txBody>
-          <a:bodyPr xmlns:a="http://schemas.openxmlformats.org/drawingml/2006/main" anchor="t">
-            <a:normAutofit fontScale="100000"/>
-          </a:bodyPr>
-          <a:lstStyle xmlns:a="http://schemas.openxmlformats.org/drawingml/2006/main"/>
-          <a:p xmlns:a="http://schemas.openxmlformats.org/drawingml/2006/main">
-            <a:pPr algn="l">
+              <a:buNone/>
               <a:defRPr sz="1650" b="0" i="0">
                 <a:solidFill>
                   <a:srgbClr val="5F6670"/>
@@ -5304,6 +5474,7 @@
           <a:lstStyle xmlns:a="http://schemas.openxmlformats.org/drawingml/2006/main"/>
           <a:p xmlns:a="http://schemas.openxmlformats.org/drawingml/2006/main">
             <a:pPr algn="l">
+              <a:buNone/>
               <a:defRPr sz="1650" b="1" i="0">
                 <a:solidFill>
                   <a:srgbClr val="000000"/>
@@ -5391,6 +5562,7 @@
           <a:lstStyle xmlns:a="http://schemas.openxmlformats.org/drawingml/2006/main"/>
           <a:p xmlns:a="http://schemas.openxmlformats.org/drawingml/2006/main">
             <a:pPr algn="l">
+              <a:buNone/>
               <a:defRPr sz="1275" b="1" i="0">
                 <a:solidFill>
                   <a:srgbClr val="5F6670"/>
@@ -5449,6 +5621,7 @@
           <a:lstStyle xmlns:a="http://schemas.openxmlformats.org/drawingml/2006/main"/>
           <a:p xmlns:a="http://schemas.openxmlformats.org/drawingml/2006/main">
             <a:pPr algn="l">
+              <a:buNone/>
               <a:defRPr sz="4950" b="1" i="0">
                 <a:solidFill>
                   <a:srgbClr val="000000"/>
@@ -5472,6 +5645,7 @@
           </a:p>
           <a:p xmlns:a="http://schemas.openxmlformats.org/drawingml/2006/main">
             <a:pPr algn="l">
+              <a:buNone/>
               <a:defRPr sz="4950" b="1" i="0">
                 <a:solidFill>
                   <a:srgbClr val="000000"/>
@@ -5561,6 +5735,7 @@
           <a:lstStyle xmlns:a="http://schemas.openxmlformats.org/drawingml/2006/main"/>
           <a:p xmlns:a="http://schemas.openxmlformats.org/drawingml/2006/main">
             <a:pPr algn="l">
+              <a:buNone/>
               <a:defRPr sz="4350" b="1" i="0">
                 <a:solidFill>
                   <a:srgbClr val="3D8DFF"/>
@@ -5619,6 +5794,7 @@
           <a:lstStyle xmlns:a="http://schemas.openxmlformats.org/drawingml/2006/main"/>
           <a:p xmlns:a="http://schemas.openxmlformats.org/drawingml/2006/main">
             <a:pPr algn="l">
+              <a:buNone/>
               <a:defRPr sz="1650" b="0" i="0">
                 <a:solidFill>
                   <a:srgbClr val="5F6670"/>
@@ -5677,6 +5853,7 @@
           <a:lstStyle xmlns:a="http://schemas.openxmlformats.org/drawingml/2006/main"/>
           <a:p xmlns:a="http://schemas.openxmlformats.org/drawingml/2006/main">
             <a:pPr algn="l">
+              <a:buNone/>
               <a:defRPr sz="4350" b="1" i="0">
                 <a:solidFill>
                   <a:srgbClr val="000000"/>
@@ -5735,6 +5912,7 @@
           <a:lstStyle xmlns:a="http://schemas.openxmlformats.org/drawingml/2006/main"/>
           <a:p xmlns:a="http://schemas.openxmlformats.org/drawingml/2006/main">
             <a:pPr algn="l">
+              <a:buNone/>
               <a:defRPr sz="1650" b="0" i="0">
                 <a:solidFill>
                   <a:srgbClr val="5F6670"/>
@@ -5793,6 +5971,7 @@
           <a:lstStyle xmlns:a="http://schemas.openxmlformats.org/drawingml/2006/main"/>
           <a:p xmlns:a="http://schemas.openxmlformats.org/drawingml/2006/main">
             <a:pPr algn="l">
+              <a:buNone/>
               <a:defRPr sz="4350" b="1" i="0">
                 <a:solidFill>
                   <a:srgbClr val="000000"/>
@@ -5851,6 +6030,7 @@
           <a:lstStyle xmlns:a="http://schemas.openxmlformats.org/drawingml/2006/main"/>
           <a:p xmlns:a="http://schemas.openxmlformats.org/drawingml/2006/main">
             <a:pPr algn="l">
+              <a:buNone/>
               <a:defRPr sz="1650" b="0" i="0">
                 <a:solidFill>
                   <a:srgbClr val="5F6670"/>
@@ -5940,6 +6120,7 @@
           <a:lstStyle xmlns:a="http://schemas.openxmlformats.org/drawingml/2006/main"/>
           <a:p xmlns:a="http://schemas.openxmlformats.org/drawingml/2006/main">
             <a:pPr algn="l">
+              <a:buNone/>
               <a:defRPr sz="1725" b="1" i="0">
                 <a:solidFill>
                   <a:srgbClr val="000000"/>
@@ -5998,6 +6179,7 @@
           <a:lstStyle xmlns:a="http://schemas.openxmlformats.org/drawingml/2006/main"/>
           <a:p xmlns:a="http://schemas.openxmlformats.org/drawingml/2006/main">
             <a:pPr algn="r">
+              <a:buNone/>
               <a:defRPr sz="1950" b="1" i="0">
                 <a:solidFill>
                   <a:srgbClr val="3D8DFF"/>
@@ -6085,6 +6267,7 @@
           <a:lstStyle xmlns:a="http://schemas.openxmlformats.org/drawingml/2006/main"/>
           <a:p xmlns:a="http://schemas.openxmlformats.org/drawingml/2006/main">
             <a:pPr algn="l">
+              <a:buNone/>
               <a:defRPr sz="1125" b="1" i="0">
                 <a:solidFill>
                   <a:srgbClr val="5F6670"/>
@@ -6143,6 +6326,7 @@
           <a:lstStyle xmlns:a="http://schemas.openxmlformats.org/drawingml/2006/main"/>
           <a:p xmlns:a="http://schemas.openxmlformats.org/drawingml/2006/main">
             <a:pPr algn="l">
+              <a:buNone/>
               <a:defRPr sz="3600" b="1" i="0">
                 <a:solidFill>
                   <a:srgbClr val="000000"/>
@@ -6232,6 +6416,7 @@
           <a:lstStyle xmlns:a="http://schemas.openxmlformats.org/drawingml/2006/main"/>
           <a:p xmlns:a="http://schemas.openxmlformats.org/drawingml/2006/main">
             <a:pPr algn="r">
+              <a:buNone/>
               <a:defRPr sz="1050" b="0" i="0">
                 <a:solidFill>
                   <a:srgbClr val="5F6670"/>
@@ -6290,6 +6475,7 @@
           <a:lstStyle xmlns:a="http://schemas.openxmlformats.org/drawingml/2006/main"/>
           <a:p xmlns:a="http://schemas.openxmlformats.org/drawingml/2006/main">
             <a:pPr algn="l">
+              <a:buNone/>
               <a:defRPr sz="4650" b="1" i="0">
                 <a:solidFill>
                   <a:srgbClr val="3D8DFF"/>
@@ -6313,6 +6499,7 @@
           </a:p>
           <a:p xmlns:a="http://schemas.openxmlformats.org/drawingml/2006/main">
             <a:pPr algn="l">
+              <a:buNone/>
               <a:defRPr sz="4650" b="1" i="0">
                 <a:solidFill>
                   <a:srgbClr val="3D8DFF"/>
@@ -6336,6 +6523,7 @@
           </a:p>
           <a:p xmlns:a="http://schemas.openxmlformats.org/drawingml/2006/main">
             <a:pPr algn="l">
+              <a:buNone/>
               <a:defRPr sz="4650" b="1" i="0">
                 <a:solidFill>
                   <a:srgbClr val="3D8DFF"/>
@@ -6425,6 +6613,7 @@
           <a:lstStyle xmlns:a="http://schemas.openxmlformats.org/drawingml/2006/main"/>
           <a:p xmlns:a="http://schemas.openxmlformats.org/drawingml/2006/main">
             <a:pPr algn="l">
+              <a:buNone/>
               <a:defRPr sz="2400" b="1" i="0">
                 <a:solidFill>
                   <a:srgbClr val="5F6670"/>
@@ -6483,6 +6672,7 @@
           <a:lstStyle xmlns:a="http://schemas.openxmlformats.org/drawingml/2006/main"/>
           <a:p xmlns:a="http://schemas.openxmlformats.org/drawingml/2006/main">
             <a:pPr algn="l">
+              <a:buNone/>
               <a:defRPr sz="2100" b="1" i="0">
                 <a:solidFill>
                   <a:srgbClr val="000000"/>
@@ -6541,6 +6731,7 @@
           <a:lstStyle xmlns:a="http://schemas.openxmlformats.org/drawingml/2006/main"/>
           <a:p xmlns:a="http://schemas.openxmlformats.org/drawingml/2006/main">
             <a:pPr algn="l">
+              <a:buNone/>
               <a:defRPr sz="2400" b="1" i="0">
                 <a:solidFill>
                   <a:srgbClr val="5F6670"/>
@@ -6599,6 +6790,7 @@
           <a:lstStyle xmlns:a="http://schemas.openxmlformats.org/drawingml/2006/main"/>
           <a:p xmlns:a="http://schemas.openxmlformats.org/drawingml/2006/main">
             <a:pPr algn="l">
+              <a:buNone/>
               <a:defRPr sz="2100" b="1" i="0">
                 <a:solidFill>
                   <a:srgbClr val="000000"/>
@@ -6657,6 +6849,7 @@
           <a:lstStyle xmlns:a="http://schemas.openxmlformats.org/drawingml/2006/main"/>
           <a:p xmlns:a="http://schemas.openxmlformats.org/drawingml/2006/main">
             <a:pPr algn="l">
+              <a:buNone/>
               <a:defRPr sz="2400" b="1" i="0">
                 <a:solidFill>
                   <a:srgbClr val="5F6670"/>
@@ -6715,6 +6908,7 @@
           <a:lstStyle xmlns:a="http://schemas.openxmlformats.org/drawingml/2006/main"/>
           <a:p xmlns:a="http://schemas.openxmlformats.org/drawingml/2006/main">
             <a:pPr algn="l">
+              <a:buNone/>
               <a:defRPr sz="2100" b="1" i="0">
                 <a:solidFill>
                   <a:srgbClr val="000000"/>
@@ -6804,6 +6998,7 @@
           <a:lstStyle xmlns:a="http://schemas.openxmlformats.org/drawingml/2006/main"/>
           <a:p xmlns:a="http://schemas.openxmlformats.org/drawingml/2006/main">
             <a:pPr algn="l">
+              <a:buNone/>
               <a:defRPr sz="1650" b="1" i="0">
                 <a:solidFill>
                   <a:srgbClr val="000000"/>
@@ -6891,6 +7086,7 @@
           <a:lstStyle xmlns:a="http://schemas.openxmlformats.org/drawingml/2006/main"/>
           <a:p xmlns:a="http://schemas.openxmlformats.org/drawingml/2006/main">
             <a:pPr algn="l">
+              <a:buNone/>
               <a:defRPr sz="1125" b="1" i="0">
                 <a:solidFill>
                   <a:srgbClr val="5F6670"/>
@@ -6949,6 +7145,7 @@
           <a:lstStyle xmlns:a="http://schemas.openxmlformats.org/drawingml/2006/main"/>
           <a:p xmlns:a="http://schemas.openxmlformats.org/drawingml/2006/main">
             <a:pPr algn="l">
+              <a:buNone/>
               <a:defRPr sz="3600" b="1" i="0">
                 <a:solidFill>
                   <a:srgbClr val="000000"/>
@@ -7038,6 +7235,7 @@
           <a:lstStyle xmlns:a="http://schemas.openxmlformats.org/drawingml/2006/main"/>
           <a:p xmlns:a="http://schemas.openxmlformats.org/drawingml/2006/main">
             <a:pPr algn="r">
+              <a:buNone/>
               <a:defRPr sz="1050" b="0" i="0">
                 <a:solidFill>
                   <a:srgbClr val="5F6670"/>
@@ -7220,6 +7418,7 @@
           <a:lstStyle xmlns:a="http://schemas.openxmlformats.org/drawingml/2006/main"/>
           <a:p xmlns:a="http://schemas.openxmlformats.org/drawingml/2006/main">
             <a:pPr algn="l">
+              <a:buNone/>
               <a:defRPr sz="2400" b="1" i="0">
                 <a:solidFill>
                   <a:srgbClr val="000000"/>
@@ -7278,6 +7477,7 @@
           <a:lstStyle xmlns:a="http://schemas.openxmlformats.org/drawingml/2006/main"/>
           <a:p xmlns:a="http://schemas.openxmlformats.org/drawingml/2006/main">
             <a:pPr algn="l">
+              <a:buNone/>
               <a:defRPr sz="2400" b="1" i="0">
                 <a:solidFill>
                   <a:srgbClr val="000000"/>
@@ -7336,6 +7536,7 @@
           <a:lstStyle xmlns:a="http://schemas.openxmlformats.org/drawingml/2006/main"/>
           <a:p xmlns:a="http://schemas.openxmlformats.org/drawingml/2006/main">
             <a:pPr algn="l">
+              <a:buNone/>
               <a:defRPr sz="1650" b="0" i="0">
                 <a:solidFill>
                   <a:srgbClr val="5F6670"/>
@@ -7394,6 +7595,7 @@
           <a:lstStyle xmlns:a="http://schemas.openxmlformats.org/drawingml/2006/main"/>
           <a:p xmlns:a="http://schemas.openxmlformats.org/drawingml/2006/main">
             <a:pPr algn="l">
+              <a:buNone/>
               <a:defRPr sz="2400" b="1" i="0">
                 <a:solidFill>
                   <a:srgbClr val="3D8DFF"/>
@@ -7452,6 +7654,7 @@
           <a:lstStyle xmlns:a="http://schemas.openxmlformats.org/drawingml/2006/main"/>
           <a:p xmlns:a="http://schemas.openxmlformats.org/drawingml/2006/main">
             <a:pPr algn="l">
+              <a:buNone/>
               <a:defRPr sz="2400" b="1" i="0">
                 <a:solidFill>
                   <a:srgbClr val="000000"/>
@@ -7510,6 +7713,7 @@
           <a:lstStyle xmlns:a="http://schemas.openxmlformats.org/drawingml/2006/main"/>
           <a:p xmlns:a="http://schemas.openxmlformats.org/drawingml/2006/main">
             <a:pPr algn="l">
+              <a:buNone/>
               <a:defRPr sz="1650" b="0" i="0">
                 <a:solidFill>
                   <a:srgbClr val="5F6670"/>
@@ -7568,6 +7772,7 @@
           <a:lstStyle xmlns:a="http://schemas.openxmlformats.org/drawingml/2006/main"/>
           <a:p xmlns:a="http://schemas.openxmlformats.org/drawingml/2006/main">
             <a:pPr algn="l">
+              <a:buNone/>
               <a:defRPr sz="2400" b="1" i="0">
                 <a:solidFill>
                   <a:srgbClr val="000000"/>
@@ -7626,6 +7831,7 @@
           <a:lstStyle xmlns:a="http://schemas.openxmlformats.org/drawingml/2006/main"/>
           <a:p xmlns:a="http://schemas.openxmlformats.org/drawingml/2006/main">
             <a:pPr algn="l">
+              <a:buNone/>
               <a:defRPr sz="2400" b="1" i="0">
                 <a:solidFill>
                   <a:srgbClr val="000000"/>
@@ -7684,6 +7890,7 @@
           <a:lstStyle xmlns:a="http://schemas.openxmlformats.org/drawingml/2006/main"/>
           <a:p xmlns:a="http://schemas.openxmlformats.org/drawingml/2006/main">
             <a:pPr algn="l">
+              <a:buNone/>
               <a:defRPr sz="1650" b="0" i="0">
                 <a:solidFill>
                   <a:srgbClr val="5F6670"/>
@@ -7773,6 +7980,7 @@
           <a:lstStyle xmlns:a="http://schemas.openxmlformats.org/drawingml/2006/main"/>
           <a:p xmlns:a="http://schemas.openxmlformats.org/drawingml/2006/main">
             <a:pPr algn="l">
+              <a:buNone/>
               <a:defRPr sz="1650" b="1" i="0">
                 <a:solidFill>
                   <a:srgbClr val="000000"/>
@@ -7831,6 +8039,7 @@
           <a:lstStyle xmlns:a="http://schemas.openxmlformats.org/drawingml/2006/main"/>
           <a:p xmlns:a="http://schemas.openxmlformats.org/drawingml/2006/main">
             <a:pPr algn="l">
+              <a:buNone/>
               <a:defRPr sz="975" b="0" i="0">
                 <a:solidFill>
                   <a:srgbClr val="5F6670"/>
@@ -7918,6 +8127,7 @@
           <a:lstStyle xmlns:a="http://schemas.openxmlformats.org/drawingml/2006/main"/>
           <a:p xmlns:a="http://schemas.openxmlformats.org/drawingml/2006/main">
             <a:pPr algn="l">
+              <a:buNone/>
               <a:defRPr sz="1125" b="1" i="0">
                 <a:solidFill>
                   <a:srgbClr val="5F6670"/>
@@ -7976,6 +8186,7 @@
           <a:lstStyle xmlns:a="http://schemas.openxmlformats.org/drawingml/2006/main"/>
           <a:p xmlns:a="http://schemas.openxmlformats.org/drawingml/2006/main">
             <a:pPr algn="l">
+              <a:buNone/>
               <a:defRPr sz="3600" b="1" i="0">
                 <a:solidFill>
                   <a:srgbClr val="000000"/>
@@ -8065,6 +8276,7 @@
           <a:lstStyle xmlns:a="http://schemas.openxmlformats.org/drawingml/2006/main"/>
           <a:p xmlns:a="http://schemas.openxmlformats.org/drawingml/2006/main">
             <a:pPr algn="r">
+              <a:buNone/>
               <a:defRPr sz="1050" b="0" i="0">
                 <a:solidFill>
                   <a:srgbClr val="5F6670"/>
@@ -8123,14 +8335,14 @@
       </p:sp>
       <p:pic>
         <p:nvPicPr>
-          <p:cNvPr id="16" name=""/>
+          <p:cNvPr id="18" name=""/>
           <p:cNvPicPr>
             <a:picLocks xmlns:a="http://schemas.openxmlformats.org/drawingml/2006/main" noChangeAspect="1"/>
           </p:cNvPicPr>
           <p:nvPr/>
         </p:nvPicPr>
         <p:blipFill>
-          <a:blip xmlns:r="http://schemas.openxmlformats.org/officeDocument/2006/relationships" xmlns:a="http://schemas.openxmlformats.org/drawingml/2006/main" r:embed="R74a33f5384754afd"/>
+          <a:blip xmlns:r="http://schemas.openxmlformats.org/officeDocument/2006/relationships" xmlns:a="http://schemas.openxmlformats.org/drawingml/2006/main" r:embed="R07ee05e308784b62"/>
           <a:stretch xmlns:a="http://schemas.openxmlformats.org/drawingml/2006/main"/>
         </p:blipFill>
         <p:spPr>
@@ -8178,6 +8390,7 @@
           <a:lstStyle xmlns:a="http://schemas.openxmlformats.org/drawingml/2006/main"/>
           <a:p xmlns:a="http://schemas.openxmlformats.org/drawingml/2006/main">
             <a:pPr algn="l">
+              <a:buNone/>
               <a:defRPr sz="2400" b="1" i="0">
                 <a:solidFill>
                   <a:srgbClr val="000000"/>
@@ -8236,6 +8449,7 @@
           <a:lstStyle xmlns:a="http://schemas.openxmlformats.org/drawingml/2006/main"/>
           <a:p xmlns:a="http://schemas.openxmlformats.org/drawingml/2006/main">
             <a:pPr algn="l">
+              <a:buNone/>
               <a:defRPr sz="1725" b="0" i="0">
                 <a:solidFill>
                   <a:srgbClr val="000000"/>
@@ -8264,6 +8478,7 @@
           </a:p>
           <a:p xmlns:a="http://schemas.openxmlformats.org/drawingml/2006/main">
             <a:pPr algn="l">
+              <a:buNone/>
               <a:defRPr sz="1725" b="0" i="0">
                 <a:solidFill>
                   <a:srgbClr val="000000"/>
@@ -8292,6 +8507,7 @@
           </a:p>
           <a:p xmlns:a="http://schemas.openxmlformats.org/drawingml/2006/main">
             <a:pPr algn="l">
+              <a:buNone/>
               <a:defRPr sz="1725" b="0" i="0">
                 <a:solidFill>
                   <a:srgbClr val="000000"/>
@@ -8350,6 +8566,7 @@
           <a:lstStyle xmlns:a="http://schemas.openxmlformats.org/drawingml/2006/main"/>
           <a:p xmlns:a="http://schemas.openxmlformats.org/drawingml/2006/main">
             <a:pPr algn="l">
+              <a:buNone/>
               <a:defRPr sz="2025" b="1" i="0">
                 <a:solidFill>
                   <a:srgbClr val="3D8DFF"/>
@@ -8408,6 +8625,7 @@
           <a:lstStyle xmlns:a="http://schemas.openxmlformats.org/drawingml/2006/main"/>
           <a:p xmlns:a="http://schemas.openxmlformats.org/drawingml/2006/main">
             <a:pPr algn="l">
+              <a:buNone/>
               <a:defRPr sz="975" b="0" i="0">
                 <a:solidFill>
                   <a:srgbClr val="5F6670"/>
@@ -8495,6 +8713,7 @@
           <a:lstStyle xmlns:a="http://schemas.openxmlformats.org/drawingml/2006/main"/>
           <a:p xmlns:a="http://schemas.openxmlformats.org/drawingml/2006/main">
             <a:pPr algn="l">
+              <a:buNone/>
               <a:defRPr sz="1125" b="1" i="0">
                 <a:solidFill>
                   <a:srgbClr val="5F6670"/>
@@ -8553,6 +8772,7 @@
           <a:lstStyle xmlns:a="http://schemas.openxmlformats.org/drawingml/2006/main"/>
           <a:p xmlns:a="http://schemas.openxmlformats.org/drawingml/2006/main">
             <a:pPr algn="l">
+              <a:buNone/>
               <a:defRPr sz="3600" b="1" i="0">
                 <a:solidFill>
                   <a:srgbClr val="000000"/>
@@ -8642,6 +8862,7 @@
           <a:lstStyle xmlns:a="http://schemas.openxmlformats.org/drawingml/2006/main"/>
           <a:p xmlns:a="http://schemas.openxmlformats.org/drawingml/2006/main">
             <a:pPr algn="r">
+              <a:buNone/>
               <a:defRPr sz="1050" b="0" i="0">
                 <a:solidFill>
                   <a:srgbClr val="5F6670"/>
@@ -8700,6 +8921,7 @@
           <a:lstStyle xmlns:a="http://schemas.openxmlformats.org/drawingml/2006/main"/>
           <a:p xmlns:a="http://schemas.openxmlformats.org/drawingml/2006/main">
             <a:pPr algn="l">
+              <a:buNone/>
               <a:defRPr sz="2400" b="1" i="0">
                 <a:solidFill>
                   <a:srgbClr val="5F6670"/>
@@ -8758,6 +8980,7 @@
           <a:lstStyle xmlns:a="http://schemas.openxmlformats.org/drawingml/2006/main"/>
           <a:p xmlns:a="http://schemas.openxmlformats.org/drawingml/2006/main">
             <a:pPr algn="l">
+              <a:buNone/>
               <a:defRPr sz="2550" b="1" i="0">
                 <a:solidFill>
                   <a:srgbClr val="000000"/>
@@ -8781,6 +9004,7 @@
           </a:p>
           <a:p xmlns:a="http://schemas.openxmlformats.org/drawingml/2006/main">
             <a:pPr algn="l">
+              <a:buNone/>
               <a:defRPr sz="2550" b="1" i="0">
                 <a:solidFill>
                   <a:srgbClr val="000000"/>
@@ -8804,6 +9028,7 @@
           </a:p>
           <a:p xmlns:a="http://schemas.openxmlformats.org/drawingml/2006/main">
             <a:pPr algn="l">
+              <a:buNone/>
               <a:defRPr sz="2550" b="1" i="0">
                 <a:solidFill>
                   <a:srgbClr val="000000"/>
@@ -8862,6 +9087,7 @@
           <a:lstStyle xmlns:a="http://schemas.openxmlformats.org/drawingml/2006/main"/>
           <a:p xmlns:a="http://schemas.openxmlformats.org/drawingml/2006/main">
             <a:pPr algn="l">
+              <a:buNone/>
               <a:defRPr sz="2400" b="1" i="0">
                 <a:solidFill>
                   <a:srgbClr val="5F6670"/>
@@ -8920,6 +9146,7 @@
           <a:lstStyle xmlns:a="http://schemas.openxmlformats.org/drawingml/2006/main"/>
           <a:p xmlns:a="http://schemas.openxmlformats.org/drawingml/2006/main">
             <a:pPr algn="l">
+              <a:buNone/>
               <a:defRPr sz="2550" b="1" i="0">
                 <a:solidFill>
                   <a:srgbClr val="000000"/>
@@ -8943,6 +9170,7 @@
           </a:p>
           <a:p xmlns:a="http://schemas.openxmlformats.org/drawingml/2006/main">
             <a:pPr algn="l">
+              <a:buNone/>
               <a:defRPr sz="2550" b="1" i="0">
                 <a:solidFill>
                   <a:srgbClr val="000000"/>
@@ -8966,6 +9194,7 @@
           </a:p>
           <a:p xmlns:a="http://schemas.openxmlformats.org/drawingml/2006/main">
             <a:pPr algn="l">
+              <a:buNone/>
               <a:defRPr sz="2550" b="1" i="0">
                 <a:solidFill>
                   <a:srgbClr val="000000"/>
@@ -9086,6 +9315,7 @@
           <a:lstStyle xmlns:a="http://schemas.openxmlformats.org/drawingml/2006/main"/>
           <a:p xmlns:a="http://schemas.openxmlformats.org/drawingml/2006/main">
             <a:pPr algn="l">
+              <a:buNone/>
               <a:defRPr sz="1950" b="1" i="0">
                 <a:solidFill>
                   <a:srgbClr val="3D8DFF"/>
@@ -9144,6 +9374,7 @@
           <a:lstStyle xmlns:a="http://schemas.openxmlformats.org/drawingml/2006/main"/>
           <a:p xmlns:a="http://schemas.openxmlformats.org/drawingml/2006/main">
             <a:pPr algn="l">
+              <a:buNone/>
               <a:defRPr sz="1650" b="0" i="0">
                 <a:solidFill>
                   <a:srgbClr val="000000"/>
@@ -9231,6 +9462,7 @@
           <a:lstStyle xmlns:a="http://schemas.openxmlformats.org/drawingml/2006/main"/>
           <a:p xmlns:a="http://schemas.openxmlformats.org/drawingml/2006/main">
             <a:pPr algn="l">
+              <a:buNone/>
               <a:defRPr sz="1125" b="1" i="0">
                 <a:solidFill>
                   <a:srgbClr val="5F6670"/>
@@ -9289,6 +9521,7 @@
           <a:lstStyle xmlns:a="http://schemas.openxmlformats.org/drawingml/2006/main"/>
           <a:p xmlns:a="http://schemas.openxmlformats.org/drawingml/2006/main">
             <a:pPr algn="l">
+              <a:buNone/>
               <a:defRPr sz="3600" b="1" i="0">
                 <a:solidFill>
                   <a:srgbClr val="000000"/>
@@ -9378,6 +9611,7 @@
           <a:lstStyle xmlns:a="http://schemas.openxmlformats.org/drawingml/2006/main"/>
           <a:p xmlns:a="http://schemas.openxmlformats.org/drawingml/2006/main">
             <a:pPr algn="r">
+              <a:buNone/>
               <a:defRPr sz="1050" b="0" i="0">
                 <a:solidFill>
                   <a:srgbClr val="5F6670"/>
@@ -9403,7 +9637,7 @@
       </p:sp>
       <p:graphicFrame>
         <p:nvGraphicFramePr>
-          <p:cNvPr id="13" name=""/>
+          <p:cNvPr id="15" name=""/>
           <p:cNvGraphicFramePr/>
           <p:nvPr/>
         </p:nvGraphicFramePr>
@@ -9429,7 +9663,9 @@
                     <a:bodyPr/>
                     <a:lstStyle/>
                     <a:p>
-                      <a:pPr algn="l"/>
+                      <a:pPr algn="l">
+                        <a:buNone/>
+                      </a:pPr>
                       <a:r>
                         <a:rPr sz="1650" b="1">
                           <a:solidFill>
@@ -9454,7 +9690,9 @@
                     <a:bodyPr/>
                     <a:lstStyle/>
                     <a:p>
-                      <a:pPr algn="ctr"/>
+                      <a:pPr algn="ctr">
+                        <a:buNone/>
+                      </a:pPr>
                       <a:r>
                         <a:rPr sz="1650" b="1">
                           <a:solidFill>
@@ -9479,7 +9717,9 @@
                     <a:bodyPr/>
                     <a:lstStyle/>
                     <a:p>
-                      <a:pPr algn="ctr"/>
+                      <a:pPr algn="ctr">
+                        <a:buNone/>
+                      </a:pPr>
                       <a:r>
                         <a:rPr sz="1650" b="1">
                           <a:solidFill>
@@ -9504,7 +9744,9 @@
                     <a:bodyPr/>
                     <a:lstStyle/>
                     <a:p>
-                      <a:pPr algn="ctr"/>
+                      <a:pPr algn="ctr">
+                        <a:buNone/>
+                      </a:pPr>
                       <a:r>
                         <a:rPr sz="1650" b="1">
                           <a:solidFill>
@@ -9529,7 +9771,9 @@
                     <a:bodyPr/>
                     <a:lstStyle/>
                     <a:p>
-                      <a:pPr algn="ctr"/>
+                      <a:pPr algn="ctr">
+                        <a:buNone/>
+                      </a:pPr>
                       <a:r>
                         <a:rPr sz="1650" b="1">
                           <a:solidFill>
@@ -9554,7 +9798,9 @@
                     <a:bodyPr/>
                     <a:lstStyle/>
                     <a:p>
-                      <a:pPr algn="ctr"/>
+                      <a:pPr algn="ctr">
+                        <a:buNone/>
+                      </a:pPr>
                       <a:r>
                         <a:rPr sz="1650" b="1">
                           <a:solidFill>
@@ -9581,7 +9827,9 @@
                     <a:bodyPr/>
                     <a:lstStyle/>
                     <a:p>
-                      <a:pPr algn="l"/>
+                      <a:pPr algn="l">
+                        <a:buNone/>
+                      </a:pPr>
                       <a:r>
                         <a:rPr sz="1650" b="0">
                           <a:solidFill>
@@ -9606,7 +9854,9 @@
                     <a:bodyPr/>
                     <a:lstStyle/>
                     <a:p>
-                      <a:pPr algn="ctr"/>
+                      <a:pPr algn="ctr">
+                        <a:buNone/>
+                      </a:pPr>
                       <a:r>
                         <a:rPr sz="1650" b="0">
                           <a:solidFill>
@@ -9631,7 +9881,9 @@
                     <a:bodyPr/>
                     <a:lstStyle/>
                     <a:p>
-                      <a:pPr algn="ctr"/>
+                      <a:pPr algn="ctr">
+                        <a:buNone/>
+                      </a:pPr>
                       <a:r>
                         <a:rPr sz="1650" b="0">
                           <a:solidFill>
@@ -9656,7 +9908,9 @@
                     <a:bodyPr/>
                     <a:lstStyle/>
                     <a:p>
-                      <a:pPr algn="ctr"/>
+                      <a:pPr algn="ctr">
+                        <a:buNone/>
+                      </a:pPr>
                       <a:r>
                         <a:rPr sz="1650" b="0">
                           <a:solidFill>
@@ -9681,7 +9935,9 @@
                     <a:bodyPr/>
                     <a:lstStyle/>
                     <a:p>
-                      <a:pPr algn="ctr"/>
+                      <a:pPr algn="ctr">
+                        <a:buNone/>
+                      </a:pPr>
                       <a:r>
                         <a:rPr sz="1650" b="0">
                           <a:solidFill>
@@ -9706,7 +9962,9 @@
                     <a:bodyPr/>
                     <a:lstStyle/>
                     <a:p>
-                      <a:pPr algn="ctr"/>
+                      <a:pPr algn="ctr">
+                        <a:buNone/>
+                      </a:pPr>
                       <a:r>
                         <a:rPr sz="1650" b="0">
                           <a:solidFill>
@@ -9733,7 +9991,9 @@
                     <a:bodyPr/>
                     <a:lstStyle/>
                     <a:p>
-                      <a:pPr algn="l"/>
+                      <a:pPr algn="l">
+                        <a:buNone/>
+                      </a:pPr>
                       <a:r>
                         <a:rPr sz="1650" b="1">
                           <a:solidFill>
@@ -9758,7 +10018,9 @@
                     <a:bodyPr/>
                     <a:lstStyle/>
                     <a:p>
-                      <a:pPr algn="ctr"/>
+                      <a:pPr algn="ctr">
+                        <a:buNone/>
+                      </a:pPr>
                       <a:r>
                         <a:rPr sz="1650" b="1">
                           <a:solidFill>
@@ -9783,7 +10045,9 @@
                     <a:bodyPr/>
                     <a:lstStyle/>
                     <a:p>
-                      <a:pPr algn="ctr"/>
+                      <a:pPr algn="ctr">
+                        <a:buNone/>
+                      </a:pPr>
                       <a:r>
                         <a:rPr sz="1650" b="1">
                           <a:solidFill>
@@ -9808,7 +10072,9 @@
                     <a:bodyPr/>
                     <a:lstStyle/>
                     <a:p>
-                      <a:pPr algn="ctr"/>
+                      <a:pPr algn="ctr">
+                        <a:buNone/>
+                      </a:pPr>
                       <a:r>
                         <a:rPr sz="1650" b="1">
                           <a:solidFill>
@@ -9833,7 +10099,9 @@
                     <a:bodyPr/>
                     <a:lstStyle/>
                     <a:p>
-                      <a:pPr algn="ctr"/>
+                      <a:pPr algn="ctr">
+                        <a:buNone/>
+                      </a:pPr>
                       <a:r>
                         <a:rPr sz="1650" b="1">
                           <a:solidFill>
@@ -9858,7 +10126,9 @@
                     <a:bodyPr/>
                     <a:lstStyle/>
                     <a:p>
-                      <a:pPr algn="ctr"/>
+                      <a:pPr algn="ctr">
+                        <a:buNone/>
+                      </a:pPr>
                       <a:r>
                         <a:rPr sz="1650" b="1">
                           <a:solidFill>
@@ -9885,7 +10155,9 @@
                     <a:bodyPr/>
                     <a:lstStyle/>
                     <a:p>
-                      <a:pPr algn="l"/>
+                      <a:pPr algn="l">
+                        <a:buNone/>
+                      </a:pPr>
                       <a:r>
                         <a:rPr sz="1650" b="0">
                           <a:solidFill>
@@ -9910,7 +10182,9 @@
                     <a:bodyPr/>
                     <a:lstStyle/>
                     <a:p>
-                      <a:pPr algn="ctr"/>
+                      <a:pPr algn="ctr">
+                        <a:buNone/>
+                      </a:pPr>
                       <a:r>
                         <a:rPr sz="1650" b="0">
                           <a:solidFill>
@@ -9935,7 +10209,9 @@
                     <a:bodyPr/>
                     <a:lstStyle/>
                     <a:p>
-                      <a:pPr algn="ctr"/>
+                      <a:pPr algn="ctr">
+                        <a:buNone/>
+                      </a:pPr>
                       <a:r>
                         <a:rPr sz="1650" b="0">
                           <a:solidFill>
@@ -9960,7 +10236,9 @@
                     <a:bodyPr/>
                     <a:lstStyle/>
                     <a:p>
-                      <a:pPr algn="ctr"/>
+                      <a:pPr algn="ctr">
+                        <a:buNone/>
+                      </a:pPr>
                       <a:r>
                         <a:rPr sz="1650" b="0">
                           <a:solidFill>
@@ -9985,7 +10263,9 @@
                     <a:bodyPr/>
                     <a:lstStyle/>
                     <a:p>
-                      <a:pPr algn="ctr"/>
+                      <a:pPr algn="ctr">
+                        <a:buNone/>
+                      </a:pPr>
                       <a:r>
                         <a:rPr sz="1650" b="0">
                           <a:solidFill>
@@ -10010,7 +10290,9 @@
                     <a:bodyPr/>
                     <a:lstStyle/>
                     <a:p>
-                      <a:pPr algn="ctr"/>
+                      <a:pPr algn="ctr">
+                        <a:buNone/>
+                      </a:pPr>
                       <a:r>
                         <a:rPr sz="1650" b="0">
                           <a:solidFill>
@@ -10037,7 +10319,9 @@
                     <a:bodyPr/>
                     <a:lstStyle/>
                     <a:p>
-                      <a:pPr algn="l"/>
+                      <a:pPr algn="l">
+                        <a:buNone/>
+                      </a:pPr>
                       <a:r>
                         <a:rPr sz="1650" b="0">
                           <a:solidFill>
@@ -10062,7 +10346,9 @@
                     <a:bodyPr/>
                     <a:lstStyle/>
                     <a:p>
-                      <a:pPr algn="ctr"/>
+                      <a:pPr algn="ctr">
+                        <a:buNone/>
+                      </a:pPr>
                       <a:r>
                         <a:rPr sz="1650" b="0">
                           <a:solidFill>
@@ -10087,7 +10373,9 @@
                     <a:bodyPr/>
                     <a:lstStyle/>
                     <a:p>
-                      <a:pPr algn="ctr"/>
+                      <a:pPr algn="ctr">
+                        <a:buNone/>
+                      </a:pPr>
                       <a:r>
                         <a:rPr sz="1650" b="0">
                           <a:solidFill>
@@ -10112,7 +10400,9 @@
                     <a:bodyPr/>
                     <a:lstStyle/>
                     <a:p>
-                      <a:pPr algn="ctr"/>
+                      <a:pPr algn="ctr">
+                        <a:buNone/>
+                      </a:pPr>
                       <a:r>
                         <a:rPr sz="1650" b="0">
                           <a:solidFill>
@@ -10137,7 +10427,9 @@
                     <a:bodyPr/>
                     <a:lstStyle/>
                     <a:p>
-                      <a:pPr algn="ctr"/>
+                      <a:pPr algn="ctr">
+                        <a:buNone/>
+                      </a:pPr>
                       <a:r>
                         <a:rPr sz="1650" b="0">
                           <a:solidFill>
@@ -10162,7 +10454,9 @@
                     <a:bodyPr/>
                     <a:lstStyle/>
                     <a:p>
-                      <a:pPr algn="ctr"/>
+                      <a:pPr algn="ctr">
+                        <a:buNone/>
+                      </a:pPr>
                       <a:r>
                         <a:rPr sz="1650" b="0">
                           <a:solidFill>
@@ -10189,7 +10483,9 @@
                     <a:bodyPr/>
                     <a:lstStyle/>
                     <a:p>
-                      <a:pPr algn="l"/>
+                      <a:pPr algn="l">
+                        <a:buNone/>
+                      </a:pPr>
                       <a:r>
                         <a:rPr sz="1650" b="0">
                           <a:solidFill>
@@ -10214,7 +10510,9 @@
                     <a:bodyPr/>
                     <a:lstStyle/>
                     <a:p>
-                      <a:pPr algn="ctr"/>
+                      <a:pPr algn="ctr">
+                        <a:buNone/>
+                      </a:pPr>
                       <a:r>
                         <a:rPr sz="1650" b="0">
                           <a:solidFill>
@@ -10239,7 +10537,9 @@
                     <a:bodyPr/>
                     <a:lstStyle/>
                     <a:p>
-                      <a:pPr algn="ctr"/>
+                      <a:pPr algn="ctr">
+                        <a:buNone/>
+                      </a:pPr>
                       <a:r>
                         <a:rPr sz="1650" b="0">
                           <a:solidFill>
@@ -10264,7 +10564,9 @@
                     <a:bodyPr/>
                     <a:lstStyle/>
                     <a:p>
-                      <a:pPr algn="ctr"/>
+                      <a:pPr algn="ctr">
+                        <a:buNone/>
+                      </a:pPr>
                       <a:r>
                         <a:rPr sz="1650" b="0">
                           <a:solidFill>
@@ -10289,7 +10591,9 @@
                     <a:bodyPr/>
                     <a:lstStyle/>
                     <a:p>
-                      <a:pPr algn="ctr"/>
+                      <a:pPr algn="ctr">
+                        <a:buNone/>
+                      </a:pPr>
                       <a:r>
                         <a:rPr sz="1650" b="0">
                           <a:solidFill>
@@ -10314,7 +10618,9 @@
                     <a:bodyPr/>
                     <a:lstStyle/>
                     <a:p>
-                      <a:pPr algn="ctr"/>
+                      <a:pPr algn="ctr">
+                        <a:buNone/>
+                      </a:pPr>
                       <a:r>
                         <a:rPr sz="1650" b="0">
                           <a:solidFill>
@@ -10341,7 +10647,9 @@
                     <a:bodyPr/>
                     <a:lstStyle/>
                     <a:p>
-                      <a:pPr algn="l"/>
+                      <a:pPr algn="l">
+                        <a:buNone/>
+                      </a:pPr>
                       <a:r>
                         <a:rPr sz="1650" b="1">
                           <a:solidFill>
@@ -10366,7 +10674,9 @@
                     <a:bodyPr/>
                     <a:lstStyle/>
                     <a:p>
-                      <a:pPr algn="ctr"/>
+                      <a:pPr algn="ctr">
+                        <a:buNone/>
+                      </a:pPr>
                       <a:r>
                         <a:rPr sz="1650" b="1">
                           <a:solidFill>
@@ -10391,7 +10701,9 @@
                     <a:bodyPr/>
                     <a:lstStyle/>
                     <a:p>
-                      <a:pPr algn="ctr"/>
+                      <a:pPr algn="ctr">
+                        <a:buNone/>
+                      </a:pPr>
                       <a:r>
                         <a:rPr sz="1650" b="1">
                           <a:solidFill>
@@ -10416,7 +10728,9 @@
                     <a:bodyPr/>
                     <a:lstStyle/>
                     <a:p>
-                      <a:pPr algn="ctr"/>
+                      <a:pPr algn="ctr">
+                        <a:buNone/>
+                      </a:pPr>
                       <a:r>
                         <a:rPr sz="1650" b="1">
                           <a:solidFill>
@@ -10441,7 +10755,9 @@
                     <a:bodyPr/>
                     <a:lstStyle/>
                     <a:p>
-                      <a:pPr algn="ctr"/>
+                      <a:pPr algn="ctr">
+                        <a:buNone/>
+                      </a:pPr>
                       <a:r>
                         <a:rPr sz="1650" b="1">
                           <a:solidFill>
@@ -10466,7 +10782,9 @@
                     <a:bodyPr/>
                     <a:lstStyle/>
                     <a:p>
-                      <a:pPr algn="ctr"/>
+                      <a:pPr algn="ctr">
+                        <a:buNone/>
+                      </a:pPr>
                       <a:r>
                         <a:rPr sz="1650" b="1">
                           <a:solidFill>
@@ -10526,6 +10844,7 @@
           <a:lstStyle xmlns:a="http://schemas.openxmlformats.org/drawingml/2006/main"/>
           <a:p xmlns:a="http://schemas.openxmlformats.org/drawingml/2006/main">
             <a:pPr algn="l">
+              <a:buNone/>
               <a:defRPr sz="1350" b="1" i="0">
                 <a:solidFill>
                   <a:srgbClr val="000000"/>
@@ -10584,6 +10903,7 @@
           <a:lstStyle xmlns:a="http://schemas.openxmlformats.org/drawingml/2006/main"/>
           <a:p xmlns:a="http://schemas.openxmlformats.org/drawingml/2006/main">
             <a:pPr algn="r">
+              <a:buNone/>
               <a:defRPr sz="1350" b="1" i="0">
                 <a:solidFill>
                   <a:srgbClr val="3D8DFF"/>
@@ -10642,6 +10962,7 @@
           <a:lstStyle xmlns:a="http://schemas.openxmlformats.org/drawingml/2006/main"/>
           <a:p xmlns:a="http://schemas.openxmlformats.org/drawingml/2006/main">
             <a:pPr algn="l">
+              <a:buNone/>
               <a:defRPr sz="975" b="0" i="0">
                 <a:solidFill>
                   <a:srgbClr val="5F6670"/>
@@ -10729,6 +11050,7 @@
           <a:lstStyle xmlns:a="http://schemas.openxmlformats.org/drawingml/2006/main"/>
           <a:p xmlns:a="http://schemas.openxmlformats.org/drawingml/2006/main">
             <a:pPr algn="l">
+              <a:buNone/>
               <a:defRPr sz="1125" b="1" i="0">
                 <a:solidFill>
                   <a:srgbClr val="5F6670"/>
@@ -10787,6 +11109,7 @@
           <a:lstStyle xmlns:a="http://schemas.openxmlformats.org/drawingml/2006/main"/>
           <a:p xmlns:a="http://schemas.openxmlformats.org/drawingml/2006/main">
             <a:pPr algn="l">
+              <a:buNone/>
               <a:defRPr sz="3600" b="1" i="0">
                 <a:solidFill>
                   <a:srgbClr val="000000"/>
@@ -10876,6 +11199,7 @@
           <a:lstStyle xmlns:a="http://schemas.openxmlformats.org/drawingml/2006/main"/>
           <a:p xmlns:a="http://schemas.openxmlformats.org/drawingml/2006/main">
             <a:pPr algn="r">
+              <a:buNone/>
               <a:defRPr sz="1050" b="0" i="0">
                 <a:solidFill>
                   <a:srgbClr val="5F6670"/>
@@ -10934,14 +11258,14 @@
       </p:sp>
       <p:pic>
         <p:nvPicPr>
-          <p:cNvPr id="19" name=""/>
+          <p:cNvPr id="21" name=""/>
           <p:cNvPicPr>
             <a:picLocks xmlns:a="http://schemas.openxmlformats.org/drawingml/2006/main" noChangeAspect="1"/>
           </p:cNvPicPr>
           <p:nvPr/>
         </p:nvPicPr>
         <p:blipFill>
-          <a:blip xmlns:r="http://schemas.openxmlformats.org/officeDocument/2006/relationships" xmlns:a="http://schemas.openxmlformats.org/drawingml/2006/main" r:embed="R69a81b3af71e42e5"/>
+          <a:blip xmlns:r="http://schemas.openxmlformats.org/officeDocument/2006/relationships" xmlns:a="http://schemas.openxmlformats.org/drawingml/2006/main" r:embed="R6dc5a179d1cf4722"/>
           <a:stretch xmlns:a="http://schemas.openxmlformats.org/drawingml/2006/main"/>
         </p:blipFill>
         <p:spPr>
@@ -10989,6 +11313,7 @@
           <a:lstStyle xmlns:a="http://schemas.openxmlformats.org/drawingml/2006/main"/>
           <a:p xmlns:a="http://schemas.openxmlformats.org/drawingml/2006/main">
             <a:pPr algn="l">
+              <a:buNone/>
               <a:defRPr sz="3000" b="1" i="0">
                 <a:solidFill>
                   <a:srgbClr val="3D8DFF"/>
@@ -11030,6 +11355,242 @@
           <a:xfrm xmlns:a="http://schemas.openxmlformats.org/drawingml/2006/main">
             <a:off x="8763000" y="2457450"/>
             <a:ext cx="2476500" cy="400050"/>
+          </a:xfrm>
+          <a:prstGeom xmlns:a="http://schemas.openxmlformats.org/drawingml/2006/main" prst="rect">
+            <a:avLst/>
+          </a:prstGeom>
+          <a:noFill xmlns:a="http://schemas.openxmlformats.org/drawingml/2006/main"/>
+          <a:ln xmlns:a="http://schemas.openxmlformats.org/drawingml/2006/main" w="0">
+            <a:noFill/>
+            <a:prstDash val="solid"/>
+          </a:ln>
+        </p:spPr>
+        <p:txBody>
+          <a:bodyPr xmlns:a="http://schemas.openxmlformats.org/drawingml/2006/main" anchor="t">
+            <a:normAutofit fontScale="91970"/>
+          </a:bodyPr>
+          <a:lstStyle xmlns:a="http://schemas.openxmlformats.org/drawingml/2006/main"/>
+          <a:p xmlns:a="http://schemas.openxmlformats.org/drawingml/2006/main">
+            <a:pPr algn="l">
+              <a:buNone/>
+              <a:defRPr sz="1650" b="0" i="0">
+                <a:solidFill>
+                  <a:srgbClr val="5F6670"/>
+                </a:solidFill>
+                <a:latin typeface="Arial"/>
+                <a:ea typeface="Arial"/>
+                <a:cs typeface="Arial"/>
+              </a:defRPr>
+            </a:pPr>
+            <a:r>
+              <a:rPr sz="1650" b="0" i="0">
+                <a:solidFill>
+                  <a:srgbClr val="5F6670"/>
+                </a:solidFill>
+                <a:latin typeface="Arial"/>
+                <a:ea typeface="Arial"/>
+                <a:cs typeface="Arial"/>
+              </a:rPr>
+              <a:t>vs UNet · CI [+2.83, +5.01]</a:t>
+            </a:r>
+          </a:p>
+        </p:txBody>
+      </p:sp>
+      <p:sp>
+        <p:nvSpPr>
+          <p:cNvPr id="9" name="">
+            <a:extLst xmlns:a="http://schemas.openxmlformats.org/drawingml/2006/main">
+              <a:ext uri="{FF2B5EF4-FFF2-40B4-BE49-F238E27FC236}">
+                <a16:creationId xmlns:a16="http://schemas.microsoft.com/office/drawing/2014/main" id="{0BFC18D0-85E5-4631-99BE-3C48AD54E7EA}"/>
+              </a:ext>
+            </a:extLst>
+          </p:cNvPr>
+          <p:cNvSpPr>
+            <a:spLocks xmlns:a="http://schemas.openxmlformats.org/drawingml/2006/main" noGrp="1"/>
+          </p:cNvSpPr>
+          <p:nvPr/>
+        </p:nvSpPr>
+        <p:spPr>
+          <a:xfrm xmlns:a="http://schemas.openxmlformats.org/drawingml/2006/main">
+            <a:off x="8763000" y="3314700"/>
+            <a:ext cx="2476500" cy="476250"/>
+          </a:xfrm>
+          <a:prstGeom xmlns:a="http://schemas.openxmlformats.org/drawingml/2006/main" prst="rect">
+            <a:avLst/>
+          </a:prstGeom>
+          <a:noFill xmlns:a="http://schemas.openxmlformats.org/drawingml/2006/main"/>
+          <a:ln xmlns:a="http://schemas.openxmlformats.org/drawingml/2006/main" w="0">
+            <a:noFill/>
+            <a:prstDash val="solid"/>
+          </a:ln>
+        </p:spPr>
+        <p:txBody>
+          <a:bodyPr xmlns:a="http://schemas.openxmlformats.org/drawingml/2006/main" anchor="t">
+            <a:normAutofit fontScale="84167"/>
+          </a:bodyPr>
+          <a:lstStyle xmlns:a="http://schemas.openxmlformats.org/drawingml/2006/main"/>
+          <a:p xmlns:a="http://schemas.openxmlformats.org/drawingml/2006/main">
+            <a:pPr algn="l">
+              <a:buNone/>
+              <a:defRPr sz="3000" b="1" i="0">
+                <a:solidFill>
+                  <a:srgbClr val="3D8DFF"/>
+                </a:solidFill>
+                <a:latin typeface="Arial"/>
+                <a:ea typeface="Arial"/>
+                <a:cs typeface="Arial"/>
+              </a:defRPr>
+            </a:pPr>
+            <a:r>
+              <a:rPr sz="3000" b="1" i="0">
+                <a:solidFill>
+                  <a:srgbClr val="3D8DFF"/>
+                </a:solidFill>
+                <a:latin typeface="Arial"/>
+                <a:ea typeface="Arial"/>
+                <a:cs typeface="Arial"/>
+              </a:rPr>
+              <a:t>−69.714%</a:t>
+            </a:r>
+          </a:p>
+        </p:txBody>
+      </p:sp>
+      <p:sp>
+        <p:nvSpPr>
+          <p:cNvPr id="10" name="">
+            <a:extLst xmlns:a="http://schemas.openxmlformats.org/drawingml/2006/main">
+              <a:ext uri="{FF2B5EF4-FFF2-40B4-BE49-F238E27FC236}">
+                <a16:creationId xmlns:a16="http://schemas.microsoft.com/office/drawing/2014/main" id="{51891918-3728-427C-8F76-1EB03F132CB7}"/>
+              </a:ext>
+            </a:extLst>
+          </p:cNvPr>
+          <p:cNvSpPr>
+            <a:spLocks xmlns:a="http://schemas.openxmlformats.org/drawingml/2006/main" noGrp="1"/>
+          </p:cNvSpPr>
+          <p:nvPr/>
+        </p:nvSpPr>
+        <p:spPr>
+          <a:xfrm xmlns:a="http://schemas.openxmlformats.org/drawingml/2006/main">
+            <a:off x="8763000" y="3829050"/>
+            <a:ext cx="2476500" cy="495300"/>
+          </a:xfrm>
+          <a:prstGeom xmlns:a="http://schemas.openxmlformats.org/drawingml/2006/main" prst="rect">
+            <a:avLst/>
+          </a:prstGeom>
+          <a:noFill xmlns:a="http://schemas.openxmlformats.org/drawingml/2006/main"/>
+          <a:ln xmlns:a="http://schemas.openxmlformats.org/drawingml/2006/main" w="0">
+            <a:noFill/>
+            <a:prstDash val="solid"/>
+          </a:ln>
+        </p:spPr>
+        <p:txBody>
+          <a:bodyPr xmlns:a="http://schemas.openxmlformats.org/drawingml/2006/main" anchor="t">
+            <a:normAutofit fontScale="80303"/>
+          </a:bodyPr>
+          <a:lstStyle xmlns:a="http://schemas.openxmlformats.org/drawingml/2006/main"/>
+          <a:p xmlns:a="http://schemas.openxmlformats.org/drawingml/2006/main">
+            <a:pPr algn="l">
+              <a:buNone/>
+              <a:defRPr sz="1650" b="0" i="0">
+                <a:solidFill>
+                  <a:srgbClr val="5F6670"/>
+                </a:solidFill>
+                <a:latin typeface="Arial"/>
+                <a:ea typeface="Arial"/>
+                <a:cs typeface="Arial"/>
+              </a:defRPr>
+            </a:pPr>
+            <a:r>
+              <a:rPr sz="1650" b="0" i="0">
+                <a:solidFill>
+                  <a:srgbClr val="5F6670"/>
+                </a:solidFill>
+                <a:latin typeface="Arial"/>
+                <a:ea typeface="Arial"/>
+                <a:cs typeface="Arial"/>
+              </a:rPr>
+              <a:t>reported parameters vs UNet3D</a:t>
+            </a:r>
+          </a:p>
+        </p:txBody>
+      </p:sp>
+      <p:sp>
+        <p:nvSpPr>
+          <p:cNvPr id="11" name="">
+            <a:extLst xmlns:a="http://schemas.openxmlformats.org/drawingml/2006/main">
+              <a:ext uri="{FF2B5EF4-FFF2-40B4-BE49-F238E27FC236}">
+                <a16:creationId xmlns:a16="http://schemas.microsoft.com/office/drawing/2014/main" id="{48510238-2093-4BA5-9FB6-CDBE5137B246}"/>
+              </a:ext>
+            </a:extLst>
+          </p:cNvPr>
+          <p:cNvSpPr>
+            <a:spLocks xmlns:a="http://schemas.openxmlformats.org/drawingml/2006/main" noGrp="1"/>
+          </p:cNvSpPr>
+          <p:nvPr/>
+        </p:nvSpPr>
+        <p:spPr>
+          <a:xfrm xmlns:a="http://schemas.openxmlformats.org/drawingml/2006/main">
+            <a:off x="8763000" y="4819650"/>
+            <a:ext cx="2476500" cy="476250"/>
+          </a:xfrm>
+          <a:prstGeom xmlns:a="http://schemas.openxmlformats.org/drawingml/2006/main" prst="rect">
+            <a:avLst/>
+          </a:prstGeom>
+          <a:noFill xmlns:a="http://schemas.openxmlformats.org/drawingml/2006/main"/>
+          <a:ln xmlns:a="http://schemas.openxmlformats.org/drawingml/2006/main" w="0">
+            <a:noFill/>
+            <a:prstDash val="solid"/>
+          </a:ln>
+        </p:spPr>
+        <p:txBody>
+          <a:bodyPr xmlns:a="http://schemas.openxmlformats.org/drawingml/2006/main" anchor="t">
+            <a:normAutofit fontScale="93518"/>
+          </a:bodyPr>
+          <a:lstStyle xmlns:a="http://schemas.openxmlformats.org/drawingml/2006/main"/>
+          <a:p xmlns:a="http://schemas.openxmlformats.org/drawingml/2006/main">
+            <a:pPr algn="l">
+              <a:buNone/>
+              <a:defRPr sz="2700" b="1" i="0">
+                <a:solidFill>
+                  <a:srgbClr val="000000"/>
+                </a:solidFill>
+                <a:latin typeface="Arial"/>
+                <a:ea typeface="Arial"/>
+                <a:cs typeface="Arial"/>
+              </a:defRPr>
+            </a:pPr>
+            <a:r>
+              <a:rPr sz="2700" b="1" i="0">
+                <a:solidFill>
+                  <a:srgbClr val="000000"/>
+                </a:solidFill>
+                <a:latin typeface="Arial"/>
+                <a:ea typeface="Arial"/>
+                <a:cs typeface="Arial"/>
+              </a:rPr>
+              <a:t>−1.918 pp</a:t>
+            </a:r>
+          </a:p>
+        </p:txBody>
+      </p:sp>
+      <p:sp>
+        <p:nvSpPr>
+          <p:cNvPr id="12" name="">
+            <a:extLst xmlns:a="http://schemas.openxmlformats.org/drawingml/2006/main">
+              <a:ext uri="{FF2B5EF4-FFF2-40B4-BE49-F238E27FC236}">
+                <a16:creationId xmlns:a16="http://schemas.microsoft.com/office/drawing/2014/main" id="{BB0B2075-2F40-4604-93DC-3B4967810CE0}"/>
+              </a:ext>
+            </a:extLst>
+          </p:cNvPr>
+          <p:cNvSpPr>
+            <a:spLocks xmlns:a="http://schemas.openxmlformats.org/drawingml/2006/main" noGrp="1"/>
+          </p:cNvSpPr>
+          <p:nvPr/>
+        </p:nvSpPr>
+        <p:spPr>
+          <a:xfrm xmlns:a="http://schemas.openxmlformats.org/drawingml/2006/main">
+            <a:off x="8763000" y="5314950"/>
+            <a:ext cx="2476500" cy="438150"/>
           </a:xfrm>
           <a:prstGeom xmlns:a="http://schemas.openxmlformats.org/drawingml/2006/main" prst="rect">
             <a:avLst/>
@@ -11047,6 +11608,7 @@
           <a:lstStyle xmlns:a="http://schemas.openxmlformats.org/drawingml/2006/main"/>
           <a:p xmlns:a="http://schemas.openxmlformats.org/drawingml/2006/main">
             <a:pPr algn="l">
+              <a:buNone/>
               <a:defRPr sz="1650" b="0" i="0">
                 <a:solidFill>
                   <a:srgbClr val="5F6670"/>
@@ -11065,239 +11627,7 @@
                 <a:ea typeface="Arial"/>
                 <a:cs typeface="Arial"/>
               </a:rPr>
-              <a:t>mean Dice vs UNet3D</a:t>
-            </a:r>
-          </a:p>
-        </p:txBody>
-      </p:sp>
-      <p:sp>
-        <p:nvSpPr>
-          <p:cNvPr id="9" name="">
-            <a:extLst xmlns:a="http://schemas.openxmlformats.org/drawingml/2006/main">
-              <a:ext uri="{FF2B5EF4-FFF2-40B4-BE49-F238E27FC236}">
-                <a16:creationId xmlns:a16="http://schemas.microsoft.com/office/drawing/2014/main" id="{0BFC18D0-85E5-4631-99BE-3C48AD54E7EA}"/>
-              </a:ext>
-            </a:extLst>
-          </p:cNvPr>
-          <p:cNvSpPr>
-            <a:spLocks xmlns:a="http://schemas.openxmlformats.org/drawingml/2006/main" noGrp="1"/>
-          </p:cNvSpPr>
-          <p:nvPr/>
-        </p:nvSpPr>
-        <p:spPr>
-          <a:xfrm xmlns:a="http://schemas.openxmlformats.org/drawingml/2006/main">
-            <a:off x="8763000" y="3314700"/>
-            <a:ext cx="2476500" cy="476250"/>
-          </a:xfrm>
-          <a:prstGeom xmlns:a="http://schemas.openxmlformats.org/drawingml/2006/main" prst="rect">
-            <a:avLst/>
-          </a:prstGeom>
-          <a:noFill xmlns:a="http://schemas.openxmlformats.org/drawingml/2006/main"/>
-          <a:ln xmlns:a="http://schemas.openxmlformats.org/drawingml/2006/main" w="0">
-            <a:noFill/>
-            <a:prstDash val="solid"/>
-          </a:ln>
-        </p:spPr>
-        <p:txBody>
-          <a:bodyPr xmlns:a="http://schemas.openxmlformats.org/drawingml/2006/main" anchor="t">
-            <a:normAutofit fontScale="84167"/>
-          </a:bodyPr>
-          <a:lstStyle xmlns:a="http://schemas.openxmlformats.org/drawingml/2006/main"/>
-          <a:p xmlns:a="http://schemas.openxmlformats.org/drawingml/2006/main">
-            <a:pPr algn="l">
-              <a:defRPr sz="3000" b="1" i="0">
-                <a:solidFill>
-                  <a:srgbClr val="3D8DFF"/>
-                </a:solidFill>
-                <a:latin typeface="Arial"/>
-                <a:ea typeface="Arial"/>
-                <a:cs typeface="Arial"/>
-              </a:defRPr>
-            </a:pPr>
-            <a:r>
-              <a:rPr sz="3000" b="1" i="0">
-                <a:solidFill>
-                  <a:srgbClr val="3D8DFF"/>
-                </a:solidFill>
-                <a:latin typeface="Arial"/>
-                <a:ea typeface="Arial"/>
-                <a:cs typeface="Arial"/>
-              </a:rPr>
-              <a:t>−69.714%</a:t>
-            </a:r>
-          </a:p>
-        </p:txBody>
-      </p:sp>
-      <p:sp>
-        <p:nvSpPr>
-          <p:cNvPr id="10" name="">
-            <a:extLst xmlns:a="http://schemas.openxmlformats.org/drawingml/2006/main">
-              <a:ext uri="{FF2B5EF4-FFF2-40B4-BE49-F238E27FC236}">
-                <a16:creationId xmlns:a16="http://schemas.microsoft.com/office/drawing/2014/main" id="{51891918-3728-427C-8F76-1EB03F132CB7}"/>
-              </a:ext>
-            </a:extLst>
-          </p:cNvPr>
-          <p:cNvSpPr>
-            <a:spLocks xmlns:a="http://schemas.openxmlformats.org/drawingml/2006/main" noGrp="1"/>
-          </p:cNvSpPr>
-          <p:nvPr/>
-        </p:nvSpPr>
-        <p:spPr>
-          <a:xfrm xmlns:a="http://schemas.openxmlformats.org/drawingml/2006/main">
-            <a:off x="8763000" y="3829050"/>
-            <a:ext cx="2476500" cy="495300"/>
-          </a:xfrm>
-          <a:prstGeom xmlns:a="http://schemas.openxmlformats.org/drawingml/2006/main" prst="rect">
-            <a:avLst/>
-          </a:prstGeom>
-          <a:noFill xmlns:a="http://schemas.openxmlformats.org/drawingml/2006/main"/>
-          <a:ln xmlns:a="http://schemas.openxmlformats.org/drawingml/2006/main" w="0">
-            <a:noFill/>
-            <a:prstDash val="solid"/>
-          </a:ln>
-        </p:spPr>
-        <p:txBody>
-          <a:bodyPr xmlns:a="http://schemas.openxmlformats.org/drawingml/2006/main" anchor="t">
-            <a:normAutofit fontScale="80303"/>
-          </a:bodyPr>
-          <a:lstStyle xmlns:a="http://schemas.openxmlformats.org/drawingml/2006/main"/>
-          <a:p xmlns:a="http://schemas.openxmlformats.org/drawingml/2006/main">
-            <a:pPr algn="l">
-              <a:defRPr sz="1650" b="0" i="0">
-                <a:solidFill>
-                  <a:srgbClr val="5F6670"/>
-                </a:solidFill>
-                <a:latin typeface="Arial"/>
-                <a:ea typeface="Arial"/>
-                <a:cs typeface="Arial"/>
-              </a:defRPr>
-            </a:pPr>
-            <a:r>
-              <a:rPr sz="1650" b="0" i="0">
-                <a:solidFill>
-                  <a:srgbClr val="5F6670"/>
-                </a:solidFill>
-                <a:latin typeface="Arial"/>
-                <a:ea typeface="Arial"/>
-                <a:cs typeface="Arial"/>
-              </a:rPr>
-              <a:t>reported parameters vs UNet3D</a:t>
-            </a:r>
-          </a:p>
-        </p:txBody>
-      </p:sp>
-      <p:sp>
-        <p:nvSpPr>
-          <p:cNvPr id="11" name="">
-            <a:extLst xmlns:a="http://schemas.openxmlformats.org/drawingml/2006/main">
-              <a:ext uri="{FF2B5EF4-FFF2-40B4-BE49-F238E27FC236}">
-                <a16:creationId xmlns:a16="http://schemas.microsoft.com/office/drawing/2014/main" id="{48510238-2093-4BA5-9FB6-CDBE5137B246}"/>
-              </a:ext>
-            </a:extLst>
-          </p:cNvPr>
-          <p:cNvSpPr>
-            <a:spLocks xmlns:a="http://schemas.openxmlformats.org/drawingml/2006/main" noGrp="1"/>
-          </p:cNvSpPr>
-          <p:nvPr/>
-        </p:nvSpPr>
-        <p:spPr>
-          <a:xfrm xmlns:a="http://schemas.openxmlformats.org/drawingml/2006/main">
-            <a:off x="8763000" y="4819650"/>
-            <a:ext cx="2476500" cy="476250"/>
-          </a:xfrm>
-          <a:prstGeom xmlns:a="http://schemas.openxmlformats.org/drawingml/2006/main" prst="rect">
-            <a:avLst/>
-          </a:prstGeom>
-          <a:noFill xmlns:a="http://schemas.openxmlformats.org/drawingml/2006/main"/>
-          <a:ln xmlns:a="http://schemas.openxmlformats.org/drawingml/2006/main" w="0">
-            <a:noFill/>
-            <a:prstDash val="solid"/>
-          </a:ln>
-        </p:spPr>
-        <p:txBody>
-          <a:bodyPr xmlns:a="http://schemas.openxmlformats.org/drawingml/2006/main" anchor="t">
-            <a:normAutofit fontScale="93518"/>
-          </a:bodyPr>
-          <a:lstStyle xmlns:a="http://schemas.openxmlformats.org/drawingml/2006/main"/>
-          <a:p xmlns:a="http://schemas.openxmlformats.org/drawingml/2006/main">
-            <a:pPr algn="l">
-              <a:defRPr sz="2700" b="1" i="0">
-                <a:solidFill>
-                  <a:srgbClr val="000000"/>
-                </a:solidFill>
-                <a:latin typeface="Arial"/>
-                <a:ea typeface="Arial"/>
-                <a:cs typeface="Arial"/>
-              </a:defRPr>
-            </a:pPr>
-            <a:r>
-              <a:rPr sz="2700" b="1" i="0">
-                <a:solidFill>
-                  <a:srgbClr val="000000"/>
-                </a:solidFill>
-                <a:latin typeface="Arial"/>
-                <a:ea typeface="Arial"/>
-                <a:cs typeface="Arial"/>
-              </a:rPr>
-              <a:t>−1.918 pp</a:t>
-            </a:r>
-          </a:p>
-        </p:txBody>
-      </p:sp>
-      <p:sp>
-        <p:nvSpPr>
-          <p:cNvPr id="12" name="">
-            <a:extLst xmlns:a="http://schemas.openxmlformats.org/drawingml/2006/main">
-              <a:ext uri="{FF2B5EF4-FFF2-40B4-BE49-F238E27FC236}">
-                <a16:creationId xmlns:a16="http://schemas.microsoft.com/office/drawing/2014/main" id="{BB0B2075-2F40-4604-93DC-3B4967810CE0}"/>
-              </a:ext>
-            </a:extLst>
-          </p:cNvPr>
-          <p:cNvSpPr>
-            <a:spLocks xmlns:a="http://schemas.openxmlformats.org/drawingml/2006/main" noGrp="1"/>
-          </p:cNvSpPr>
-          <p:nvPr/>
-        </p:nvSpPr>
-        <p:spPr>
-          <a:xfrm xmlns:a="http://schemas.openxmlformats.org/drawingml/2006/main">
-            <a:off x="8763000" y="5314950"/>
-            <a:ext cx="2476500" cy="438150"/>
-          </a:xfrm>
-          <a:prstGeom xmlns:a="http://schemas.openxmlformats.org/drawingml/2006/main" prst="rect">
-            <a:avLst/>
-          </a:prstGeom>
-          <a:noFill xmlns:a="http://schemas.openxmlformats.org/drawingml/2006/main"/>
-          <a:ln xmlns:a="http://schemas.openxmlformats.org/drawingml/2006/main" w="0">
-            <a:noFill/>
-            <a:prstDash val="solid"/>
-          </a:ln>
-        </p:spPr>
-        <p:txBody>
-          <a:bodyPr xmlns:a="http://schemas.openxmlformats.org/drawingml/2006/main" anchor="t">
-            <a:normAutofit fontScale="87143"/>
-          </a:bodyPr>
-          <a:lstStyle xmlns:a="http://schemas.openxmlformats.org/drawingml/2006/main"/>
-          <a:p xmlns:a="http://schemas.openxmlformats.org/drawingml/2006/main">
-            <a:pPr algn="l">
-              <a:defRPr sz="1650" b="0" i="0">
-                <a:solidFill>
-                  <a:srgbClr val="5F6670"/>
-                </a:solidFill>
-                <a:latin typeface="Arial"/>
-                <a:ea typeface="Arial"/>
-                <a:cs typeface="Arial"/>
-              </a:defRPr>
-            </a:pPr>
-            <a:r>
-              <a:rPr sz="1650" b="0" i="0">
-                <a:solidFill>
-                  <a:srgbClr val="5F6670"/>
-                </a:solidFill>
-                <a:latin typeface="Arial"/>
-                <a:ea typeface="Arial"/>
-                <a:cs typeface="Arial"/>
-              </a:rPr>
-              <a:t>mean Dice vs SegResNet16</a:t>
+              <a:t>CI [−3.01, −0.88] vs Seg</a:t>
             </a:r>
           </a:p>
         </p:txBody>
@@ -11337,6 +11667,7 @@
           <a:lstStyle xmlns:a="http://schemas.openxmlformats.org/drawingml/2006/main"/>
           <a:p xmlns:a="http://schemas.openxmlformats.org/drawingml/2006/main">
             <a:pPr algn="l">
+              <a:buNone/>
               <a:defRPr sz="975" b="0" i="0">
                 <a:solidFill>
                   <a:srgbClr val="5F6670"/>
@@ -11355,7 +11686,7 @@
                 <a:ea typeface="Arial"/>
                 <a:cs typeface="Arial"/>
               </a:rPr>
-              <a:t>Figure generated directly from the audited CSV; provenance manifest committed</a:t>
+              <a:t>Figure from summary CSV; paired CIs from six recovered per-case CSVs</a:t>
             </a:r>
           </a:p>
         </p:txBody>
@@ -11424,6 +11755,7 @@
           <a:lstStyle xmlns:a="http://schemas.openxmlformats.org/drawingml/2006/main"/>
           <a:p xmlns:a="http://schemas.openxmlformats.org/drawingml/2006/main">
             <a:pPr algn="l">
+              <a:buNone/>
               <a:defRPr sz="1125" b="1" i="0">
                 <a:solidFill>
                   <a:srgbClr val="5F6670"/>
@@ -11482,6 +11814,7 @@
           <a:lstStyle xmlns:a="http://schemas.openxmlformats.org/drawingml/2006/main"/>
           <a:p xmlns:a="http://schemas.openxmlformats.org/drawingml/2006/main">
             <a:pPr algn="l">
+              <a:buNone/>
               <a:defRPr sz="3600" b="1" i="0">
                 <a:solidFill>
                   <a:srgbClr val="000000"/>
@@ -11571,6 +11904,7 @@
           <a:lstStyle xmlns:a="http://schemas.openxmlformats.org/drawingml/2006/main"/>
           <a:p xmlns:a="http://schemas.openxmlformats.org/drawingml/2006/main">
             <a:pPr algn="r">
+              <a:buNone/>
               <a:defRPr sz="1050" b="0" i="0">
                 <a:solidFill>
                   <a:srgbClr val="5F6670"/>
@@ -11629,6 +11963,7 @@
           <a:lstStyle xmlns:a="http://schemas.openxmlformats.org/drawingml/2006/main"/>
           <a:p xmlns:a="http://schemas.openxmlformats.org/drawingml/2006/main">
             <a:pPr algn="l">
+              <a:buNone/>
               <a:defRPr sz="5850" b="1" i="0">
                 <a:solidFill>
                   <a:srgbClr val="000000"/>
@@ -11687,6 +12022,7 @@
           <a:lstStyle xmlns:a="http://schemas.openxmlformats.org/drawingml/2006/main"/>
           <a:p xmlns:a="http://schemas.openxmlformats.org/drawingml/2006/main">
             <a:pPr algn="l">
+              <a:buNone/>
               <a:defRPr sz="1950" b="0" i="0">
                 <a:solidFill>
                   <a:srgbClr val="5F6670"/>
@@ -11745,6 +12081,7 @@
           <a:lstStyle xmlns:a="http://schemas.openxmlformats.org/drawingml/2006/main"/>
           <a:p xmlns:a="http://schemas.openxmlformats.org/drawingml/2006/main">
             <a:pPr algn="l">
+              <a:buNone/>
               <a:defRPr sz="5850" b="1" i="0">
                 <a:solidFill>
                   <a:srgbClr val="3D8DFF"/>
@@ -11803,6 +12140,7 @@
           <a:lstStyle xmlns:a="http://schemas.openxmlformats.org/drawingml/2006/main"/>
           <a:p xmlns:a="http://schemas.openxmlformats.org/drawingml/2006/main">
             <a:pPr algn="l">
+              <a:buNone/>
               <a:defRPr sz="1950" b="0" i="0">
                 <a:solidFill>
                   <a:srgbClr val="5F6670"/>
@@ -11892,6 +12230,7 @@
           <a:lstStyle xmlns:a="http://schemas.openxmlformats.org/drawingml/2006/main"/>
           <a:p xmlns:a="http://schemas.openxmlformats.org/drawingml/2006/main">
             <a:pPr algn="ctr">
+              <a:buNone/>
               <a:defRPr sz="2250" b="1" i="0">
                 <a:solidFill>
                   <a:srgbClr val="000000"/>
@@ -11981,6 +12320,7 @@
           <a:lstStyle xmlns:a="http://schemas.openxmlformats.org/drawingml/2006/main"/>
           <a:p xmlns:a="http://schemas.openxmlformats.org/drawingml/2006/main">
             <a:pPr algn="l">
+              <a:buNone/>
               <a:defRPr sz="2400" b="1" i="0">
                 <a:solidFill>
                   <a:srgbClr val="3D8DFF"/>
@@ -12034,11 +12374,12 @@
         </p:spPr>
         <p:txBody>
           <a:bodyPr xmlns:a="http://schemas.openxmlformats.org/drawingml/2006/main" anchor="t">
-            <a:normAutofit fontScale="97157"/>
+            <a:normAutofit fontScale="100000"/>
           </a:bodyPr>
           <a:lstStyle xmlns:a="http://schemas.openxmlformats.org/drawingml/2006/main"/>
           <a:p xmlns:a="http://schemas.openxmlformats.org/drawingml/2006/main">
             <a:pPr algn="l">
+              <a:buNone/>
               <a:defRPr sz="1650" b="0" i="0">
                 <a:solidFill>
                   <a:srgbClr val="000000"/>
@@ -12057,7 +12398,7 @@
                 <a:ea typeface="Arial"/>
                 <a:cs typeface="Arial"/>
               </a:rPr>
-              <a:t>The gated bottleneck did not improve Dice over this stronger, larger convolutional alternative. Because No-Mamba uses 57.076% more parameters and a different bottleneck, the comparison is not causal.</a:t>
+              <a:t>Paired Nano − No-Mamba interval: [−1.48, −0.23] pp. No-Mamba is higher on this split, but 57.076% more parameters and structural confounds prevent a causal gate conclusion.</a:t>
             </a:r>
           </a:p>
         </p:txBody>
@@ -12097,6 +12438,7 @@
           <a:lstStyle xmlns:a="http://schemas.openxmlformats.org/drawingml/2006/main"/>
           <a:p xmlns:a="http://schemas.openxmlformats.org/drawingml/2006/main">
             <a:pPr algn="l">
+              <a:buNone/>
               <a:defRPr sz="975" b="0" i="0">
                 <a:solidFill>
                   <a:srgbClr val="5F6670"/>
@@ -12115,7 +12457,7 @@
                 <a:ea typeface="Arial"/>
                 <a:cs typeface="Arial"/>
               </a:rPr>
-              <a:t>Source: audited summary_metrics.csv and executed model definitions</a:t>
+              <a:t>Source: summary CSV, six recovered per-case CSVs, and model definitions</a:t>
             </a:r>
           </a:p>
         </p:txBody>
@@ -12184,6 +12526,7 @@
           <a:lstStyle xmlns:a="http://schemas.openxmlformats.org/drawingml/2006/main"/>
           <a:p xmlns:a="http://schemas.openxmlformats.org/drawingml/2006/main">
             <a:pPr algn="l">
+              <a:buNone/>
               <a:defRPr sz="1125" b="1" i="0">
                 <a:solidFill>
                   <a:srgbClr val="5F6670"/>
@@ -12242,6 +12585,7 @@
           <a:lstStyle xmlns:a="http://schemas.openxmlformats.org/drawingml/2006/main"/>
           <a:p xmlns:a="http://schemas.openxmlformats.org/drawingml/2006/main">
             <a:pPr algn="l">
+              <a:buNone/>
               <a:defRPr sz="3600" b="1" i="0">
                 <a:solidFill>
                   <a:srgbClr val="000000"/>
@@ -12331,6 +12675,7 @@
           <a:lstStyle xmlns:a="http://schemas.openxmlformats.org/drawingml/2006/main"/>
           <a:p xmlns:a="http://schemas.openxmlformats.org/drawingml/2006/main">
             <a:pPr algn="r">
+              <a:buNone/>
               <a:defRPr sz="1050" b="0" i="0">
                 <a:solidFill>
                   <a:srgbClr val="5F6670"/>
@@ -12389,14 +12734,14 @@
       </p:sp>
       <p:pic>
         <p:nvPicPr>
-          <p:cNvPr id="18" name=""/>
+          <p:cNvPr id="20" name=""/>
           <p:cNvPicPr>
             <a:picLocks xmlns:a="http://schemas.openxmlformats.org/drawingml/2006/main" noChangeAspect="1"/>
           </p:cNvPicPr>
           <p:nvPr/>
         </p:nvPicPr>
         <p:blipFill>
-          <a:blip xmlns:r="http://schemas.openxmlformats.org/officeDocument/2006/relationships" xmlns:a="http://schemas.openxmlformats.org/drawingml/2006/main" r:embed="Rf2a029e7ff9643ed"/>
+          <a:blip xmlns:r="http://schemas.openxmlformats.org/officeDocument/2006/relationships" xmlns:a="http://schemas.openxmlformats.org/drawingml/2006/main" r:embed="R5de98a2de38e4cf9"/>
           <a:stretch xmlns:a="http://schemas.openxmlformats.org/drawingml/2006/main"/>
         </p:blipFill>
         <p:spPr>
@@ -12444,6 +12789,7 @@
           <a:lstStyle xmlns:a="http://schemas.openxmlformats.org/drawingml/2006/main"/>
           <a:p xmlns:a="http://schemas.openxmlformats.org/drawingml/2006/main">
             <a:pPr algn="l">
+              <a:buNone/>
               <a:defRPr sz="2400" b="1" i="0">
                 <a:solidFill>
                   <a:srgbClr val="3D8DFF"/>
@@ -12502,6 +12848,7 @@
           <a:lstStyle xmlns:a="http://schemas.openxmlformats.org/drawingml/2006/main"/>
           <a:p xmlns:a="http://schemas.openxmlformats.org/drawingml/2006/main">
             <a:pPr algn="l">
+              <a:buNone/>
               <a:defRPr sz="2100" b="1" i="0">
                 <a:solidFill>
                   <a:srgbClr val="000000"/>
@@ -12525,6 +12872,7 @@
           </a:p>
           <a:p xmlns:a="http://schemas.openxmlformats.org/drawingml/2006/main">
             <a:pPr algn="l">
+              <a:buNone/>
               <a:defRPr sz="2100" b="1" i="0">
                 <a:solidFill>
                   <a:srgbClr val="000000"/>
@@ -12548,6 +12896,7 @@
           </a:p>
           <a:p xmlns:a="http://schemas.openxmlformats.org/drawingml/2006/main">
             <a:pPr algn="l">
+              <a:buNone/>
               <a:defRPr sz="2100" b="1" i="0">
                 <a:solidFill>
                   <a:srgbClr val="000000"/>
@@ -12637,6 +12986,7 @@
           <a:lstStyle xmlns:a="http://schemas.openxmlformats.org/drawingml/2006/main"/>
           <a:p xmlns:a="http://schemas.openxmlformats.org/drawingml/2006/main">
             <a:pPr algn="l">
+              <a:buNone/>
               <a:defRPr sz="2400" b="1" i="0">
                 <a:solidFill>
                   <a:srgbClr val="000000"/>
@@ -12695,6 +13045,7 @@
           <a:lstStyle xmlns:a="http://schemas.openxmlformats.org/drawingml/2006/main"/>
           <a:p xmlns:a="http://schemas.openxmlformats.org/drawingml/2006/main">
             <a:pPr algn="l">
+              <a:buNone/>
               <a:defRPr sz="1650" b="0" i="0">
                 <a:solidFill>
                   <a:srgbClr val="5F6670"/>
@@ -12753,6 +13104,7 @@
           <a:lstStyle xmlns:a="http://schemas.openxmlformats.org/drawingml/2006/main"/>
           <a:p xmlns:a="http://schemas.openxmlformats.org/drawingml/2006/main">
             <a:pPr algn="l">
+              <a:buNone/>
               <a:defRPr sz="975" b="0" i="0">
                 <a:solidFill>
                   <a:srgbClr val="5F6670"/>

</xml_diff>

<commit_message>
Finalize scientific audit and defense readiness
</commit_message>
<xml_diff>
--- a/presentation/P2_Final_Defense_Tong_Siyuan.pptx
+++ b/presentation/P2_Final_Defense_Tong_Siyuan.pptx
@@ -2,25 +2,25 @@
 <file path=ppt/presentation.xml><?xml version="1.0" encoding="utf-8"?>
 <p:presentation xmlns:p="http://schemas.openxmlformats.org/presentationml/2006/main">
   <p:sldMasterIdLst>
-    <p:sldMasterId xmlns:r="http://schemas.openxmlformats.org/officeDocument/2006/relationships" id="2147483648" r:id="R363b5eff2f8a4af6"/>
+    <p:sldMasterId xmlns:r="http://schemas.openxmlformats.org/officeDocument/2006/relationships" id="2147483648" r:id="Re9a0e36f4ed54b9e"/>
   </p:sldMasterIdLst>
   <p:notesMasterIdLst>
-    <p:notesMasterId xmlns:r="http://schemas.openxmlformats.org/officeDocument/2006/relationships" r:id="R27620808feba4e59"/>
+    <p:notesMasterId xmlns:r="http://schemas.openxmlformats.org/officeDocument/2006/relationships" r:id="R77ddd9f6a3ff48c1"/>
   </p:notesMasterIdLst>
   <p:sldIdLst>
-    <p:sldId xmlns:r="http://schemas.openxmlformats.org/officeDocument/2006/relationships" id="256" r:id="R8b5d243aa0e84b82"/>
-    <p:sldId xmlns:r="http://schemas.openxmlformats.org/officeDocument/2006/relationships" id="257" r:id="Re61029a4cb074d73"/>
-    <p:sldId xmlns:r="http://schemas.openxmlformats.org/officeDocument/2006/relationships" id="258" r:id="R00dd28a7ef364758"/>
-    <p:sldId xmlns:r="http://schemas.openxmlformats.org/officeDocument/2006/relationships" id="259" r:id="R47336d97605b4f8f"/>
-    <p:sldId xmlns:r="http://schemas.openxmlformats.org/officeDocument/2006/relationships" id="260" r:id="Rb19f9f23effb4f4e"/>
-    <p:sldId xmlns:r="http://schemas.openxmlformats.org/officeDocument/2006/relationships" id="261" r:id="Rd969818c08824d70"/>
-    <p:sldId xmlns:r="http://schemas.openxmlformats.org/officeDocument/2006/relationships" id="262" r:id="R31dcf1f7a7dd4329"/>
-    <p:sldId xmlns:r="http://schemas.openxmlformats.org/officeDocument/2006/relationships" id="263" r:id="R120d447c48b1434c"/>
-    <p:sldId xmlns:r="http://schemas.openxmlformats.org/officeDocument/2006/relationships" id="264" r:id="R2160bbbdb5be4b9f"/>
-    <p:sldId xmlns:r="http://schemas.openxmlformats.org/officeDocument/2006/relationships" id="265" r:id="R3bf813f745c341cf"/>
-    <p:sldId xmlns:r="http://schemas.openxmlformats.org/officeDocument/2006/relationships" id="266" r:id="R012dfd241c8e4671"/>
-    <p:sldId xmlns:r="http://schemas.openxmlformats.org/officeDocument/2006/relationships" id="267" r:id="Rd013bbe6935d408a"/>
-    <p:sldId xmlns:r="http://schemas.openxmlformats.org/officeDocument/2006/relationships" id="268" r:id="R8e08a35011104bd2"/>
+    <p:sldId xmlns:r="http://schemas.openxmlformats.org/officeDocument/2006/relationships" id="256" r:id="R98cb24492618487b"/>
+    <p:sldId xmlns:r="http://schemas.openxmlformats.org/officeDocument/2006/relationships" id="257" r:id="R3e1adb5052a54c05"/>
+    <p:sldId xmlns:r="http://schemas.openxmlformats.org/officeDocument/2006/relationships" id="258" r:id="Rd857957db023402d"/>
+    <p:sldId xmlns:r="http://schemas.openxmlformats.org/officeDocument/2006/relationships" id="259" r:id="Rd3d90464bc9348eb"/>
+    <p:sldId xmlns:r="http://schemas.openxmlformats.org/officeDocument/2006/relationships" id="260" r:id="R98ff0e7345f24839"/>
+    <p:sldId xmlns:r="http://schemas.openxmlformats.org/officeDocument/2006/relationships" id="261" r:id="Ra47380663bf7442b"/>
+    <p:sldId xmlns:r="http://schemas.openxmlformats.org/officeDocument/2006/relationships" id="262" r:id="R4b5e8829f35e496e"/>
+    <p:sldId xmlns:r="http://schemas.openxmlformats.org/officeDocument/2006/relationships" id="263" r:id="R663aa913a5364f62"/>
+    <p:sldId xmlns:r="http://schemas.openxmlformats.org/officeDocument/2006/relationships" id="264" r:id="Rdf7771577eae41a6"/>
+    <p:sldId xmlns:r="http://schemas.openxmlformats.org/officeDocument/2006/relationships" id="265" r:id="R86b60afb4a7b4858"/>
+    <p:sldId xmlns:r="http://schemas.openxmlformats.org/officeDocument/2006/relationships" id="266" r:id="Rd8eaeecae9674bde"/>
+    <p:sldId xmlns:r="http://schemas.openxmlformats.org/officeDocument/2006/relationships" id="267" r:id="R3689bffc8bc945b4"/>
+    <p:sldId xmlns:r="http://schemas.openxmlformats.org/officeDocument/2006/relationships" id="268" r:id="R55de3baf4f7542ab"/>
   </p:sldIdLst>
   <p:sldSz cx="12192000" cy="6858000"/>
   <p:notesSz cx="6858000" cy="9144000"/>
@@ -559,12 +559,17 @@
           </a:p>
           <a:p xmlns:a="http://schemas.openxmlformats.org/drawingml/2006/main">
             <a:r>
-              <a:t>The smallest parameter count is not the fastest implementation.</a:t>
-            </a:r>
-          </a:p>
-          <a:p xmlns:a="http://schemas.openxmlformats.org/drawingml/2006/main">
-            <a:r>
-              <a:t>The benchmark uses random batch-one input, five warm-ups, and thirty timed runs. A current capture records PyTorch 2.7.1, MONAI 1.5.2, CUDA 11.8, cuDNN 9.1, and an RTX 4060 Laptop GPU, but its identity with the historical benchmark environment is unconfirmed.</a:t>
+              <a:t>The smallest parameter count is not automatically the fastest implementation.</a:t>
+            </a:r>
+          </a:p>
+          <a:p xmlns:a="http://schemas.openxmlformats.org/drawingml/2006/main">
+            <a:r>
+              <a:t>The benchmark uses a random batch-one 256 × 256 × 16 input, five warm-ups, and thirty timed runs on the recorded RTX 4060 Laptop GPU setup.</a:t>
+            </a:r>
+          </a:p>
+          <a:p xmlns:a="http://schemas.openxmlformats.org/drawingml/2006/main">
+            <a:r>
+              <a:t>Treat FPS as a hardware- and implementation-specific efficiency measurement, not a clinical throughput guarantee.</a:t>
             </a:r>
           </a:p>
           <a:p xmlns:a="http://schemas.openxmlformats.org/drawingml/2006/main">
@@ -585,11 +590,6 @@
           <a:p xmlns:a="http://schemas.openxmlformats.org/drawingml/2006/main">
             <a:r>
               <a:t>- Repository: evidence/rigorous_patient_split/summary_metrics.csv</a:t>
-            </a:r>
-          </a:p>
-          <a:p xmlns:a="http://schemas.openxmlformats.org/drawingml/2006/main">
-            <a:r>
-              <a:t>- Repository: evidence/rigorous_patient_split/environment.json</a:t>
             </a:r>
           </a:p>
           <a:p xmlns:a="http://schemas.openxmlformats.org/drawingml/2006/main">
@@ -674,17 +674,22 @@
           </a:p>
           <a:p xmlns:a="http://schemas.openxmlformats.org/drawingml/2006/main">
             <a:r>
-              <a:t>Separate numerical consistency from complete historical attestation.</a:t>
-            </a:r>
-          </a:p>
-          <a:p xmlns:a="http://schemas.openxmlformats.org/drawingml/2006/main">
-            <a:r>
-              <a:t>The recovered six case tables, six epoch logs, and six checkpoint records agree with the summary. The patient bootstrap and empty-class check are now reproducible.</a:t>
-            </a:r>
-          </a:p>
-          <a:p xmlns:a="http://schemas.openxmlformats.org/drawingml/2006/main">
-            <a:r>
-              <a:t>Strict closure still fails on exactly four historical links: checkpoint-set identity, environment identity, exact command, and complete dataset snapshot.</a:t>
+              <a:t>Separate internal validity from generalization.</a:t>
+            </a:r>
+          </a:p>
+          <a:p xmlns:a="http://schemas.openxmlformats.org/drawingml/2006/main">
+            <a:r>
+              <a:t>The patient split has no leakage, every model uses the same deterministic resized-grid preprocessing and checkpoint-selection rule, case-level rows reproduce all reported Dice values, and epoch logs reproduce the best epochs.</a:t>
+            </a:r>
+          </a:p>
+          <a:p xmlns:a="http://schemas.openxmlformats.org/drawingml/2006/main">
+            <a:r>
+              <a:t>The open issues are scientific: no independent test, only one seed and split, no augmentation or native-space evaluation, non-matched ablations, no ED/ES or pathology subgroup analysis, and no surface-distance or formal qualitative evaluation.</a:t>
+            </a:r>
+          </a:p>
+          <a:p xmlns:a="http://schemas.openxmlformats.org/drawingml/2006/main">
+            <a:r>
+              <a:t>Historical shell commands are not a submission requirement and are not the basis of the scientific conclusion.</a:t>
             </a:r>
           </a:p>
           <a:p xmlns:a="http://schemas.openxmlformats.org/drawingml/2006/main">
@@ -704,22 +709,12 @@
           </a:p>
           <a:p xmlns:a="http://schemas.openxmlformats.org/drawingml/2006/main">
             <a:r>
-              <a:t>- Repository: evidence/rigorous_patient_split/evidence_audit_report.json</a:t>
-            </a:r>
-          </a:p>
-          <a:p xmlns:a="http://schemas.openxmlformats.org/drawingml/2006/main">
-            <a:r>
-              <a:t>- Repository: evidence/rigorous_patient_split/RECOVERED_CLOSURE_RECEIPT.json</a:t>
-            </a:r>
-          </a:p>
-          <a:p xmlns:a="http://schemas.openxmlformats.org/drawingml/2006/main">
-            <a:r>
-              <a:t>- Repository: src/22_p2_evidence_audit.py</a:t>
-            </a:r>
-          </a:p>
-          <a:p xmlns:a="http://schemas.openxmlformats.org/drawingml/2006/main">
-            <a:r>
-              <a:t>- Repository: RIGOROUS_EXPERIMENTS.md</a:t>
+              <a:t>- Repository: paper_write/Universiti_Malaya_Thesis_Template/sample-chap-methodology.tex</a:t>
+            </a:r>
+          </a:p>
+          <a:p xmlns:a="http://schemas.openxmlformats.org/drawingml/2006/main">
+            <a:r>
+              <a:t>- Repository: paper_write/Universiti_Malaya_Thesis_Template/sample-chap-results-p2.tex</a:t>
             </a:r>
           </a:p>
           <a:p xmlns:a="http://schemas.openxmlformats.org/drawingml/2006/main">
@@ -799,17 +794,17 @@
           </a:p>
           <a:p xmlns:a="http://schemas.openxmlformats.org/drawingml/2006/main">
             <a:r>
-              <a:t>Summarize the contribution in the narrow form supported by the evidence: a compact spatial 3D segmentation architecture and a transparent accuracy-efficiency evaluation.</a:t>
-            </a:r>
-          </a:p>
-          <a:p xmlns:a="http://schemas.openxmlformats.org/drawingml/2006/main">
-            <a:r>
-              <a:t>The immediate next step is no longer to recover case rows; it is to confirm historical provenance and strengthen validity with matched ablations, multiple seeds, and independent evaluation.</a:t>
-            </a:r>
-          </a:p>
-          <a:p xmlns:a="http://schemas.openxmlformats.org/drawingml/2006/main">
-            <a:r>
-              <a:t>True 4D temporal modelling remains a separate future research direction.</a:t>
+              <a:t>Summarize the supported contribution narrowly: a compact 3D segmentation model with a Mamba-inspired spatial sequence gate and a transparent accuracy–efficiency comparison.</a:t>
+            </a:r>
+          </a:p>
+          <a:p xmlns:a="http://schemas.openxmlformats.org/drawingml/2006/main">
+            <a:r>
+              <a:t>The next scientific validation is multiple seeds, an independent test cohort, parameter-matched ablations, augmentation, native-space preprocessing, and surface-distance metrics.</a:t>
+            </a:r>
+          </a:p>
+          <a:p xmlns:a="http://schemas.openxmlformats.org/drawingml/2006/main">
+            <a:r>
+              <a:t>True 4D temporal modelling must process cine sequences jointly and evaluate motion or functional outputs. It remains future work, not a completed claim.</a:t>
             </a:r>
           </a:p>
           <a:p xmlns:a="http://schemas.openxmlformats.org/drawingml/2006/main">
@@ -834,7 +829,7 @@
           </a:p>
           <a:p xmlns:a="http://schemas.openxmlformats.org/drawingml/2006/main">
             <a:r>
-              <a:t>- Repository: evidence/rigorous_patient_split/evidence_audit_report.json</a:t>
+              <a:t>- Repository: paper_write/P2_FINAL_AUDIT.md</a:t>
             </a:r>
           </a:p>
           <a:p xmlns:a="http://schemas.openxmlformats.org/drawingml/2006/main">
@@ -1239,17 +1234,17 @@
           </a:p>
           <a:p xmlns:a="http://schemas.openxmlformats.org/drawingml/2006/main">
             <a:r>
-              <a:t>Walk from encoder to bottleneck to decoder. The architectural contribution is an added low-resolution sequence gate, not replacement of the entire U-Net.</a:t>
-            </a:r>
-          </a:p>
-          <a:p xmlns:a="http://schemas.openxmlformats.org/drawingml/2006/main">
-            <a:r>
-              <a:t>Defend the terminology carefully: the implementation has no selective scan and does not model time.</a:t>
-            </a:r>
-          </a:p>
-          <a:p xmlns:a="http://schemas.openxmlformats.org/drawingml/2006/main">
-            <a:r>
-              <a:t>If asked about parameter accounting, note that legacy gate-projection channels without an output path remain included in the reported trainable parameter total.</a:t>
+              <a:t>Walk through the exact tensor path: input [B, 1, 256, 256, 16], bottleneck [B, 128, 32, 32, 2], flattened sequence [B, 2048, 128], and output [B, 4, 256, 256, 16].</a:t>
+            </a:r>
+          </a:p>
+          <a:p xmlns:a="http://schemas.openxmlformats.org/drawingml/2006/main">
+            <a:r>
+              <a:t>The 2,048 items are spatial tokens: 32 × 32 × 2 after three pooling stages. They are not cardiac time points.</a:t>
+            </a:r>
+          </a:p>
+          <a:p xmlns:a="http://schemas.openxmlformats.org/drawingml/2006/main">
+            <a:r>
+              <a:t>Defend the terminology carefully: this is a Mamba-inspired gated spatial sequence block. It has no selective scan and does not perform temporal modelling.</a:t>
             </a:r>
           </a:p>
           <a:p xmlns:a="http://schemas.openxmlformats.org/drawingml/2006/main">
@@ -1349,17 +1344,27 @@
           <a:lstStyle xmlns:a="http://schemas.openxmlformats.org/drawingml/2006/main"/>
           <a:p xmlns:a="http://schemas.openxmlformats.org/drawingml/2006/main">
             <a:r>
-              <a:t>Timing: 0:55.</a:t>
-            </a:r>
-          </a:p>
-          <a:p xmlns:a="http://schemas.openxmlformats.org/drawingml/2006/main">
-            <a:r>
-              <a:t>Name the six configurations quickly, then spend more time on what the design cannot isolate.</a:t>
-            </a:r>
-          </a:p>
-          <a:p xmlns:a="http://schemas.openxmlformats.org/drawingml/2006/main">
-            <a:r>
-              <a:t>Different batch sizes and non-parameter-matched bottlenecks mean the results compare executed systems; they do not identify a pure causal effect of the gate.</a:t>
+              <a:t>Timing: 1:10.</a:t>
+            </a:r>
+          </a:p>
+          <a:p xmlns:a="http://schemas.openxmlformats.org/drawingml/2006/main">
+            <a:r>
+              <a:t>State the exact five transforms in order: LoadImaged, EnsureChannelFirstd, Resized to 256 × 256 × 16, ScaleIntensityd for the image, and ToTensord.</a:t>
+            </a:r>
+          </a:p>
+          <a:p xmlns:a="http://schemas.openxmlformats.org/drawingml/2006/main">
+            <a:r>
+              <a:t>Trilinear interpolation is used for continuous MRI intensities. Nearest-neighbour is used for labels so class IDs are not blended.</a:t>
+            </a:r>
+          </a:p>
+          <a:p xmlns:a="http://schemas.openxmlformats.org/drawingml/2006/main">
+            <a:r>
+              <a:t>ScaleIntensityd performs independent min–max scaling for each loaded 3D image. No augmentation was applied.</a:t>
+            </a:r>
+          </a:p>
+          <a:p xmlns:a="http://schemas.openxmlformats.org/drawingml/2006/main">
+            <a:r>
+              <a:t>There is no orientation canonicalization, physical-spacing normalization, heart crop, inverse resampling, or connected-component post-processing. Therefore Dice describes the resized computational grid, not native-space anatomy.</a:t>
             </a:r>
           </a:p>
           <a:p xmlns:a="http://schemas.openxmlformats.org/drawingml/2006/main">
@@ -1912,7 +1917,7 @@
   </p:cSld>
   <p:clrMap bg1="lt1" tx1="dk1" bg2="lt2" tx2="dk2" accent1="accent1" accent2="accent2" accent3="accent3" accent4="accent4" accent5="accent5" accent6="accent6" hlink="hlink" folHlink="folHlink"/>
   <p:sldLayoutIdLst>
-    <p:sldLayoutId xmlns:r="http://schemas.openxmlformats.org/officeDocument/2006/relationships" id="2147483649" r:id="Re0cef0c161984328"/>
+    <p:sldLayoutId xmlns:r="http://schemas.openxmlformats.org/officeDocument/2006/relationships" id="2147483649" r:id="R86d1f716b3644ec1"/>
   </p:sldLayoutIdLst>
   <p:txStyles>
     <p:titleStyle>
@@ -3238,7 +3243,7 @@
           <p:nvPr/>
         </p:nvPicPr>
         <p:blipFill>
-          <a:blip xmlns:r="http://schemas.openxmlformats.org/officeDocument/2006/relationships" xmlns:a="http://schemas.openxmlformats.org/drawingml/2006/main" r:embed="R8994f76e4fd6458a"/>
+          <a:blip xmlns:r="http://schemas.openxmlformats.org/officeDocument/2006/relationships" xmlns:a="http://schemas.openxmlformats.org/drawingml/2006/main" r:embed="Rd4d5394c1fa64fd1"/>
           <a:stretch xmlns:a="http://schemas.openxmlformats.org/drawingml/2006/main"/>
         </p:blipFill>
         <p:spPr>
@@ -3655,7 +3660,7 @@
                 <a:ea typeface="Arial"/>
                 <a:cs typeface="Arial"/>
               </a:rPr>
-              <a:t>Current RTX 4060 / PyTorch capture exists; historical benchmark environment remains unconfirmed</a:t>
+              <a:t>Batch-one random-input benchmark on the recorded RTX 4060 setup; hardware- and implementation-specific</a:t>
             </a:r>
           </a:p>
         </p:txBody>
@@ -3802,7 +3807,7 @@
                 <a:ea typeface="Arial"/>
                 <a:cs typeface="Arial"/>
               </a:rPr>
-              <a:t>The comparison is auditable—but uncertainty remains open</a:t>
+              <a:t>Internal validity ≠ generalization</a:t>
             </a:r>
           </a:p>
         </p:txBody>
@@ -3951,7 +3956,7 @@
                 <a:ea typeface="Arial"/>
                 <a:cs typeface="Arial"/>
               </a:rPr>
-              <a:t>CLOSED</a:t>
+              <a:t>WHAT THE STUDY SUPPORTS</a:t>
             </a:r>
           </a:p>
         </p:txBody>
@@ -4010,8 +4015,26 @@
                 <a:ea typeface="Arial"/>
                 <a:cs typeface="Arial"/>
               </a:rPr>
-              <a:t>•  </a:t>
-            </a:r>
+              <a:t>•  Patient-level split; no leakage</a:t>
+            </a:r>
+          </a:p>
+          <a:p xmlns:a="http://schemas.openxmlformats.org/drawingml/2006/main">
+            <a:r>
+              <a:t/>
+            </a:r>
+          </a:p>
+          <a:p xmlns:a="http://schemas.openxmlformats.org/drawingml/2006/main">
+            <a:pPr algn="l">
+              <a:buNone/>
+              <a:defRPr sz="1725" b="0" i="0">
+                <a:solidFill>
+                  <a:srgbClr val="000000"/>
+                </a:solidFill>
+                <a:latin typeface="Arial"/>
+                <a:ea typeface="Arial"/>
+                <a:cs typeface="Arial"/>
+              </a:defRPr>
+            </a:pPr>
             <a:r>
               <a:rPr sz="1725" b="0" i="0">
                 <a:solidFill>
@@ -4021,7 +4044,7 @@
                 <a:ea typeface="Arial"/>
                 <a:cs typeface="Arial"/>
               </a:rPr>
-              <a:t>6 × 40 case rows reproduce every summary value</a:t>
+              <a:t>•  Same preprocessing + checkpoint rule</a:t>
             </a:r>
           </a:p>
           <a:p xmlns:a="http://schemas.openxmlformats.org/drawingml/2006/main">
@@ -4050,8 +4073,26 @@
                 <a:ea typeface="Arial"/>
                 <a:cs typeface="Arial"/>
               </a:rPr>
-              <a:t>•  </a:t>
-            </a:r>
+              <a:t>•  Case rows reproduce each Dice</a:t>
+            </a:r>
+          </a:p>
+          <a:p xmlns:a="http://schemas.openxmlformats.org/drawingml/2006/main">
+            <a:r>
+              <a:t/>
+            </a:r>
+          </a:p>
+          <a:p xmlns:a="http://schemas.openxmlformats.org/drawingml/2006/main">
+            <a:pPr algn="l">
+              <a:buNone/>
+              <a:defRPr sz="1725" b="0" i="0">
+                <a:solidFill>
+                  <a:srgbClr val="000000"/>
+                </a:solidFill>
+                <a:latin typeface="Arial"/>
+                <a:ea typeface="Arial"/>
+                <a:cs typeface="Arial"/>
+              </a:defRPr>
+            </a:pPr>
             <a:r>
               <a:rPr sz="1725" b="0" i="0">
                 <a:solidFill>
@@ -4061,87 +4102,7 @@
                 <a:ea typeface="Arial"/>
                 <a:cs typeface="Arial"/>
               </a:rPr>
-              <a:t>6 × 150 logs reproduce all best epochs</a:t>
-            </a:r>
-          </a:p>
-          <a:p xmlns:a="http://schemas.openxmlformats.org/drawingml/2006/main">
-            <a:r>
-              <a:t/>
-            </a:r>
-          </a:p>
-          <a:p xmlns:a="http://schemas.openxmlformats.org/drawingml/2006/main">
-            <a:pPr algn="l">
-              <a:buNone/>
-              <a:defRPr sz="1725" b="0" i="0">
-                <a:solidFill>
-                  <a:srgbClr val="000000"/>
-                </a:solidFill>
-                <a:latin typeface="Arial"/>
-                <a:ea typeface="Arial"/>
-                <a:cs typeface="Arial"/>
-              </a:defRPr>
-            </a:pPr>
-            <a:r>
-              <a:rPr sz="1725" b="0" i="0">
-                <a:solidFill>
-                  <a:srgbClr val="000000"/>
-                </a:solidFill>
-                <a:latin typeface="Arial"/>
-                <a:ea typeface="Arial"/>
-                <a:cs typeface="Arial"/>
-              </a:rPr>
-              <a:t>•  </a:t>
-            </a:r>
-            <a:r>
-              <a:rPr sz="1725" b="0" i="0">
-                <a:solidFill>
-                  <a:srgbClr val="000000"/>
-                </a:solidFill>
-                <a:latin typeface="Arial"/>
-                <a:ea typeface="Arial"/>
-                <a:cs typeface="Arial"/>
-              </a:rPr>
-              <a:t>6 checkpoint hashes and metadata agree</a:t>
-            </a:r>
-          </a:p>
-          <a:p xmlns:a="http://schemas.openxmlformats.org/drawingml/2006/main">
-            <a:r>
-              <a:t/>
-            </a:r>
-          </a:p>
-          <a:p xmlns:a="http://schemas.openxmlformats.org/drawingml/2006/main">
-            <a:pPr algn="l">
-              <a:buNone/>
-              <a:defRPr sz="1725" b="0" i="0">
-                <a:solidFill>
-                  <a:srgbClr val="000000"/>
-                </a:solidFill>
-                <a:latin typeface="Arial"/>
-                <a:ea typeface="Arial"/>
-                <a:cs typeface="Arial"/>
-              </a:defRPr>
-            </a:pPr>
-            <a:r>
-              <a:rPr sz="1725" b="0" i="0">
-                <a:solidFill>
-                  <a:srgbClr val="000000"/>
-                </a:solidFill>
-                <a:latin typeface="Arial"/>
-                <a:ea typeface="Arial"/>
-                <a:cs typeface="Arial"/>
-              </a:rPr>
-              <a:t>•  </a:t>
-            </a:r>
-            <a:r>
-              <a:rPr sz="1725" b="0" i="0">
-                <a:solidFill>
-                  <a:srgbClr val="000000"/>
-                </a:solidFill>
-                <a:latin typeface="Arial"/>
-                <a:ea typeface="Arial"/>
-                <a:cs typeface="Arial"/>
-              </a:rPr>
-              <a:t>Empty-empty branch: 0 of 720 class scores</a:t>
+              <a:t>•  Curves reproduce best epochs</a:t>
             </a:r>
           </a:p>
         </p:txBody>
@@ -4231,7 +4192,7 @@
                 <a:ea typeface="Arial"/>
                 <a:cs typeface="Arial"/>
               </a:rPr>
-              <a:t>FOUR HISTORY LINKS OPEN</a:t>
+              <a:t>WHAT REMAINS UNTESTED</a:t>
             </a:r>
           </a:p>
         </p:txBody>
@@ -4290,8 +4251,26 @@
                 <a:ea typeface="Arial"/>
                 <a:cs typeface="Arial"/>
               </a:rPr>
-              <a:t>•  </a:t>
-            </a:r>
+              <a:t>•  Independent test + multiple seeds</a:t>
+            </a:r>
+          </a:p>
+          <a:p xmlns:a="http://schemas.openxmlformats.org/drawingml/2006/main">
+            <a:r>
+              <a:t/>
+            </a:r>
+          </a:p>
+          <a:p xmlns:a="http://schemas.openxmlformats.org/drawingml/2006/main">
+            <a:pPr algn="l">
+              <a:buNone/>
+              <a:defRPr sz="1725" b="0" i="0">
+                <a:solidFill>
+                  <a:srgbClr val="000000"/>
+                </a:solidFill>
+                <a:latin typeface="Arial"/>
+                <a:ea typeface="Arial"/>
+                <a:cs typeface="Arial"/>
+              </a:defRPr>
+            </a:pPr>
             <a:r>
               <a:rPr sz="1725" b="0" i="0">
                 <a:solidFill>
@@ -4301,7 +4280,7 @@
                 <a:ea typeface="Arial"/>
                 <a:cs typeface="Arial"/>
               </a:rPr>
-              <a:t>Checkpoint directory not confirmed unchanged</a:t>
+              <a:t>•  Augmentation + native-space evaluation</a:t>
             </a:r>
           </a:p>
           <a:p xmlns:a="http://schemas.openxmlformats.org/drawingml/2006/main">
@@ -4330,8 +4309,26 @@
                 <a:ea typeface="Arial"/>
                 <a:cs typeface="Arial"/>
               </a:rPr>
-              <a:t>•  </a:t>
-            </a:r>
+              <a:t>•  Capacity-matched ablations</a:t>
+            </a:r>
+          </a:p>
+          <a:p xmlns:a="http://schemas.openxmlformats.org/drawingml/2006/main">
+            <a:r>
+              <a:t/>
+            </a:r>
+          </a:p>
+          <a:p xmlns:a="http://schemas.openxmlformats.org/drawingml/2006/main">
+            <a:pPr algn="l">
+              <a:buNone/>
+              <a:defRPr sz="1725" b="0" i="0">
+                <a:solidFill>
+                  <a:srgbClr val="000000"/>
+                </a:solidFill>
+                <a:latin typeface="Arial"/>
+                <a:ea typeface="Arial"/>
+                <a:cs typeface="Arial"/>
+              </a:defRPr>
+            </a:pPr>
             <a:r>
               <a:rPr sz="1725" b="0" i="0">
                 <a:solidFill>
@@ -4341,87 +4338,7 @@
                 <a:ea typeface="Arial"/>
                 <a:cs typeface="Arial"/>
               </a:rPr>
-              <a:t>Historical Conda/GPU environment unconfirmed</a:t>
-            </a:r>
-          </a:p>
-          <a:p xmlns:a="http://schemas.openxmlformats.org/drawingml/2006/main">
-            <a:r>
-              <a:t/>
-            </a:r>
-          </a:p>
-          <a:p xmlns:a="http://schemas.openxmlformats.org/drawingml/2006/main">
-            <a:pPr algn="l">
-              <a:buNone/>
-              <a:defRPr sz="1725" b="0" i="0">
-                <a:solidFill>
-                  <a:srgbClr val="000000"/>
-                </a:solidFill>
-                <a:latin typeface="Arial"/>
-                <a:ea typeface="Arial"/>
-                <a:cs typeface="Arial"/>
-              </a:defRPr>
-            </a:pPr>
-            <a:r>
-              <a:rPr sz="1725" b="0" i="0">
-                <a:solidFill>
-                  <a:srgbClr val="000000"/>
-                </a:solidFill>
-                <a:latin typeface="Arial"/>
-                <a:ea typeface="Arial"/>
-                <a:cs typeface="Arial"/>
-              </a:rPr>
-              <a:t>•  </a:t>
-            </a:r>
-            <a:r>
-              <a:rPr sz="1725" b="0" i="0">
-                <a:solidFill>
-                  <a:srgbClr val="000000"/>
-                </a:solidFill>
-                <a:latin typeface="Arial"/>
-                <a:ea typeface="Arial"/>
-                <a:cs typeface="Arial"/>
-              </a:rPr>
-              <a:t>Exact command and working directory unconfirmed</a:t>
-            </a:r>
-          </a:p>
-          <a:p xmlns:a="http://schemas.openxmlformats.org/drawingml/2006/main">
-            <a:r>
-              <a:t/>
-            </a:r>
-          </a:p>
-          <a:p xmlns:a="http://schemas.openxmlformats.org/drawingml/2006/main">
-            <a:pPr algn="l">
-              <a:buNone/>
-              <a:defRPr sz="1725" b="0" i="0">
-                <a:solidFill>
-                  <a:srgbClr val="000000"/>
-                </a:solidFill>
-                <a:latin typeface="Arial"/>
-                <a:ea typeface="Arial"/>
-                <a:cs typeface="Arial"/>
-              </a:defRPr>
-            </a:pPr>
-            <a:r>
-              <a:rPr sz="1725" b="0" i="0">
-                <a:solidFill>
-                  <a:srgbClr val="000000"/>
-                </a:solidFill>
-                <a:latin typeface="Arial"/>
-                <a:ea typeface="Arial"/>
-                <a:cs typeface="Arial"/>
-              </a:rPr>
-              <a:t>•  </a:t>
-            </a:r>
-            <a:r>
-              <a:rPr sz="1725" b="0" i="0">
-                <a:solidFill>
-                  <a:srgbClr val="000000"/>
-                </a:solidFill>
-                <a:latin typeface="Arial"/>
-                <a:ea typeface="Arial"/>
-                <a:cs typeface="Arial"/>
-              </a:rPr>
-              <a:t>Full 200-case historical content manifest absent</a:t>
+              <a:t>•  ED/ES, pathology, HD95/ASD + visual review</a:t>
             </a:r>
           </a:p>
         </p:txBody>
@@ -4511,7 +4428,7 @@
                 <a:ea typeface="Arial"/>
                 <a:cs typeface="Arial"/>
               </a:rPr>
-              <a:t>Aggregate + recovered evidence: PASS · Strict closure: INCOMPLETE on four historical confirmations</a:t>
+              <a:t>These are scientific design limits—not missing historical logs or submission files.</a:t>
             </a:r>
           </a:p>
         </p:txBody>
@@ -5108,7 +5025,7 @@
                 <a:ea typeface="Arial"/>
                 <a:cs typeface="Arial"/>
               </a:rPr>
-              <a:t>NEXT EVIDENCE</a:t>
+              <a:t>NEXT VALIDATION</a:t>
             </a:r>
           </a:p>
         </p:txBody>
@@ -5202,7 +5119,7 @@
         </p:spPr>
         <p:txBody>
           <a:bodyPr xmlns:a="http://schemas.openxmlformats.org/drawingml/2006/main" anchor="t">
-            <a:normAutofit fontScale="83739"/>
+            <a:normAutofit fontScale="82121"/>
           </a:bodyPr>
           <a:lstStyle xmlns:a="http://schemas.openxmlformats.org/drawingml/2006/main"/>
           <a:p xmlns:a="http://schemas.openxmlformats.org/drawingml/2006/main">
@@ -5226,7 +5143,7 @@
                 <a:ea typeface="Arial"/>
                 <a:cs typeface="Arial"/>
               </a:rPr>
-              <a:t>Confirm historical provenance; run matched ablations and multiple seeds; add an independent or external test cohort.</a:t>
+              <a:t>Run multiple seeds and an independent test; add matched ablations, augmentation, native-space preprocessing, and surface metrics.</a:t>
             </a:r>
           </a:p>
         </p:txBody>
@@ -8205,7 +8122,7 @@
                 <a:ea typeface="Arial"/>
                 <a:cs typeface="Arial"/>
               </a:rPr>
-              <a:t>Nano-Mamba adds a compact spatial sequence gate</a:t>
+              <a:t>Nano-Mamba mixes 2,048 spatial tokens</a:t>
             </a:r>
           </a:p>
         </p:txBody>
@@ -8342,7 +8259,7 @@
           <p:nvPr/>
         </p:nvPicPr>
         <p:blipFill>
-          <a:blip xmlns:r="http://schemas.openxmlformats.org/officeDocument/2006/relationships" xmlns:a="http://schemas.openxmlformats.org/drawingml/2006/main" r:embed="R07ee05e308784b62"/>
+          <a:blip xmlns:r="http://schemas.openxmlformats.org/officeDocument/2006/relationships" xmlns:a="http://schemas.openxmlformats.org/drawingml/2006/main" r:embed="Rbd7bc88834d243df"/>
           <a:stretch xmlns:a="http://schemas.openxmlformats.org/drawingml/2006/main"/>
         </p:blipFill>
         <p:spPr>
@@ -8468,7 +8385,7 @@
                 <a:ea typeface="Arial"/>
                 <a:cs typeface="Arial"/>
               </a:rPr>
-              <a:t>•  Flattens the compressed 3D grid in a fixed spatial raster order</a:t>
+              <a:t>•  Bottleneck: B × 128 × 32 × 32 × 2</a:t>
             </a:r>
           </a:p>
           <a:p xmlns:a="http://schemas.openxmlformats.org/drawingml/2006/main">
@@ -8497,7 +8414,7 @@
                 <a:ea typeface="Arial"/>
                 <a:cs typeface="Arial"/>
               </a:rPr>
-              <a:t>•  Uses a depthwise 1D convolution, scalar sigmoid gate, output projection, and residual path</a:t>
+              <a:t>•  32 × 32 × 2 = 2,048 spatial tokens</a:t>
             </a:r>
           </a:p>
           <a:p xmlns:a="http://schemas.openxmlformats.org/drawingml/2006/main">
@@ -8526,7 +8443,7 @@
                 <a:ea typeface="Arial"/>
                 <a:cs typeface="Arial"/>
               </a:rPr>
-              <a:t>•  Reshapes the sequence back to a 3D feature grid</a:t>
+              <a:t>•  Depthwise 1D mix + gate + projection + residual</a:t>
             </a:r>
           </a:p>
         </p:txBody>
@@ -8561,7 +8478,7 @@
         </p:spPr>
         <p:txBody>
           <a:bodyPr xmlns:a="http://schemas.openxmlformats.org/drawingml/2006/main" anchor="t">
-            <a:normAutofit fontScale="77257"/>
+            <a:normAutofit fontScale="68519"/>
           </a:bodyPr>
           <a:lstStyle xmlns:a="http://schemas.openxmlformats.org/drawingml/2006/main"/>
           <a:p xmlns:a="http://schemas.openxmlformats.org/drawingml/2006/main">
@@ -8585,7 +8502,7 @@
                 <a:ea typeface="Arial"/>
                 <a:cs typeface="Arial"/>
               </a:rPr>
-              <a:t>Mamba-inspired ≠ full Mamba selective scan</a:t>
+              <a:t>Spatial tokens ≠ cardiac time points or full Mamba</a:t>
             </a:r>
           </a:p>
         </p:txBody>
@@ -8791,7 +8708,7 @@
                 <a:ea typeface="Arial"/>
                 <a:cs typeface="Arial"/>
               </a:rPr>
-              <a:t>Six executed models test accuracy and compactness</a:t>
+              <a:t>Image preprocessing is deterministic and explicit</a:t>
             </a:r>
           </a:p>
         </p:txBody>
@@ -8940,7 +8857,7 @@
                 <a:ea typeface="Arial"/>
                 <a:cs typeface="Arial"/>
               </a:rPr>
-              <a:t>REFERENCE MODELS</a:t>
+              <a:t>LOAD + SHAPE</a:t>
             </a:r>
           </a:p>
         </p:txBody>
@@ -8999,7 +8916,7 @@
                 <a:ea typeface="Arial"/>
                 <a:cs typeface="Arial"/>
               </a:rPr>
-              <a:t>3D U-Net</a:t>
+              <a:t>1  Load image + label</a:t>
             </a:r>
           </a:p>
           <a:p xmlns:a="http://schemas.openxmlformats.org/drawingml/2006/main">
@@ -9023,7 +8940,7 @@
                 <a:ea typeface="Arial"/>
                 <a:cs typeface="Arial"/>
               </a:rPr>
-              <a:t>Attention U-Net</a:t>
+              <a:t>2  Add channel axis</a:t>
             </a:r>
           </a:p>
           <a:p xmlns:a="http://schemas.openxmlformats.org/drawingml/2006/main">
@@ -9047,7 +8964,7 @@
                 <a:ea typeface="Arial"/>
                 <a:cs typeface="Arial"/>
               </a:rPr>
-              <a:t>SegResNet16</a:t>
+              <a:t>3  Resize: 256 × 256 × 16</a:t>
             </a:r>
           </a:p>
         </p:txBody>
@@ -9106,7 +9023,7 @@
                 <a:ea typeface="Arial"/>
                 <a:cs typeface="Arial"/>
               </a:rPr>
-              <a:t>PROPOSED + ABLATIONS</a:t>
+              <a:t>INTERPOLATE + PREDICT</a:t>
             </a:r>
           </a:p>
         </p:txBody>
@@ -9165,7 +9082,7 @@
                 <a:ea typeface="Arial"/>
                 <a:cs typeface="Arial"/>
               </a:rPr>
-              <a:t>Nano-Mamba U-Net</a:t>
+              <a:t>MRI: trilinear + 0–1 scaling</a:t>
             </a:r>
           </a:p>
           <a:p xmlns:a="http://schemas.openxmlformats.org/drawingml/2006/main">
@@ -9189,7 +9106,7 @@
                 <a:ea typeface="Arial"/>
                 <a:cs typeface="Arial"/>
               </a:rPr>
-              <a:t>No-Mamba U-Net</a:t>
+              <a:t>Label: nearest-neighbour</a:t>
             </a:r>
           </a:p>
           <a:p xmlns:a="http://schemas.openxmlformats.org/drawingml/2006/main">
@@ -9213,7 +9130,7 @@
                 <a:ea typeface="Arial"/>
                 <a:cs typeface="Arial"/>
               </a:rPr>
-              <a:t>Half-Mamba U-Net</a:t>
+              <a:t>4 logits → argmax mask</a:t>
             </a:r>
           </a:p>
         </p:txBody>
@@ -9334,7 +9251,7 @@
                 <a:ea typeface="Arial"/>
                 <a:cs typeface="Arial"/>
               </a:rPr>
-              <a:t>Fairness boundary</a:t>
+              <a:t>Geometry boundary</a:t>
             </a:r>
           </a:p>
         </p:txBody>
@@ -9393,7 +9310,7 @@
                 <a:ea typeface="Arial"/>
                 <a:cs typeface="Arial"/>
               </a:rPr>
-              <a:t>Batch sizes differ (1 or 2), custom models use BatchNorm, and the No-Mamba ablation has more parameters. The comparison is informative, but it is not a matched-capacity causal test of gating.</a:t>
+              <a:t>No augmentation, Orientationd, Spacingd, heart crop, inverse resampling, or mask post-processing. Dice is measured on the resized grid.</a:t>
             </a:r>
           </a:p>
         </p:txBody>
@@ -11265,7 +11182,7 @@
           <p:nvPr/>
         </p:nvPicPr>
         <p:blipFill>
-          <a:blip xmlns:r="http://schemas.openxmlformats.org/officeDocument/2006/relationships" xmlns:a="http://schemas.openxmlformats.org/drawingml/2006/main" r:embed="R6dc5a179d1cf4722"/>
+          <a:blip xmlns:r="http://schemas.openxmlformats.org/officeDocument/2006/relationships" xmlns:a="http://schemas.openxmlformats.org/drawingml/2006/main" r:embed="R5350315bef5f486e"/>
           <a:stretch xmlns:a="http://schemas.openxmlformats.org/drawingml/2006/main"/>
         </p:blipFill>
         <p:spPr>
@@ -12741,7 +12658,7 @@
           <p:nvPr/>
         </p:nvPicPr>
         <p:blipFill>
-          <a:blip xmlns:r="http://schemas.openxmlformats.org/officeDocument/2006/relationships" xmlns:a="http://schemas.openxmlformats.org/drawingml/2006/main" r:embed="R5de98a2de38e4cf9"/>
+          <a:blip xmlns:r="http://schemas.openxmlformats.org/officeDocument/2006/relationships" xmlns:a="http://schemas.openxmlformats.org/drawingml/2006/main" r:embed="R0a1c4f1315c540e2"/>
           <a:stretch xmlns:a="http://schemas.openxmlformats.org/drawingml/2006/main"/>
         </p:blipFill>
         <p:spPr>

</xml_diff>

<commit_message>
Finalize lightweight framing and defense clarity
</commit_message>
<xml_diff>
--- a/presentation/P2_Final_Defense_Tong_Siyuan.pptx
+++ b/presentation/P2_Final_Defense_Tong_Siyuan.pptx
@@ -2,26 +2,26 @@
 <file path=ppt/presentation.xml><?xml version="1.0" encoding="utf-8"?>
 <p:presentation xmlns:p="http://schemas.openxmlformats.org/presentationml/2006/main">
   <p:sldMasterIdLst>
-    <p:sldMasterId xmlns:r="http://schemas.openxmlformats.org/officeDocument/2006/relationships" id="2147483648" r:id="Rb2527270788a46b4"/>
+    <p:sldMasterId xmlns:r="http://schemas.openxmlformats.org/officeDocument/2006/relationships" id="2147483648" r:id="R04ecfa55e1bd435a"/>
   </p:sldMasterIdLst>
   <p:notesMasterIdLst>
-    <p:notesMasterId xmlns:r="http://schemas.openxmlformats.org/officeDocument/2006/relationships" r:id="Raae51987226b43d5"/>
+    <p:notesMasterId xmlns:r="http://schemas.openxmlformats.org/officeDocument/2006/relationships" r:id="Rf6e229e7566f4d3a"/>
   </p:notesMasterIdLst>
   <p:sldIdLst>
-    <p:sldId xmlns:r="http://schemas.openxmlformats.org/officeDocument/2006/relationships" id="256" r:id="R654852bfbf7449c2"/>
-    <p:sldId xmlns:r="http://schemas.openxmlformats.org/officeDocument/2006/relationships" id="257" r:id="R5b18ad981e5846af"/>
-    <p:sldId xmlns:r="http://schemas.openxmlformats.org/officeDocument/2006/relationships" id="258" r:id="R792887100af04354"/>
-    <p:sldId xmlns:r="http://schemas.openxmlformats.org/officeDocument/2006/relationships" id="259" r:id="Rb4606738d1504cf6"/>
-    <p:sldId xmlns:r="http://schemas.openxmlformats.org/officeDocument/2006/relationships" id="260" r:id="R829142a99c0f4547"/>
-    <p:sldId xmlns:r="http://schemas.openxmlformats.org/officeDocument/2006/relationships" id="261" r:id="Ra30744796d9d4f86"/>
-    <p:sldId xmlns:r="http://schemas.openxmlformats.org/officeDocument/2006/relationships" id="262" r:id="R9df967ad83fe4c31"/>
-    <p:sldId xmlns:r="http://schemas.openxmlformats.org/officeDocument/2006/relationships" id="263" r:id="Rc63b9c068c05489c"/>
-    <p:sldId xmlns:r="http://schemas.openxmlformats.org/officeDocument/2006/relationships" id="264" r:id="R7f9236d9a95940ef"/>
-    <p:sldId xmlns:r="http://schemas.openxmlformats.org/officeDocument/2006/relationships" id="265" r:id="Rd0d96fee6e6c452b"/>
-    <p:sldId xmlns:r="http://schemas.openxmlformats.org/officeDocument/2006/relationships" id="266" r:id="Rce708fc7f3444d5c"/>
-    <p:sldId xmlns:r="http://schemas.openxmlformats.org/officeDocument/2006/relationships" id="267" r:id="R35420dffaa054fbe"/>
-    <p:sldId xmlns:r="http://schemas.openxmlformats.org/officeDocument/2006/relationships" id="268" r:id="Rcf6a749bc6e74189"/>
-    <p:sldId xmlns:r="http://schemas.openxmlformats.org/officeDocument/2006/relationships" id="269" r:id="R7726ac0702094316"/>
+    <p:sldId xmlns:r="http://schemas.openxmlformats.org/officeDocument/2006/relationships" id="256" r:id="R0387bed15f804dcc"/>
+    <p:sldId xmlns:r="http://schemas.openxmlformats.org/officeDocument/2006/relationships" id="257" r:id="R5907e425a299445e"/>
+    <p:sldId xmlns:r="http://schemas.openxmlformats.org/officeDocument/2006/relationships" id="258" r:id="R6a45bea07d724021"/>
+    <p:sldId xmlns:r="http://schemas.openxmlformats.org/officeDocument/2006/relationships" id="259" r:id="R2383322b58da4362"/>
+    <p:sldId xmlns:r="http://schemas.openxmlformats.org/officeDocument/2006/relationships" id="260" r:id="R97fa62385a6e4c6c"/>
+    <p:sldId xmlns:r="http://schemas.openxmlformats.org/officeDocument/2006/relationships" id="261" r:id="R97d655704a864444"/>
+    <p:sldId xmlns:r="http://schemas.openxmlformats.org/officeDocument/2006/relationships" id="262" r:id="R54954b54eb094d8f"/>
+    <p:sldId xmlns:r="http://schemas.openxmlformats.org/officeDocument/2006/relationships" id="263" r:id="R12c1a95969da4ba2"/>
+    <p:sldId xmlns:r="http://schemas.openxmlformats.org/officeDocument/2006/relationships" id="264" r:id="R587896ae4333451d"/>
+    <p:sldId xmlns:r="http://schemas.openxmlformats.org/officeDocument/2006/relationships" id="265" r:id="Rdf5b926f9b6e42f0"/>
+    <p:sldId xmlns:r="http://schemas.openxmlformats.org/officeDocument/2006/relationships" id="266" r:id="Re3845b499aec44a9"/>
+    <p:sldId xmlns:r="http://schemas.openxmlformats.org/officeDocument/2006/relationships" id="267" r:id="R5cce2b6e32a7491d"/>
+    <p:sldId xmlns:r="http://schemas.openxmlformats.org/officeDocument/2006/relationships" id="268" r:id="R213bcc232d7e46cc"/>
+    <p:sldId xmlns:r="http://schemas.openxmlformats.org/officeDocument/2006/relationships" id="269" r:id="Re183d8400ae14695"/>
   </p:sldIdLst>
   <p:sldSz cx="12192000" cy="6858000"/>
   <p:notesSz cx="6858000" cy="9144000"/>
@@ -493,6 +493,12 @@
               <a:t>- evidence/spatiotemporal_cine/INDEPENDENT_AUDIT.json</a:t>
             </a:r>
           </a:p>
+          <a:p xmlns:a="http://schemas.openxmlformats.org/drawingml/2006/main">
+            <a:r>
+              <a:t>
+[/Sources]</a:t>
+            </a:r>
+          </a:p>
         </p:txBody>
       </p:sp>
       <p:sp>
@@ -570,7 +576,7 @@
           </a:p>
           <a:p xmlns:a="http://schemas.openxmlformats.org/drawingml/2006/main">
             <a:r>
-              <a:t>The supported temporal finding is smoother global LV-volume trajectories. The lower-is-smoother metric improved by 0.001129, and its paired 95 percent bootstrap interval is entirely below zero. Nineteen of twenty patients improved. By contrast, endpoint Dice changed by only plus 0.0144 percentage points and its interval crosses zero. Therefore I do not claim an accuracy gain from the fixed fusion.</a:t>
+              <a:t>The supported temporal finding is smoother global LV-volume trajectories. The lower-is-smoother metric improved by 0.001129, and its paired 95 percent bootstrap interval is entirely below zero. Nineteen of twenty patients improved. By contrast, endpoint Dice changed by only plus 0.0144 percentage points and its interval crosses zero. Therefore I do not claim an accuracy gain from fixed fusion.</a:t>
             </a:r>
           </a:p>
           <a:p xmlns:a="http://schemas.openxmlformats.org/drawingml/2006/main">
@@ -580,7 +586,7 @@
           </a:p>
           <a:p xmlns:a="http://schemas.openxmlformats.org/drawingml/2006/main">
             <a:r>
-              <a:t>The chart aligns every patient's predicted ED to normalized phase zero and divides volume by that patient's predicted EDV before averaging. The shaded band is the patient-level standard deviation, not a confidence interval. All patient metrics and the bootstrap were independently recomputed from the supplied frame table.</a:t>
+              <a:t>The upper chart aligns each patient to reference ED, normalizes each method by its own patient maximum, and shows both cohort means with mean plus or minus one between-patient standard deviation. The lower panel shows the paired fusion-minus-frame-wise difference and its pointwise patient 2.5th-to-97.5th percentile band. It makes the very small method difference visible without converting it into an accuracy claim.</a:t>
             </a:r>
           </a:p>
           <a:p xmlns:a="http://schemas.openxmlformats.org/drawingml/2006/main">
@@ -595,22 +601,32 @@
           </a:p>
           <a:p xmlns:a="http://schemas.openxmlformats.org/drawingml/2006/main">
             <a:r>
-              <a:t>- evidence/spatiotemporal_cine/raw/paired_method_comparison.csv</a:t>
-            </a:r>
-          </a:p>
-          <a:p xmlns:a="http://schemas.openxmlformats.org/drawingml/2006/main">
-            <a:r>
-              <a:t>- evidence/spatiotemporal_cine/raw/paired_bootstrap_ci.csv</a:t>
-            </a:r>
-          </a:p>
-          <a:p xmlns:a="http://schemas.openxmlformats.org/drawingml/2006/main">
-            <a:r>
-              <a:t>- evidence/spatiotemporal_cine/raw/population_lv_motion_curve.csv</a:t>
+              <a:t>- evidence/spatiotemporal_cine/raw/frame_metrics.csv</a:t>
+            </a:r>
+          </a:p>
+          <a:p xmlns:a="http://schemas.openxmlformats.org/drawingml/2006/main">
+            <a:r>
+              <a:t>- evidence/spatiotemporal_cine/raw/patient_metrics.csv</a:t>
+            </a:r>
+          </a:p>
+          <a:p xmlns:a="http://schemas.openxmlformats.org/drawingml/2006/main">
+            <a:r>
+              <a:t>- evidence/spatiotemporal_cine/raw/summary.json</a:t>
+            </a:r>
+          </a:p>
+          <a:p xmlns:a="http://schemas.openxmlformats.org/drawingml/2006/main">
+            <a:r>
+              <a:t>- figures/spatiotemporal/population_lv_motion_curve_provenance.json</a:t>
             </a:r>
           </a:p>
           <a:p xmlns:a="http://schemas.openxmlformats.org/drawingml/2006/main">
             <a:r>
               <a:t>- evidence/spatiotemporal_cine/INDEPENDENT_AUDIT.json</a:t>
+            </a:r>
+          </a:p>
+          <a:p xmlns:a="http://schemas.openxmlformats.org/drawingml/2006/main">
+            <a:r>
+              <a:t>[/Sources]</a:t>
             </a:r>
           </a:p>
         </p:txBody>
@@ -710,7 +726,7 @@
           </a:p>
           <a:p xmlns:a="http://schemas.openxmlformats.org/drawingml/2006/main">
             <a:r>
-              <a:t>The recovered official cine files contain an affine-metadata inconsistency relative to endpoint files for six patients. Shape, voxel spacing and endpoint pixel identity were checked; physical scalar metrics use header spacings. I do not use those affines to assert world-coordinate tissue correspondence.</a:t>
+              <a:t>Six recovered public cines have affine metadata that differs from the standalone endpoint containers. Shape, header voxel sizes, endpoint pixel content and endpoint image-label alignment passed the gates. Physical volumes use header voxel sizes, and the pipeline does not use those inconsistent affines to assert world-coordinate tissue correspondence.</a:t>
             </a:r>
           </a:p>
           <a:p xmlns:a="http://schemas.openxmlformats.org/drawingml/2006/main">
@@ -730,17 +746,22 @@
           </a:p>
           <a:p xmlns:a="http://schemas.openxmlformats.org/drawingml/2006/main">
             <a:r>
-              <a:t>- evidence/spatiotemporal_cine/raw/ejection_fraction_validation.csv</a:t>
-            </a:r>
-          </a:p>
-          <a:p xmlns:a="http://schemas.openxmlformats.org/drawingml/2006/main">
-            <a:r>
-              <a:t>- evidence/spatiotemporal_cine/raw/phase_detection_validation.csv</a:t>
+              <a:t>- evidence/spatiotemporal_cine/raw/summary.json</a:t>
+            </a:r>
+          </a:p>
+          <a:p xmlns:a="http://schemas.openxmlformats.org/drawingml/2006/main">
+            <a:r>
+              <a:t>- evidence/spatiotemporal_cine/raw/input_manifest.json</a:t>
             </a:r>
           </a:p>
           <a:p xmlns:a="http://schemas.openxmlformats.org/drawingml/2006/main">
             <a:r>
               <a:t>- evidence/spatiotemporal_cine/INDEPENDENT_AUDIT.json</a:t>
+            </a:r>
+          </a:p>
+          <a:p xmlns:a="http://schemas.openxmlformats.org/drawingml/2006/main">
+            <a:r>
+              <a:t>[/Sources]</a:t>
             </a:r>
           </a:p>
         </p:txBody>
@@ -858,6 +879,12 @@
               <a:t>- paper_write/Universiti_Malaya_Thesis_Template/sample-chap-results-p2.tex</a:t>
             </a:r>
           </a:p>
+          <a:p xmlns:a="http://schemas.openxmlformats.org/drawingml/2006/main">
+            <a:r>
+              <a:t>
+[/Sources]</a:t>
+            </a:r>
+          </a:p>
         </p:txBody>
       </p:sp>
       <p:sp>
@@ -963,6 +990,12 @@
               <a:t>- evidence/spatiotemporal_cine/INDEPENDENT_AUDIT.json</a:t>
             </a:r>
           </a:p>
+          <a:p xmlns:a="http://schemas.openxmlformats.org/drawingml/2006/main">
+            <a:r>
+              <a:t>
+[/Sources]</a:t>
+            </a:r>
+          </a:p>
         </p:txBody>
       </p:sp>
       <p:sp>
@@ -1060,17 +1093,22 @@
           </a:p>
           <a:p xmlns:a="http://schemas.openxmlformats.org/drawingml/2006/main">
             <a:r>
-              <a:t>- evidence/spatiotemporal_cine/raw/paired_method_comparison.csv</a:t>
-            </a:r>
-          </a:p>
-          <a:p xmlns:a="http://schemas.openxmlformats.org/drawingml/2006/main">
-            <a:r>
-              <a:t>- evidence/spatiotemporal_cine/raw/paired_bootstrap_ci.csv</a:t>
+              <a:t>- evidence/spatiotemporal_cine/raw/summary.json</a:t>
+            </a:r>
+          </a:p>
+          <a:p xmlns:a="http://schemas.openxmlformats.org/drawingml/2006/main">
+            <a:r>
+              <a:t>- evidence/spatiotemporal_cine/raw/patient_metrics.csv</a:t>
             </a:r>
           </a:p>
           <a:p xmlns:a="http://schemas.openxmlformats.org/drawingml/2006/main">
             <a:r>
               <a:t>- evidence/spatiotemporal_cine/INDEPENDENT_AUDIT.json</a:t>
+            </a:r>
+          </a:p>
+          <a:p xmlns:a="http://schemas.openxmlformats.org/drawingml/2006/main">
+            <a:r>
+              <a:t>[/Sources]</a:t>
             </a:r>
           </a:p>
         </p:txBody>
@@ -1188,6 +1226,12 @@
               <a:t>- SCIENTIFIC_BOUNDARIES.md</a:t>
             </a:r>
           </a:p>
+          <a:p xmlns:a="http://schemas.openxmlformats.org/drawingml/2006/main">
+            <a:r>
+              <a:t>
+[/Sources]</a:t>
+            </a:r>
+          </a:p>
         </p:txBody>
       </p:sp>
       <p:sp>
@@ -1285,12 +1329,27 @@
           </a:p>
           <a:p xmlns:a="http://schemas.openxmlformats.org/drawingml/2006/main">
             <a:r>
-              <a:t>- evidence/spatiotemporal_cine/raw/run_metadata.json</a:t>
+              <a:t>- evidence/rigorous_patient_split/data_discovery_report.json</a:t>
+            </a:r>
+          </a:p>
+          <a:p xmlns:a="http://schemas.openxmlformats.org/drawingml/2006/main">
+            <a:r>
+              <a:t>- evidence/spatiotemporal_cine/raw/run_provenance.json</a:t>
+            </a:r>
+          </a:p>
+          <a:p xmlns:a="http://schemas.openxmlformats.org/drawingml/2006/main">
+            <a:r>
+              <a:t>- evidence/spatiotemporal_cine/raw/input_manifest.json</a:t>
             </a:r>
           </a:p>
           <a:p xmlns:a="http://schemas.openxmlformats.org/drawingml/2006/main">
             <a:r>
               <a:t>- evidence/spatiotemporal_cine/INDEPENDENT_AUDIT.json</a:t>
+            </a:r>
+          </a:p>
+          <a:p xmlns:a="http://schemas.openxmlformats.org/drawingml/2006/main">
+            <a:r>
+              <a:t>[/Sources]</a:t>
             </a:r>
           </a:p>
         </p:txBody>
@@ -1370,7 +1429,7 @@
           </a:p>
           <a:p xmlns:a="http://schemas.openxmlformats.org/drawingml/2006/main">
             <a:r>
-              <a:t>The architecture is a compact 3D encoder-decoder. The bottleneck uses a Mamba-inspired selective state-space gate across flattened spatial tokens, but it is not the reference Mamba implementation and it does not scan cine time. The longitudinal full-cine behavior comes from repeated spatial inference plus the fixed post-hoc temporal probability fusion, not from learned recurrent state across phases.</a:t>
+              <a:t>The architecture is a compact 3D encoder-decoder. At the bottleneck, 2,048 compressed spatial tokens are processed in a fixed raster order by a kernel-3 depthwise one-dimensional convolution, token-wise scalar gate, projections and a residual connection. This local block has no recurrent state-space propagation, selective scan, attention or direct global all-token interaction. Raster order also creates artificial adjacency where rows or slices meet. It is Mamba-inspired, not a reference Mamba or Visual State Space implementation, and it never scans cine time.</a:t>
             </a:r>
           </a:p>
           <a:p xmlns:a="http://schemas.openxmlformats.org/drawingml/2006/main">
@@ -1380,7 +1439,7 @@
           </a:p>
           <a:p xmlns:a="http://schemas.openxmlformats.org/drawingml/2006/main">
             <a:r>
-              <a:t>The reported parameter count is 1.456 million. The main limitation of the architecture comparison is that No-Mamba is not parameter matched and uses a different batch size, so its higher Dice cannot isolate the causal effect of the gate.</a:t>
+              <a:t>The reported parameter count is exactly 1,456,325. The convolutional control historically called No-Mamba contains zero Mamba operations: DoubleConv 64-to-128 followed by DoubleConv 128-to-128. Both it and Nano use batch size two, but the control is not parameter matched and has 2.288 million parameters. The 64-channel Mamba ablation uses the same local gate at 64 channels before expanding to 128; “Half” refers to that block width, not half of the full model.</a:t>
             </a:r>
           </a:p>
           <a:p xmlns:a="http://schemas.openxmlformats.org/drawingml/2006/main">
@@ -1400,12 +1459,22 @@
           </a:p>
           <a:p xmlns:a="http://schemas.openxmlformats.org/drawingml/2006/main">
             <a:r>
+              <a:t>- src/21_rigorous_experiment_pipeline.py</a:t>
+            </a:r>
+          </a:p>
+          <a:p xmlns:a="http://schemas.openxmlformats.org/drawingml/2006/main">
+            <a:r>
               <a:t>- paper_write/Universiti_Malaya_Thesis_Template/sample-chap-methodology.tex</a:t>
             </a:r>
           </a:p>
           <a:p xmlns:a="http://schemas.openxmlformats.org/drawingml/2006/main">
             <a:r>
               <a:t>- evidence/rigorous_patient_split/summary_metrics.csv</a:t>
+            </a:r>
+          </a:p>
+          <a:p xmlns:a="http://schemas.openxmlformats.org/drawingml/2006/main">
+            <a:r>
+              <a:t>[/Sources]</a:t>
             </a:r>
           </a:p>
         </p:txBody>
@@ -1523,6 +1592,12 @@
               <a:t>- paper_write/Universiti_Malaya_Thesis_Template/sample-chap-methodology.tex</a:t>
             </a:r>
           </a:p>
+          <a:p xmlns:a="http://schemas.openxmlformats.org/drawingml/2006/main">
+            <a:r>
+              <a:t>
+[/Sources]</a:t>
+            </a:r>
+          </a:p>
         </p:txBody>
       </p:sp>
       <p:sp>
@@ -1600,7 +1675,7 @@
           </a:p>
           <a:p xmlns:a="http://schemas.openxmlformats.org/drawingml/2006/main">
             <a:r>
-              <a:t>This table is the primary six-model comparison on the same 20-patient validation split. SegResNet16 has the highest mean Dice. No-Mamba also exceeds Nano-Mamba, so I do not claim that the Mamba-inspired gate improves accuracy. Nano-Mamba's defensible contribution is the compact accuracy-efficiency operating point: 84.779 percent mean Dice with 1.456 million reported parameters. FPS is hardware-specific and is secondary evidence.</a:t>
+              <a:t>This table is the primary six-model comparison on the same 20-patient validation split. SegResNet16 has the highest mean Dice. The zero-Mamba convolutional control also exceeds Nano-Mamba, so I do not claim that the gated block improves accuracy. Nano-Mamba's defensible contribution is the lightweight operating point: 84.779 percent mean Dice, the lowest reported parameter count at 1.456 million, and competitive batch-one throughput on the recorded hardware. “Lightweight” does not mean that Nano leads every speed, memory or accuracy metric.</a:t>
             </a:r>
           </a:p>
           <a:p xmlns:a="http://schemas.openxmlformats.org/drawingml/2006/main">
@@ -1626,6 +1701,11 @@
           <a:p xmlns:a="http://schemas.openxmlformats.org/drawingml/2006/main">
             <a:r>
               <a:t>- paper_write/Universiti_Malaya_Thesis_Template/sample-chap-results-p2.tex</a:t>
+            </a:r>
+          </a:p>
+          <a:p xmlns:a="http://schemas.openxmlformats.org/drawingml/2006/main">
+            <a:r>
+              <a:t>[/Sources]</a:t>
             </a:r>
           </a:p>
         </p:txBody>
@@ -1815,17 +1895,7 @@
           <a:lstStyle xmlns:a="http://schemas.openxmlformats.org/drawingml/2006/main"/>
           <a:p xmlns:a="http://schemas.openxmlformats.org/drawingml/2006/main">
             <a:r>
-              <a:t>Timing: 1:10.</a:t>
-            </a:r>
-          </a:p>
-          <a:p xmlns:a="http://schemas.openxmlformats.org/drawingml/2006/main">
-            <a:r>
-              <a:t>Treat this as an important negative result. The paired Nano-minus-No-Mamba interval is −1.48 to −0.23 percentage points on these validation patients.</a:t>
-            </a:r>
-          </a:p>
-          <a:p xmlns:a="http://schemas.openxmlformats.org/drawingml/2006/main">
-            <a:r>
-              <a:t>No-Mamba is larger and structurally different, so the observed ordering does not isolate a causal effect of the gate. Matched capacity and multiple seeds remain necessary.</a:t>
+              <a:t>Timing: 1:10</a:t>
             </a:r>
           </a:p>
           <a:p xmlns:a="http://schemas.openxmlformats.org/drawingml/2006/main">
@@ -1835,32 +1905,52 @@
           </a:p>
           <a:p xmlns:a="http://schemas.openxmlformats.org/drawingml/2006/main">
             <a:r>
+              <a:t>Treat this as an important negative result. The paired Nano-minus-control interval is −1.48 to −0.23 percentage points on these validation patients. The control contains zero Mamba operations and its higher Dice is evidence against saying that adding this gated block raises Dice.</a:t>
+            </a:r>
+          </a:p>
+          <a:p xmlns:a="http://schemas.openxmlformats.org/drawingml/2006/main">
+            <a:r>
+              <a:t/>
+            </a:r>
+          </a:p>
+          <a:p xmlns:a="http://schemas.openxmlformats.org/drawingml/2006/main">
+            <a:r>
+              <a:t>It is not a clean causal ablation: the control has a different convolutional bottleneck and 57.1 percent more parameters. Conversely, Nano uses 36.3 percent fewer parameters while retaining about 99.0 percent of the control's Dice and essentially the same recorded FPS. A parameter-matched, multi-seed ablation is needed to isolate the gate. The 64-channel Mamba ablation is only 0.17 percentage points above Nano and its paired interval crosses zero.</a:t>
+            </a:r>
+          </a:p>
+          <a:p xmlns:a="http://schemas.openxmlformats.org/drawingml/2006/main">
+            <a:r>
+              <a:t/>
+            </a:r>
+          </a:p>
+          <a:p xmlns:a="http://schemas.openxmlformats.org/drawingml/2006/main">
+            <a:r>
               <a:t>[Sources]</a:t>
             </a:r>
           </a:p>
           <a:p xmlns:a="http://schemas.openxmlformats.org/drawingml/2006/main">
             <a:r>
-              <a:t>- Repository: evidence/rigorous_patient_split/summary_metrics.csv</a:t>
-            </a:r>
-          </a:p>
-          <a:p xmlns:a="http://schemas.openxmlformats.org/drawingml/2006/main">
-            <a:r>
-              <a:t>- Repository: evidence/rigorous_patient_split/per_case_NanoMambaUNet.csv</a:t>
-            </a:r>
-          </a:p>
-          <a:p xmlns:a="http://schemas.openxmlformats.org/drawingml/2006/main">
-            <a:r>
-              <a:t>- Repository: evidence/rigorous_patient_split/per_case_Ablation_NoMamba_UNet.csv</a:t>
-            </a:r>
-          </a:p>
-          <a:p xmlns:a="http://schemas.openxmlformats.org/drawingml/2006/main">
-            <a:r>
-              <a:t>- Repository: src/21_rigorous_experiment_pipeline.py</a:t>
-            </a:r>
-          </a:p>
-          <a:p xmlns:a="http://schemas.openxmlformats.org/drawingml/2006/main">
-            <a:r>
-              <a:t>- Repository: SCIENTIFIC_BOUNDARIES.md</a:t>
+              <a:t>- evidence/rigorous_patient_split/summary_metrics.csv</a:t>
+            </a:r>
+          </a:p>
+          <a:p xmlns:a="http://schemas.openxmlformats.org/drawingml/2006/main">
+            <a:r>
+              <a:t>- evidence/rigorous_patient_split/per_case_NanoMambaUNet.csv</a:t>
+            </a:r>
+          </a:p>
+          <a:p xmlns:a="http://schemas.openxmlformats.org/drawingml/2006/main">
+            <a:r>
+              <a:t>- evidence/rigorous_patient_split/per_case_Ablation_NoMamba_UNet.csv</a:t>
+            </a:r>
+          </a:p>
+          <a:p xmlns:a="http://schemas.openxmlformats.org/drawingml/2006/main">
+            <a:r>
+              <a:t>- evidence/rigorous_patient_split/per_case_Ablation_HalfMamba_UNet.csv</a:t>
+            </a:r>
+          </a:p>
+          <a:p xmlns:a="http://schemas.openxmlformats.org/drawingml/2006/main">
+            <a:r>
+              <a:t>- src/21_rigorous_experiment_pipeline.py</a:t>
             </a:r>
           </a:p>
           <a:p xmlns:a="http://schemas.openxmlformats.org/drawingml/2006/main">
@@ -1996,6 +2086,12 @@
           <a:p xmlns:a="http://schemas.openxmlformats.org/drawingml/2006/main">
             <a:r>
               <a:t>- paper_write/Universiti_Malaya_Thesis_Template/sample-chap-methodology.tex</a:t>
+            </a:r>
+          </a:p>
+          <a:p xmlns:a="http://schemas.openxmlformats.org/drawingml/2006/main">
+            <a:r>
+              <a:t>
+[/Sources]</a:t>
             </a:r>
           </a:p>
         </p:txBody>
@@ -2063,7 +2159,7 @@
   </p:cSld>
   <p:clrMap bg1="lt1" tx1="dk1" bg2="lt2" tx2="dk2" accent1="accent1" accent2="accent2" accent3="accent3" accent4="accent4" accent5="accent5" accent6="accent6" hlink="hlink" folHlink="folHlink"/>
   <p:sldLayoutIdLst>
-    <p:sldLayoutId xmlns:r="http://schemas.openxmlformats.org/officeDocument/2006/relationships" id="2147483649" r:id="R756830230bab44d3"/>
+    <p:sldLayoutId xmlns:r="http://schemas.openxmlformats.org/officeDocument/2006/relationships" id="2147483649" r:id="Rfb97d6f6737d4375"/>
   </p:sldLayoutIdLst>
   <p:txStyles>
     <p:titleStyle>
@@ -3802,7 +3898,8 @@
           <p:nvPr/>
         </p:nvPicPr>
         <p:blipFill>
-          <a:blip xmlns:r="http://schemas.openxmlformats.org/officeDocument/2006/relationships" xmlns:a="http://schemas.openxmlformats.org/drawingml/2006/main" r:embed="Rbc44b8b8f68c4402"/>
+          <a:blip xmlns:r="http://schemas.openxmlformats.org/officeDocument/2006/relationships" xmlns:a="http://schemas.openxmlformats.org/drawingml/2006/main" r:embed="R541c7dd707c34b05"/>
+          <a:srcRect xmlns:a="http://schemas.openxmlformats.org/drawingml/2006/main" l="0" t="0" r="0" b="0"/>
           <a:stretch xmlns:a="http://schemas.openxmlformats.org/drawingml/2006/main"/>
         </p:blipFill>
         <p:spPr>
@@ -4388,7 +4485,7 @@
           <p:nvPr/>
         </p:nvPicPr>
         <p:blipFill>
-          <a:blip xmlns:r="http://schemas.openxmlformats.org/officeDocument/2006/relationships" xmlns:a="http://schemas.openxmlformats.org/drawingml/2006/main" r:embed="Rec32042c05224310"/>
+          <a:blip xmlns:r="http://schemas.openxmlformats.org/officeDocument/2006/relationships" xmlns:a="http://schemas.openxmlformats.org/drawingml/2006/main" r:embed="Ra9d9c54185204de7"/>
           <a:stretch xmlns:a="http://schemas.openxmlformats.org/drawingml/2006/main"/>
         </p:blipFill>
         <p:spPr>
@@ -5702,7 +5799,7 @@
                 <a:ea typeface="Arial"/>
                 <a:cs typeface="Arial"/>
               </a:rPr>
-              <a:t>84.78% Dice with 1.456M reported parameters; spatial Mamba-inspired gate</a:t>
+              <a:t>84.78% Dice with 1.456M reported parameters; local Mamba-inspired gate</a:t>
             </a:r>
           </a:p>
         </p:txBody>
@@ -8858,7 +8955,7 @@
                 <a:ea typeface="Arial"/>
                 <a:cs typeface="Arial"/>
               </a:rPr>
-              <a:t>Nano-Mamba mixes 2,048 spatial tokens</a:t>
+              <a:t>Nano-Mamba locally processes 2,048 spatial tokens</a:t>
             </a:r>
           </a:p>
         </p:txBody>
@@ -8995,7 +9092,7 @@
           <p:nvPr/>
         </p:nvPicPr>
         <p:blipFill>
-          <a:blip xmlns:r="http://schemas.openxmlformats.org/officeDocument/2006/relationships" xmlns:a="http://schemas.openxmlformats.org/drawingml/2006/main" r:embed="Rb46ddc65938b4514"/>
+          <a:blip xmlns:r="http://schemas.openxmlformats.org/officeDocument/2006/relationships" xmlns:a="http://schemas.openxmlformats.org/drawingml/2006/main" r:embed="R3e1a56eb0df342e3"/>
           <a:stretch xmlns:a="http://schemas.openxmlformats.org/drawingml/2006/main"/>
         </p:blipFill>
         <p:spPr>
@@ -9179,7 +9276,7 @@
                 <a:ea typeface="Arial"/>
                 <a:cs typeface="Arial"/>
               </a:rPr>
-              <a:t>•  Depthwise 1D mix + gate + projection + residual</a:t>
+              <a:t>•  Kernel-3 depthwise 1D mix + scalar gate; no SSM scan or global interaction</a:t>
             </a:r>
           </a:p>
         </p:txBody>
@@ -9238,7 +9335,7 @@
                 <a:ea typeface="Arial"/>
                 <a:cs typeface="Arial"/>
               </a:rPr>
-              <a:t>Spatial tokens ≠ cardiac time points or full Mamba</a:t>
+              <a:t>Spatial tokens ≠ cardiac time; local gate ≠ full Mamba/SSM</a:t>
             </a:r>
           </a:p>
         </p:txBody>
@@ -10820,7 +10917,7 @@
                           <a:ea typeface="Arial"/>
                           <a:cs typeface="Arial"/>
                         </a:rPr>
-                        <a:t>No-Mamba</a:t>
+                        <a:t>Conv. control (No-Mamba)</a:t>
                       </a:r>
                     </a:p>
                   </a:txBody>
@@ -10984,7 +11081,7 @@
                           <a:ea typeface="Arial"/>
                           <a:cs typeface="Arial"/>
                         </a:rPr>
-                        <a:t>Half-Mamba</a:t>
+                        <a:t>64-ch Mamba (Half)</a:t>
                       </a:r>
                     </a:p>
                   </a:txBody>
@@ -11918,7 +12015,7 @@
           <p:nvPr/>
         </p:nvPicPr>
         <p:blipFill>
-          <a:blip xmlns:r="http://schemas.openxmlformats.org/officeDocument/2006/relationships" xmlns:a="http://schemas.openxmlformats.org/drawingml/2006/main" r:embed="Rcb87a48cec8c4b0a"/>
+          <a:blip xmlns:r="http://schemas.openxmlformats.org/officeDocument/2006/relationships" xmlns:a="http://schemas.openxmlformats.org/drawingml/2006/main" r:embed="Rfc3f97133fb54297"/>
           <a:stretch xmlns:a="http://schemas.openxmlformats.org/drawingml/2006/main"/>
         </p:blipFill>
         <p:spPr>
@@ -12486,7 +12583,7 @@
                 <a:ea typeface="Arial"/>
                 <a:cs typeface="Arial"/>
               </a:rPr>
-              <a:t>The No-Mamba result prevents a causal accuracy claim</a:t>
+              <a:t>The zero-Mamba control prevents a causal accuracy claim</a:t>
             </a:r>
           </a:p>
         </p:txBody>
@@ -12694,7 +12791,7 @@
                 <a:ea typeface="Arial"/>
                 <a:cs typeface="Arial"/>
               </a:rPr>
-              <a:t>No-Mamba mean Dice</a:t>
+              <a:t>Zero-Mamba conv. control</a:t>
             </a:r>
           </a:p>
         </p:txBody>
@@ -13051,7 +13148,7 @@
                 <a:ea typeface="Arial"/>
                 <a:cs typeface="Arial"/>
               </a:rPr>
-              <a:t>Paired Nano − No-Mamba interval: [−1.48, −0.23] pp. No-Mamba is higher on this split, but 57.076% more parameters and structural confounds prevent a causal gate conclusion.</a:t>
+              <a:t>Nano − control CI: [−1.48, −0.23] pp. The zero-Mamba control is higher on this split but has 57.1% more parameters and a different bottleneck; no causal gate effect is isolated.</a:t>
             </a:r>
           </a:p>
         </p:txBody>

</xml_diff>